<commit_message>
refactor: modularize presentation into separate files per topic with shared design system
</commit_message>
<xml_diff>
--- a/presentacion/Presentacion_Telemetria_Optimizacion.pptx
+++ b/presentacion/Presentacion_Telemetria_Optimizacion.pptx
@@ -9403,7 +9403,7 @@
                 </a:solidFill>
                 <a:latin typeface="Segoe UI"/>
               </a:rPr>
-              <a:t>La latencia se redujo de 13.71 ms a 0.12 ms; las lecturas pasaron de 1,301 bloques a 4 bloques (mejora &gt;110x).</a:t>
+              <a:t>La latencia se redujo de 13.71 ms a 0.12 ms; las lecturas pasaron de 1,301 bloques a solo 4 bloques (mejora &gt;110x).</a:t>
             </a:r>
           </a:p>
           <a:p>
@@ -9440,7 +9440,7 @@
                 </a:solidFill>
                 <a:latin typeface="Segoe UI"/>
               </a:rPr>
-              <a:t>El índice compuesto evitó el algoritmo Quicksort en memoria, disminuyendo el tiempo de 28.5 ms a 0.45 ms.</a:t>
+              <a:t>El índice compuesto evitó el Quicksort sobre 400k filas; la latencia se redujo de 391.04 ms a 0.10 ms (mejora &gt;3,900x).</a:t>
             </a:r>
           </a:p>
           <a:p>
@@ -9477,7 +9477,7 @@
                 </a:solidFill>
                 <a:latin typeface="Segoe UI"/>
               </a:rPr>
-              <a:t>La consulta no utilizaba el índice estándar por evaluación en fila; el índice funcional redujo la espera de 42.1 ms a 0.28 ms.</a:t>
+              <a:t>El índice funcional resolvió la invalidación del índice estándar, reduciendo el tiempo de 71.17 ms a 0.72 ms (mejora &gt;95x).</a:t>
             </a:r>
           </a:p>
           <a:p>

</xml_diff>

<commit_message>
feat(slides): document archive_mode postmaster context, %p/%f syntax, and archiver process in backup slides
</commit_message>
<xml_diff>
--- a/presentacion/Presentacion_Telemetria_Optimizacion.pptx
+++ b/presentacion/Presentacion_Telemetria_Optimizacion.pptx
@@ -16,6 +16,9 @@
     <p:sldId id="264" r:id="rId15"/>
     <p:sldId id="265" r:id="rId16"/>
     <p:sldId id="266" r:id="rId17"/>
+    <p:sldId id="267" r:id="rId18"/>
+    <p:sldId id="268" r:id="rId19"/>
+    <p:sldId id="269" r:id="rId20"/>
   </p:sldIdLst>
   <p:sldSz cx="12191695" cy="6858000" type="screen4x3"/>
   <p:notesSz cx="6858000" cy="9144000"/>
@@ -3753,7 +3756,7 @@
               </a:defRPr>
             </a:pPr>
             <a:r>
-              <a:t>METODOLOGÍA EXPERIMENTAL</a:t>
+              <a:t>DIAGNÓSTICO EXPERIMENTAL</a:t>
             </a:r>
           </a:p>
         </p:txBody>
@@ -3789,7 +3792,7 @@
               </a:defRPr>
             </a:pPr>
             <a:r>
-              <a:t>Flujo Integrado de Demostración del Laboratorio</a:t>
+              <a:t>Comportamiento del Almacenamiento: Datos vs Logs Transaccionales</a:t>
             </a:r>
           </a:p>
         </p:txBody>
@@ -3803,7 +3806,7 @@
         <p:spPr>
           <a:xfrm>
             <a:off x="731520" y="1508760"/>
-            <a:ext cx="3291840" cy="4663440"/>
+            <a:ext cx="5029200" cy="4663440"/>
           </a:xfrm>
           <a:prstGeom prst="roundRect">
             <a:avLst/>
@@ -3849,7 +3852,7 @@
         <p:spPr>
           <a:xfrm>
             <a:off x="960120" y="1673352"/>
-            <a:ext cx="2834640" cy="411480"/>
+            <a:ext cx="4572000" cy="411480"/>
           </a:xfrm>
           <a:prstGeom prst="rect">
             <a:avLst/>
@@ -3871,7 +3874,7 @@
               </a:defRPr>
             </a:pPr>
             <a:r>
-              <a:t>Fase 1: Línea Base y Respaldo</a:t>
+              <a:t>Hallazgos de la Simulación</a:t>
             </a:r>
           </a:p>
         </p:txBody>
@@ -3884,8 +3887,8 @@
         </p:nvSpPr>
         <p:spPr>
           <a:xfrm>
-            <a:off x="914400" y="2103120"/>
-            <a:ext cx="2926080" cy="3840480"/>
+            <a:off x="960120" y="2057400"/>
+            <a:ext cx="4572000" cy="3931920"/>
           </a:xfrm>
           <a:prstGeom prst="rect">
             <a:avLst/>
@@ -3922,7 +3925,7 @@
                 </a:solidFill>
                 <a:latin typeface="Segoe UI"/>
               </a:rPr>
-              <a:t>Poblado Inicial: </a:t>
+              <a:t>Condición de Prueba: </a:t>
             </a:r>
             <a:r>
               <a:rPr b="0" sz="1200">
@@ -3931,7 +3934,7 @@
                 </a:solidFill>
                 <a:latin typeface="Segoe UI"/>
               </a:rPr>
-              <a:t>Generación masiva de 600,000 registros sintéticos en PostgreSQL mediante funciones de memoria.</a:t>
+              <a:t>Ejecución continua de 500 sentencias UPDATE consecutivas sobre una única fila de saldo.</a:t>
             </a:r>
           </a:p>
           <a:p>
@@ -3959,7 +3962,7 @@
                 </a:solidFill>
                 <a:latin typeface="Segoe UI"/>
               </a:rPr>
-              <a:t>Respaldo Completo: </a:t>
+              <a:t>Resultado en Tablas: </a:t>
             </a:r>
             <a:r>
               <a:rPr b="0" sz="1200">
@@ -3968,7 +3971,7 @@
                 </a:solidFill>
                 <a:latin typeface="Segoe UI"/>
               </a:rPr>
-              <a:t>Ejecución de snapshot inicial en formato comprimido dentro del almacenamiento aislado.</a:t>
+              <a:t>El tamaño físico de la tabla en disco se mantiene invariable (~12.1 MB).</a:t>
             </a:r>
           </a:p>
           <a:p>
@@ -3996,7 +3999,7 @@
                 </a:solidFill>
                 <a:latin typeface="Segoe UI"/>
               </a:rPr>
-              <a:t>Recuperación PITR: </a:t>
+              <a:t>Resultado en Logs: </a:t>
             </a:r>
             <a:r>
               <a:rPr b="0" sz="1200">
@@ -4005,114 +4008,9 @@
                 </a:solidFill>
                 <a:latin typeface="Segoe UI"/>
               </a:rPr>
-              <a:t>Simulación de incidente destructivo y validación de consistencia transaccional tras restaurar.</a:t>
-            </a:r>
-          </a:p>
-        </p:txBody>
-      </p:sp>
-      <p:sp>
-        <p:nvSpPr>
-          <p:cNvPr id="8" name="Rounded Rectangle 7"/>
-          <p:cNvSpPr/>
-          <p:nvPr/>
-        </p:nvSpPr>
-        <p:spPr>
-          <a:xfrm>
-            <a:off x="4389120" y="1508760"/>
-            <a:ext cx="3291840" cy="4663440"/>
-          </a:xfrm>
-          <a:prstGeom prst="roundRect">
-            <a:avLst/>
-          </a:prstGeom>
-          <a:solidFill>
-            <a:srgbClr val="1E293B"/>
-          </a:solidFill>
-          <a:ln w="12700">
-            <a:solidFill>
-              <a:srgbClr val="334155"/>
-            </a:solidFill>
-          </a:ln>
-          <a:effectLst/>
-        </p:spPr>
-        <p:style>
-          <a:lnRef idx="1">
-            <a:schemeClr val="accent1"/>
-          </a:lnRef>
-          <a:fillRef idx="3">
-            <a:schemeClr val="accent1"/>
-          </a:fillRef>
-          <a:effectRef idx="2">
-            <a:schemeClr val="accent1"/>
-          </a:effectRef>
-          <a:fontRef idx="minor">
-            <a:schemeClr val="lt1"/>
-          </a:fontRef>
-        </p:style>
-        <p:txBody>
-          <a:bodyPr rtlCol="0" anchor="ctr"/>
-          <a:lstStyle/>
-          <a:p>
-            <a:pPr algn="ctr"/>
-          </a:p>
-        </p:txBody>
-      </p:sp>
-      <p:sp>
-        <p:nvSpPr>
-          <p:cNvPr id="9" name="TextBox 8"/>
-          <p:cNvSpPr txBox="1"/>
-          <p:nvPr/>
-        </p:nvSpPr>
-        <p:spPr>
-          <a:xfrm>
-            <a:off x="4617720" y="1673352"/>
-            <a:ext cx="2834640" cy="411480"/>
-          </a:xfrm>
-          <a:prstGeom prst="rect">
-            <a:avLst/>
-          </a:prstGeom>
-          <a:noFill/>
-        </p:spPr>
-        <p:txBody>
-          <a:bodyPr wrap="square">
-            <a:spAutoFit/>
-          </a:bodyPr>
-          <a:lstStyle/>
-          <a:p>
-            <a:pPr>
-              <a:defRPr sz="1400" b="1">
-                <a:solidFill>
-                  <a:srgbClr val="60A5FA"/>
-                </a:solidFill>
-                <a:latin typeface="Segoe UI"/>
-              </a:defRPr>
-            </a:pPr>
-            <a:r>
-              <a:t>Fase 2: Telemetría y Carga</a:t>
-            </a:r>
-          </a:p>
-        </p:txBody>
-      </p:sp>
-      <p:sp>
-        <p:nvSpPr>
-          <p:cNvPr id="10" name="TextBox 9"/>
-          <p:cNvSpPr txBox="1"/>
-          <p:nvPr/>
-        </p:nvSpPr>
-        <p:spPr>
-          <a:xfrm>
-            <a:off x="4572000" y="2103120"/>
-            <a:ext cx="2926080" cy="3840480"/>
-          </a:xfrm>
-          <a:prstGeom prst="rect">
-            <a:avLst/>
-          </a:prstGeom>
-          <a:noFill/>
-        </p:spPr>
-        <p:txBody>
-          <a:bodyPr wrap="square">
-            <a:spAutoFit/>
-          </a:bodyPr>
-          <a:lstStyle/>
+              <a:t>Se emitieron 500 registros WAL de 16 MB y cientos de entradas de auditoría hacia Loki.</a:t>
+            </a:r>
+          </a:p>
           <a:p>
             <a:pPr>
               <a:spcBef>
@@ -4138,7 +4036,7 @@
                 </a:solidFill>
                 <a:latin typeface="Segoe UI"/>
               </a:rPr>
-              <a:t>Inyección Concurrente: </a:t>
+              <a:t>Conclusión Crítica: </a:t>
             </a:r>
             <a:r>
               <a:rPr b="0" sz="1200">
@@ -4147,7 +4045,7 @@
                 </a:solidFill>
                 <a:latin typeface="Segoe UI"/>
               </a:rPr>
-              <a:t>Simulación de tráfico transaccional continuo (lecturas, transferencias y rollbacks).</a:t>
+              <a:t>El almacenamiento de logs crece en función de la actividad operativa, no del número de filas.</a:t>
             </a:r>
           </a:p>
           <a:p>
@@ -4175,7 +4073,7 @@
                 </a:solidFill>
                 <a:latin typeface="Segoe UI"/>
               </a:rPr>
-              <a:t>Transmisión en Streaming: </a:t>
+              <a:t>Principio Rector: </a:t>
             </a:r>
             <a:r>
               <a:rPr b="0" sz="1200">
@@ -4184,264 +4082,35 @@
                 </a:solidFill>
                 <a:latin typeface="Segoe UI"/>
               </a:rPr>
-              <a:t>Captura en tiempo real de eventos con Promtail hacia el repositorio de Loki.</a:t>
-            </a:r>
-          </a:p>
-          <a:p>
-            <a:pPr>
-              <a:spcBef>
-                <a:spcPts val="200"/>
-              </a:spcBef>
-              <a:spcAft>
-                <a:spcPts val="700"/>
-              </a:spcAft>
-            </a:pPr>
-            <a:r>
-              <a:rPr b="0" sz="1200">
-                <a:solidFill>
-                  <a:srgbClr val="60A5FA"/>
-                </a:solidFill>
-                <a:latin typeface="Segoe UI"/>
-              </a:rPr>
-              <a:t>•  </a:t>
-            </a:r>
-            <a:r>
-              <a:rPr b="1" sz="1200">
-                <a:solidFill>
-                  <a:srgbClr val="E2E8F0"/>
-                </a:solidFill>
-                <a:latin typeface="Segoe UI"/>
-              </a:rPr>
-              <a:t>Monitoreo en Vivo: </a:t>
-            </a:r>
-            <a:r>
-              <a:rPr b="0" sz="1200">
-                <a:solidFill>
-                  <a:srgbClr val="94A3B8"/>
-                </a:solidFill>
-                <a:latin typeface="Segoe UI"/>
-              </a:rPr>
-              <a:t>Inspección de curvas de QPS, patrones de escritura y registro de errores en Grafana.</a:t>
-            </a:r>
-          </a:p>
-        </p:txBody>
-      </p:sp>
-      <p:sp>
-        <p:nvSpPr>
-          <p:cNvPr id="11" name="Rounded Rectangle 10"/>
-          <p:cNvSpPr/>
-          <p:nvPr/>
-        </p:nvSpPr>
-        <p:spPr>
-          <a:xfrm>
-            <a:off x="8046720" y="1508760"/>
-            <a:ext cx="3383280" cy="4663440"/>
-          </a:xfrm>
-          <a:prstGeom prst="roundRect">
-            <a:avLst/>
-          </a:prstGeom>
-          <a:solidFill>
-            <a:srgbClr val="1E293B"/>
-          </a:solidFill>
-          <a:ln w="12700">
-            <a:solidFill>
-              <a:srgbClr val="334155"/>
-            </a:solidFill>
-          </a:ln>
-          <a:effectLst/>
-        </p:spPr>
-        <p:style>
-          <a:lnRef idx="1">
-            <a:schemeClr val="accent1"/>
-          </a:lnRef>
-          <a:fillRef idx="3">
-            <a:schemeClr val="accent1"/>
-          </a:fillRef>
-          <a:effectRef idx="2">
-            <a:schemeClr val="accent1"/>
-          </a:effectRef>
-          <a:fontRef idx="minor">
-            <a:schemeClr val="lt1"/>
-          </a:fontRef>
-        </p:style>
-        <p:txBody>
-          <a:bodyPr rtlCol="0" anchor="ctr"/>
-          <a:lstStyle/>
-          <a:p>
-            <a:pPr algn="ctr"/>
-          </a:p>
-        </p:txBody>
-      </p:sp>
-      <p:sp>
-        <p:nvSpPr>
-          <p:cNvPr id="12" name="TextBox 11"/>
-          <p:cNvSpPr txBox="1"/>
-          <p:nvPr/>
-        </p:nvSpPr>
-        <p:spPr>
-          <a:xfrm>
-            <a:off x="8275320" y="1673352"/>
-            <a:ext cx="2926080" cy="411480"/>
+              <a:t>La separación de discos e instancias de log es indispensable para evitar incidentes por disco lleno.</a:t>
+            </a:r>
+          </a:p>
+        </p:txBody>
+      </p:sp>
+      <p:pic>
+        <p:nvPicPr>
+          <p:cNvPr id="8" name="Picture 7" descr="grafico_paradoja_logs.png"/>
+          <p:cNvPicPr>
+            <a:picLocks noChangeAspect="1"/>
+          </p:cNvPicPr>
+          <p:nvPr/>
+        </p:nvPicPr>
+        <p:blipFill>
+          <a:blip r:embed="rId2"/>
+          <a:stretch>
+            <a:fillRect/>
+          </a:stretch>
+        </p:blipFill>
+        <p:spPr>
+          <a:xfrm>
+            <a:off x="6035040" y="1645920"/>
+            <a:ext cx="5394960" cy="3371850"/>
           </a:xfrm>
           <a:prstGeom prst="rect">
             <a:avLst/>
           </a:prstGeom>
-          <a:noFill/>
-        </p:spPr>
-        <p:txBody>
-          <a:bodyPr wrap="square">
-            <a:spAutoFit/>
-          </a:bodyPr>
-          <a:lstStyle/>
-          <a:p>
-            <a:pPr>
-              <a:defRPr sz="1400" b="1">
-                <a:solidFill>
-                  <a:srgbClr val="60A5FA"/>
-                </a:solidFill>
-                <a:latin typeface="Segoe UI"/>
-              </a:defRPr>
-            </a:pPr>
-            <a:r>
-              <a:t>Fase 3: Diagnóstico y Tuning</a:t>
-            </a:r>
-          </a:p>
-        </p:txBody>
-      </p:sp>
-      <p:sp>
-        <p:nvSpPr>
-          <p:cNvPr id="13" name="TextBox 12"/>
-          <p:cNvSpPr txBox="1"/>
-          <p:nvPr/>
-        </p:nvSpPr>
-        <p:spPr>
-          <a:xfrm>
-            <a:off x="8229600" y="2103120"/>
-            <a:ext cx="3017520" cy="3840480"/>
-          </a:xfrm>
-          <a:prstGeom prst="rect">
-            <a:avLst/>
-          </a:prstGeom>
-          <a:noFill/>
-        </p:spPr>
-        <p:txBody>
-          <a:bodyPr wrap="square">
-            <a:spAutoFit/>
-          </a:bodyPr>
-          <a:lstStyle/>
-          <a:p>
-            <a:pPr>
-              <a:spcBef>
-                <a:spcPts val="200"/>
-              </a:spcBef>
-              <a:spcAft>
-                <a:spcPts val="700"/>
-              </a:spcAft>
-            </a:pPr>
-            <a:r>
-              <a:rPr b="0" sz="1200">
-                <a:solidFill>
-                  <a:srgbClr val="60A5FA"/>
-                </a:solidFill>
-                <a:latin typeface="Segoe UI"/>
-              </a:rPr>
-              <a:t>•  </a:t>
-            </a:r>
-            <a:r>
-              <a:rPr b="1" sz="1200">
-                <a:solidFill>
-                  <a:srgbClr val="E2E8F0"/>
-                </a:solidFill>
-                <a:latin typeface="Segoe UI"/>
-              </a:rPr>
-              <a:t>Detección de Cuellos: </a:t>
-            </a:r>
-            <a:r>
-              <a:rPr b="0" sz="1200">
-                <a:solidFill>
-                  <a:srgbClr val="94A3B8"/>
-                </a:solidFill>
-                <a:latin typeface="Segoe UI"/>
-              </a:rPr>
-              <a:t>Identificación de sentencias costosas reportadas por telemetría y pg_stat_statements.</a:t>
-            </a:r>
-          </a:p>
-          <a:p>
-            <a:pPr>
-              <a:spcBef>
-                <a:spcPts val="200"/>
-              </a:spcBef>
-              <a:spcAft>
-                <a:spcPts val="700"/>
-              </a:spcAft>
-            </a:pPr>
-            <a:r>
-              <a:rPr b="0" sz="1200">
-                <a:solidFill>
-                  <a:srgbClr val="60A5FA"/>
-                </a:solidFill>
-                <a:latin typeface="Segoe UI"/>
-              </a:rPr>
-              <a:t>•  </a:t>
-            </a:r>
-            <a:r>
-              <a:rPr b="1" sz="1200">
-                <a:solidFill>
-                  <a:srgbClr val="E2E8F0"/>
-                </a:solidFill>
-                <a:latin typeface="Segoe UI"/>
-              </a:rPr>
-              <a:t>Análisis de Planes: </a:t>
-            </a:r>
-            <a:r>
-              <a:rPr b="0" sz="1200">
-                <a:solidFill>
-                  <a:srgbClr val="94A3B8"/>
-                </a:solidFill>
-                <a:latin typeface="Segoe UI"/>
-              </a:rPr>
-              <a:t>Evaluación de costos y lecturas de bloques de disco mediante EXPLAIN ANALYZE.</a:t>
-            </a:r>
-          </a:p>
-          <a:p>
-            <a:pPr>
-              <a:spcBef>
-                <a:spcPts val="200"/>
-              </a:spcBef>
-              <a:spcAft>
-                <a:spcPts val="700"/>
-              </a:spcAft>
-            </a:pPr>
-            <a:r>
-              <a:rPr b="0" sz="1200">
-                <a:solidFill>
-                  <a:srgbClr val="60A5FA"/>
-                </a:solidFill>
-                <a:latin typeface="Segoe UI"/>
-              </a:rPr>
-              <a:t>•  </a:t>
-            </a:r>
-            <a:r>
-              <a:rPr b="1" sz="1200">
-                <a:solidFill>
-                  <a:srgbClr val="E2E8F0"/>
-                </a:solidFill>
-                <a:latin typeface="Segoe UI"/>
-              </a:rPr>
-              <a:t>Verificación de Índices: </a:t>
-            </a:r>
-            <a:r>
-              <a:rPr b="0" sz="1200">
-                <a:solidFill>
-                  <a:srgbClr val="94A3B8"/>
-                </a:solidFill>
-                <a:latin typeface="Segoe UI"/>
-              </a:rPr>
-              <a:t>Constatación inmediata de la caída drástica en la latencia tras crear las estructuras.</a:t>
-            </a:r>
-          </a:p>
-        </p:txBody>
-      </p:sp>
+        </p:spPr>
+      </p:pic>
     </p:spTree>
   </p:cSld>
   <p:clrMapOvr>
@@ -4534,6 +4203,1836 @@
               </a:defRPr>
             </a:pPr>
             <a:r>
+              <a:t>AFINAMIENTO DE RENDIMIENTO</a:t>
+            </a:r>
+          </a:p>
+        </p:txBody>
+      </p:sp>
+      <p:sp>
+        <p:nvSpPr>
+          <p:cNvPr id="4" name="TextBox 3"/>
+          <p:cNvSpPr txBox="1"/>
+          <p:nvPr/>
+        </p:nvSpPr>
+        <p:spPr>
+          <a:xfrm>
+            <a:off x="731520" y="658368"/>
+            <a:ext cx="10698480" cy="640080"/>
+          </a:xfrm>
+          <a:prstGeom prst="rect">
+            <a:avLst/>
+          </a:prstGeom>
+          <a:noFill/>
+        </p:spPr>
+        <p:txBody>
+          <a:bodyPr wrap="square">
+            <a:spAutoFit/>
+          </a:bodyPr>
+          <a:lstStyle/>
+          <a:p>
+            <a:pPr>
+              <a:defRPr sz="2200" b="1">
+                <a:solidFill>
+                  <a:srgbClr val="F8FAFC"/>
+                </a:solidFill>
+                <a:latin typeface="Segoe UI"/>
+              </a:defRPr>
+            </a:pPr>
+            <a:r>
+              <a:t>Análisis de Planes de Ejecución y Métricas de E/S</a:t>
+            </a:r>
+          </a:p>
+        </p:txBody>
+      </p:sp>
+      <p:sp>
+        <p:nvSpPr>
+          <p:cNvPr id="5" name="Rounded Rectangle 4"/>
+          <p:cNvSpPr/>
+          <p:nvPr/>
+        </p:nvSpPr>
+        <p:spPr>
+          <a:xfrm>
+            <a:off x="731520" y="1508760"/>
+            <a:ext cx="5212080" cy="4663440"/>
+          </a:xfrm>
+          <a:prstGeom prst="roundRect">
+            <a:avLst/>
+          </a:prstGeom>
+          <a:solidFill>
+            <a:srgbClr val="1E293B"/>
+          </a:solidFill>
+          <a:ln w="12700">
+            <a:solidFill>
+              <a:srgbClr val="334155"/>
+            </a:solidFill>
+          </a:ln>
+          <a:effectLst/>
+        </p:spPr>
+        <p:style>
+          <a:lnRef idx="1">
+            <a:schemeClr val="accent1"/>
+          </a:lnRef>
+          <a:fillRef idx="3">
+            <a:schemeClr val="accent1"/>
+          </a:fillRef>
+          <a:effectRef idx="2">
+            <a:schemeClr val="accent1"/>
+          </a:effectRef>
+          <a:fontRef idx="minor">
+            <a:schemeClr val="lt1"/>
+          </a:fontRef>
+        </p:style>
+        <p:txBody>
+          <a:bodyPr rtlCol="0" anchor="ctr"/>
+          <a:lstStyle/>
+          <a:p>
+            <a:pPr algn="ctr"/>
+          </a:p>
+        </p:txBody>
+      </p:sp>
+      <p:sp>
+        <p:nvSpPr>
+          <p:cNvPr id="6" name="TextBox 5"/>
+          <p:cNvSpPr txBox="1"/>
+          <p:nvPr/>
+        </p:nvSpPr>
+        <p:spPr>
+          <a:xfrm>
+            <a:off x="960120" y="1673352"/>
+            <a:ext cx="4754880" cy="411480"/>
+          </a:xfrm>
+          <a:prstGeom prst="rect">
+            <a:avLst/>
+          </a:prstGeom>
+          <a:noFill/>
+        </p:spPr>
+        <p:txBody>
+          <a:bodyPr wrap="square">
+            <a:spAutoFit/>
+          </a:bodyPr>
+          <a:lstStyle/>
+          <a:p>
+            <a:pPr>
+              <a:defRPr sz="1400" b="1">
+                <a:solidFill>
+                  <a:srgbClr val="60A5FA"/>
+                </a:solidFill>
+                <a:latin typeface="Segoe UI"/>
+              </a:defRPr>
+            </a:pPr>
+            <a:r>
+              <a:t>Fundamentos de EXPLAIN ANALYZE</a:t>
+            </a:r>
+          </a:p>
+        </p:txBody>
+      </p:sp>
+      <p:sp>
+        <p:nvSpPr>
+          <p:cNvPr id="7" name="TextBox 6"/>
+          <p:cNvSpPr txBox="1"/>
+          <p:nvPr/>
+        </p:nvSpPr>
+        <p:spPr>
+          <a:xfrm>
+            <a:off x="960120" y="2057400"/>
+            <a:ext cx="4754880" cy="3931920"/>
+          </a:xfrm>
+          <a:prstGeom prst="rect">
+            <a:avLst/>
+          </a:prstGeom>
+          <a:noFill/>
+        </p:spPr>
+        <p:txBody>
+          <a:bodyPr wrap="square">
+            <a:spAutoFit/>
+          </a:bodyPr>
+          <a:lstStyle/>
+          <a:p>
+            <a:pPr>
+              <a:spcBef>
+                <a:spcPts val="200"/>
+              </a:spcBef>
+              <a:spcAft>
+                <a:spcPts val="700"/>
+              </a:spcAft>
+            </a:pPr>
+            <a:r>
+              <a:rPr b="0" sz="1200">
+                <a:solidFill>
+                  <a:srgbClr val="60A5FA"/>
+                </a:solidFill>
+                <a:latin typeface="Segoe UI"/>
+              </a:rPr>
+              <a:t>•  </a:t>
+            </a:r>
+            <a:r>
+              <a:rPr b="1" sz="1200">
+                <a:solidFill>
+                  <a:srgbClr val="E2E8F0"/>
+                </a:solidFill>
+                <a:latin typeface="Segoe UI"/>
+              </a:rPr>
+              <a:t>Tiempo de Ejecución: </a:t>
+            </a:r>
+            <a:r>
+              <a:rPr b="0" sz="1200">
+                <a:solidFill>
+                  <a:srgbClr val="94A3B8"/>
+                </a:solidFill>
+                <a:latin typeface="Segoe UI"/>
+              </a:rPr>
+              <a:t>Medición cronométrica real del procesamiento interno en el motor de la base de datos.</a:t>
+            </a:r>
+          </a:p>
+          <a:p>
+            <a:pPr>
+              <a:spcBef>
+                <a:spcPts val="200"/>
+              </a:spcBef>
+              <a:spcAft>
+                <a:spcPts val="700"/>
+              </a:spcAft>
+            </a:pPr>
+            <a:r>
+              <a:rPr b="0" sz="1200">
+                <a:solidFill>
+                  <a:srgbClr val="60A5FA"/>
+                </a:solidFill>
+                <a:latin typeface="Segoe UI"/>
+              </a:rPr>
+              <a:t>•  </a:t>
+            </a:r>
+            <a:r>
+              <a:rPr b="1" sz="1200">
+                <a:solidFill>
+                  <a:srgbClr val="E2E8F0"/>
+                </a:solidFill>
+                <a:latin typeface="Segoe UI"/>
+              </a:rPr>
+              <a:t>Buffers (Hit vs Read): </a:t>
+            </a:r>
+            <a:r>
+              <a:rPr b="0" sz="1200">
+                <a:solidFill>
+                  <a:srgbClr val="94A3B8"/>
+                </a:solidFill>
+                <a:latin typeface="Segoe UI"/>
+              </a:rPr>
+              <a:t>Hit indica lectura directa en memoria RAM; Read representa lectura física de disco (cuello de botella de E/S).</a:t>
+            </a:r>
+          </a:p>
+          <a:p>
+            <a:pPr>
+              <a:spcBef>
+                <a:spcPts val="200"/>
+              </a:spcBef>
+              <a:spcAft>
+                <a:spcPts val="700"/>
+              </a:spcAft>
+            </a:pPr>
+            <a:r>
+              <a:rPr b="0" sz="1200">
+                <a:solidFill>
+                  <a:srgbClr val="60A5FA"/>
+                </a:solidFill>
+                <a:latin typeface="Segoe UI"/>
+              </a:rPr>
+              <a:t>•  </a:t>
+            </a:r>
+            <a:r>
+              <a:rPr b="1" sz="1200">
+                <a:solidFill>
+                  <a:srgbClr val="E2E8F0"/>
+                </a:solidFill>
+                <a:latin typeface="Segoe UI"/>
+              </a:rPr>
+              <a:t>Sequential Scan (Seq Scan): </a:t>
+            </a:r>
+            <a:r>
+              <a:rPr b="0" sz="1200">
+                <a:solidFill>
+                  <a:srgbClr val="94A3B8"/>
+                </a:solidFill>
+                <a:latin typeface="Segoe UI"/>
+              </a:rPr>
+              <a:t>Recorrido exhaustivo de cada página de la tabla. Ineficiente para búsquedas selectivas sobre grandes volúmenes.</a:t>
+            </a:r>
+          </a:p>
+          <a:p>
+            <a:pPr>
+              <a:spcBef>
+                <a:spcPts val="200"/>
+              </a:spcBef>
+              <a:spcAft>
+                <a:spcPts val="700"/>
+              </a:spcAft>
+            </a:pPr>
+            <a:r>
+              <a:rPr b="0" sz="1200">
+                <a:solidFill>
+                  <a:srgbClr val="60A5FA"/>
+                </a:solidFill>
+                <a:latin typeface="Segoe UI"/>
+              </a:rPr>
+              <a:t>•  </a:t>
+            </a:r>
+            <a:r>
+              <a:rPr b="1" sz="1200">
+                <a:solidFill>
+                  <a:srgbClr val="E2E8F0"/>
+                </a:solidFill>
+                <a:latin typeface="Segoe UI"/>
+              </a:rPr>
+              <a:t>Index Scan: </a:t>
+            </a:r>
+            <a:r>
+              <a:rPr b="0" sz="1200">
+                <a:solidFill>
+                  <a:srgbClr val="94A3B8"/>
+                </a:solidFill>
+                <a:latin typeface="Segoe UI"/>
+              </a:rPr>
+              <a:t>Acceso selectivo mediante estructuras balanceadas B-Tree con complejidad logarítmica O(log N).</a:t>
+            </a:r>
+          </a:p>
+        </p:txBody>
+      </p:sp>
+      <p:sp>
+        <p:nvSpPr>
+          <p:cNvPr id="8" name="Rounded Rectangle 7"/>
+          <p:cNvSpPr/>
+          <p:nvPr/>
+        </p:nvSpPr>
+        <p:spPr>
+          <a:xfrm>
+            <a:off x="6217920" y="1508760"/>
+            <a:ext cx="5212080" cy="4663440"/>
+          </a:xfrm>
+          <a:prstGeom prst="roundRect">
+            <a:avLst/>
+          </a:prstGeom>
+          <a:solidFill>
+            <a:srgbClr val="1E293B"/>
+          </a:solidFill>
+          <a:ln w="12700">
+            <a:solidFill>
+              <a:srgbClr val="334155"/>
+            </a:solidFill>
+          </a:ln>
+          <a:effectLst/>
+        </p:spPr>
+        <p:style>
+          <a:lnRef idx="1">
+            <a:schemeClr val="accent1"/>
+          </a:lnRef>
+          <a:fillRef idx="3">
+            <a:schemeClr val="accent1"/>
+          </a:fillRef>
+          <a:effectRef idx="2">
+            <a:schemeClr val="accent1"/>
+          </a:effectRef>
+          <a:fontRef idx="minor">
+            <a:schemeClr val="lt1"/>
+          </a:fontRef>
+        </p:style>
+        <p:txBody>
+          <a:bodyPr rtlCol="0" anchor="ctr"/>
+          <a:lstStyle/>
+          <a:p>
+            <a:pPr algn="ctr"/>
+          </a:p>
+        </p:txBody>
+      </p:sp>
+      <p:sp>
+        <p:nvSpPr>
+          <p:cNvPr id="9" name="TextBox 8"/>
+          <p:cNvSpPr txBox="1"/>
+          <p:nvPr/>
+        </p:nvSpPr>
+        <p:spPr>
+          <a:xfrm>
+            <a:off x="6446520" y="1673352"/>
+            <a:ext cx="4754880" cy="411480"/>
+          </a:xfrm>
+          <a:prstGeom prst="rect">
+            <a:avLst/>
+          </a:prstGeom>
+          <a:noFill/>
+        </p:spPr>
+        <p:txBody>
+          <a:bodyPr wrap="square">
+            <a:spAutoFit/>
+          </a:bodyPr>
+          <a:lstStyle/>
+          <a:p>
+            <a:pPr>
+              <a:defRPr sz="1400" b="1">
+                <a:solidFill>
+                  <a:srgbClr val="60A5FA"/>
+                </a:solidFill>
+                <a:latin typeface="Segoe UI"/>
+              </a:defRPr>
+            </a:pPr>
+            <a:r>
+              <a:t>Técnicas de Indexación Aplicadas</a:t>
+            </a:r>
+          </a:p>
+        </p:txBody>
+      </p:sp>
+      <p:sp>
+        <p:nvSpPr>
+          <p:cNvPr id="10" name="TextBox 9"/>
+          <p:cNvSpPr txBox="1"/>
+          <p:nvPr/>
+        </p:nvSpPr>
+        <p:spPr>
+          <a:xfrm>
+            <a:off x="6446520" y="2057400"/>
+            <a:ext cx="4754880" cy="3931920"/>
+          </a:xfrm>
+          <a:prstGeom prst="rect">
+            <a:avLst/>
+          </a:prstGeom>
+          <a:noFill/>
+        </p:spPr>
+        <p:txBody>
+          <a:bodyPr wrap="square">
+            <a:spAutoFit/>
+          </a:bodyPr>
+          <a:lstStyle/>
+          <a:p>
+            <a:pPr>
+              <a:spcBef>
+                <a:spcPts val="200"/>
+              </a:spcBef>
+              <a:spcAft>
+                <a:spcPts val="700"/>
+              </a:spcAft>
+            </a:pPr>
+            <a:r>
+              <a:rPr b="0" sz="1200">
+                <a:solidFill>
+                  <a:srgbClr val="60A5FA"/>
+                </a:solidFill>
+                <a:latin typeface="Segoe UI"/>
+              </a:rPr>
+              <a:t>•  </a:t>
+            </a:r>
+            <a:r>
+              <a:rPr b="1" sz="1200">
+                <a:solidFill>
+                  <a:srgbClr val="E2E8F0"/>
+                </a:solidFill>
+                <a:latin typeface="Segoe UI"/>
+              </a:rPr>
+              <a:t>Índice B-Tree Único: </a:t>
+            </a:r>
+            <a:r>
+              <a:rPr b="0" sz="1200">
+                <a:solidFill>
+                  <a:srgbClr val="94A3B8"/>
+                </a:solidFill>
+                <a:latin typeface="Segoe UI"/>
+              </a:rPr>
+              <a:t>Búsqueda directa por documento de identidad; evita el escaneo de 100,000 filas.</a:t>
+            </a:r>
+          </a:p>
+          <a:p>
+            <a:pPr>
+              <a:spcBef>
+                <a:spcPts val="200"/>
+              </a:spcBef>
+              <a:spcAft>
+                <a:spcPts val="700"/>
+              </a:spcAft>
+            </a:pPr>
+            <a:r>
+              <a:rPr b="0" sz="1200">
+                <a:solidFill>
+                  <a:srgbClr val="60A5FA"/>
+                </a:solidFill>
+                <a:latin typeface="Segoe UI"/>
+              </a:rPr>
+              <a:t>•  </a:t>
+            </a:r>
+            <a:r>
+              <a:rPr b="1" sz="1200">
+                <a:solidFill>
+                  <a:srgbClr val="E2E8F0"/>
+                </a:solidFill>
+                <a:latin typeface="Segoe UI"/>
+              </a:rPr>
+              <a:t>Índice Compuesto Multicolumna: </a:t>
+            </a:r>
+            <a:r>
+              <a:rPr b="0" sz="1200">
+                <a:solidFill>
+                  <a:srgbClr val="94A3B8"/>
+                </a:solidFill>
+                <a:latin typeface="Segoe UI"/>
+              </a:rPr>
+              <a:t>Indexación simultánea de cuenta y fecha; elimina la necesidad de ordenamiento en memoria (Sort).</a:t>
+            </a:r>
+          </a:p>
+          <a:p>
+            <a:pPr>
+              <a:spcBef>
+                <a:spcPts val="200"/>
+              </a:spcBef>
+              <a:spcAft>
+                <a:spcPts val="700"/>
+              </a:spcAft>
+            </a:pPr>
+            <a:r>
+              <a:rPr b="0" sz="1200">
+                <a:solidFill>
+                  <a:srgbClr val="60A5FA"/>
+                </a:solidFill>
+                <a:latin typeface="Segoe UI"/>
+              </a:rPr>
+              <a:t>•  </a:t>
+            </a:r>
+            <a:r>
+              <a:rPr b="1" sz="1200">
+                <a:solidFill>
+                  <a:srgbClr val="E2E8F0"/>
+                </a:solidFill>
+                <a:latin typeface="Segoe UI"/>
+              </a:rPr>
+              <a:t>Índice Basado en Expresiones: </a:t>
+            </a:r>
+            <a:r>
+              <a:rPr b="0" sz="1200">
+                <a:solidFill>
+                  <a:srgbClr val="94A3B8"/>
+                </a:solidFill>
+                <a:latin typeface="Segoe UI"/>
+              </a:rPr>
+              <a:t>Creación sobre funciones de transformación (ej. LOWER); neutraliza anti-patrones en el WHERE.</a:t>
+            </a:r>
+          </a:p>
+          <a:p>
+            <a:pPr>
+              <a:spcBef>
+                <a:spcPts val="200"/>
+              </a:spcBef>
+              <a:spcAft>
+                <a:spcPts val="700"/>
+              </a:spcAft>
+            </a:pPr>
+            <a:r>
+              <a:rPr b="0" sz="1200">
+                <a:solidFill>
+                  <a:srgbClr val="60A5FA"/>
+                </a:solidFill>
+                <a:latin typeface="Segoe UI"/>
+              </a:rPr>
+              <a:t>•  </a:t>
+            </a:r>
+            <a:r>
+              <a:rPr b="1" sz="1200">
+                <a:solidFill>
+                  <a:srgbClr val="E2E8F0"/>
+                </a:solidFill>
+                <a:latin typeface="Segoe UI"/>
+              </a:rPr>
+              <a:t>Auditoría con pg_stat_statements: </a:t>
+            </a:r>
+            <a:r>
+              <a:rPr b="0" sz="1200">
+                <a:solidFill>
+                  <a:srgbClr val="94A3B8"/>
+                </a:solidFill>
+                <a:latin typeface="Segoe UI"/>
+              </a:rPr>
+              <a:t>Inspección acumulada para identificar las 10 consultas más lentas del sistema global.</a:t>
+            </a:r>
+          </a:p>
+        </p:txBody>
+      </p:sp>
+    </p:spTree>
+  </p:cSld>
+  <p:clrMapOvr>
+    <a:masterClrMapping/>
+  </p:clrMapOvr>
+</p:sld>
+</file>
+
+<file path=ppt/slides/slide12.xml><?xml version="1.0" encoding="utf-8"?>
+<p:sld xmlns:a="http://schemas.openxmlformats.org/drawingml/2006/main" xmlns:p="http://schemas.openxmlformats.org/presentationml/2006/main" xmlns:r="http://schemas.openxmlformats.org/officeDocument/2006/relationships">
+  <p:cSld>
+    <p:spTree>
+      <p:nvGrpSpPr>
+        <p:cNvPr id="1" name=""/>
+        <p:cNvGrpSpPr/>
+        <p:nvPr/>
+      </p:nvGrpSpPr>
+      <p:grpSpPr/>
+      <p:sp>
+        <p:nvSpPr>
+          <p:cNvPr id="2" name="Rectangle 1"/>
+          <p:cNvSpPr/>
+          <p:nvPr/>
+        </p:nvSpPr>
+        <p:spPr>
+          <a:xfrm>
+            <a:off x="0" y="0"/>
+            <a:ext cx="12191695" cy="6858000"/>
+          </a:xfrm>
+          <a:prstGeom prst="rect">
+            <a:avLst/>
+          </a:prstGeom>
+          <a:solidFill>
+            <a:srgbClr val="0F172A"/>
+          </a:solidFill>
+          <a:ln>
+            <a:noFill/>
+          </a:ln>
+        </p:spPr>
+        <p:style>
+          <a:lnRef idx="1">
+            <a:schemeClr val="accent1"/>
+          </a:lnRef>
+          <a:fillRef idx="3">
+            <a:schemeClr val="accent1"/>
+          </a:fillRef>
+          <a:effectRef idx="2">
+            <a:schemeClr val="accent1"/>
+          </a:effectRef>
+          <a:fontRef idx="minor">
+            <a:schemeClr val="lt1"/>
+          </a:fontRef>
+        </p:style>
+        <p:txBody>
+          <a:bodyPr rtlCol="0" anchor="ctr"/>
+          <a:lstStyle/>
+          <a:p>
+            <a:pPr algn="ctr"/>
+          </a:p>
+        </p:txBody>
+      </p:sp>
+      <p:sp>
+        <p:nvSpPr>
+          <p:cNvPr id="3" name="TextBox 2"/>
+          <p:cNvSpPr txBox="1"/>
+          <p:nvPr/>
+        </p:nvSpPr>
+        <p:spPr>
+          <a:xfrm>
+            <a:off x="731520" y="384048"/>
+            <a:ext cx="10698480" cy="274320"/>
+          </a:xfrm>
+          <a:prstGeom prst="rect">
+            <a:avLst/>
+          </a:prstGeom>
+          <a:noFill/>
+        </p:spPr>
+        <p:txBody>
+          <a:bodyPr wrap="square">
+            <a:spAutoFit/>
+          </a:bodyPr>
+          <a:lstStyle/>
+          <a:p>
+            <a:pPr>
+              <a:defRPr sz="1000" b="1">
+                <a:solidFill>
+                  <a:srgbClr val="60A5FA"/>
+                </a:solidFill>
+                <a:latin typeface="Segoe UI"/>
+              </a:defRPr>
+            </a:pPr>
+            <a:r>
+              <a:t>RESULTADOS COMPARATIVOS</a:t>
+            </a:r>
+          </a:p>
+        </p:txBody>
+      </p:sp>
+      <p:sp>
+        <p:nvSpPr>
+          <p:cNvPr id="4" name="TextBox 3"/>
+          <p:cNvSpPr txBox="1"/>
+          <p:nvPr/>
+        </p:nvSpPr>
+        <p:spPr>
+          <a:xfrm>
+            <a:off x="731520" y="658368"/>
+            <a:ext cx="10698480" cy="640080"/>
+          </a:xfrm>
+          <a:prstGeom prst="rect">
+            <a:avLst/>
+          </a:prstGeom>
+          <a:noFill/>
+        </p:spPr>
+        <p:txBody>
+          <a:bodyPr wrap="square">
+            <a:spAutoFit/>
+          </a:bodyPr>
+          <a:lstStyle/>
+          <a:p>
+            <a:pPr>
+              <a:defRPr sz="2200" b="1">
+                <a:solidFill>
+                  <a:srgbClr val="F8FAFC"/>
+                </a:solidFill>
+                <a:latin typeface="Segoe UI"/>
+              </a:defRPr>
+            </a:pPr>
+            <a:r>
+              <a:t>Impacto de la Optimización: De Sequential Scan a Index Scan</a:t>
+            </a:r>
+          </a:p>
+        </p:txBody>
+      </p:sp>
+      <p:sp>
+        <p:nvSpPr>
+          <p:cNvPr id="5" name="Rounded Rectangle 4"/>
+          <p:cNvSpPr/>
+          <p:nvPr/>
+        </p:nvSpPr>
+        <p:spPr>
+          <a:xfrm>
+            <a:off x="731520" y="1508760"/>
+            <a:ext cx="5029200" cy="4663440"/>
+          </a:xfrm>
+          <a:prstGeom prst="roundRect">
+            <a:avLst/>
+          </a:prstGeom>
+          <a:solidFill>
+            <a:srgbClr val="1E293B"/>
+          </a:solidFill>
+          <a:ln w="12700">
+            <a:solidFill>
+              <a:srgbClr val="334155"/>
+            </a:solidFill>
+          </a:ln>
+          <a:effectLst/>
+        </p:spPr>
+        <p:style>
+          <a:lnRef idx="1">
+            <a:schemeClr val="accent1"/>
+          </a:lnRef>
+          <a:fillRef idx="3">
+            <a:schemeClr val="accent1"/>
+          </a:fillRef>
+          <a:effectRef idx="2">
+            <a:schemeClr val="accent1"/>
+          </a:effectRef>
+          <a:fontRef idx="minor">
+            <a:schemeClr val="lt1"/>
+          </a:fontRef>
+        </p:style>
+        <p:txBody>
+          <a:bodyPr rtlCol="0" anchor="ctr"/>
+          <a:lstStyle/>
+          <a:p>
+            <a:pPr algn="ctr"/>
+          </a:p>
+        </p:txBody>
+      </p:sp>
+      <p:sp>
+        <p:nvSpPr>
+          <p:cNvPr id="6" name="TextBox 5"/>
+          <p:cNvSpPr txBox="1"/>
+          <p:nvPr/>
+        </p:nvSpPr>
+        <p:spPr>
+          <a:xfrm>
+            <a:off x="960120" y="1673352"/>
+            <a:ext cx="4572000" cy="411480"/>
+          </a:xfrm>
+          <a:prstGeom prst="rect">
+            <a:avLst/>
+          </a:prstGeom>
+          <a:noFill/>
+        </p:spPr>
+        <p:txBody>
+          <a:bodyPr wrap="square">
+            <a:spAutoFit/>
+          </a:bodyPr>
+          <a:lstStyle/>
+          <a:p>
+            <a:pPr>
+              <a:defRPr sz="1400" b="1">
+                <a:solidFill>
+                  <a:srgbClr val="60A5FA"/>
+                </a:solidFill>
+                <a:latin typeface="Segoe UI"/>
+              </a:defRPr>
+            </a:pPr>
+            <a:r>
+              <a:t>Métricas de Desempeño</a:t>
+            </a:r>
+          </a:p>
+        </p:txBody>
+      </p:sp>
+      <p:sp>
+        <p:nvSpPr>
+          <p:cNvPr id="7" name="TextBox 6"/>
+          <p:cNvSpPr txBox="1"/>
+          <p:nvPr/>
+        </p:nvSpPr>
+        <p:spPr>
+          <a:xfrm>
+            <a:off x="960120" y="2057400"/>
+            <a:ext cx="4572000" cy="3931920"/>
+          </a:xfrm>
+          <a:prstGeom prst="rect">
+            <a:avLst/>
+          </a:prstGeom>
+          <a:noFill/>
+        </p:spPr>
+        <p:txBody>
+          <a:bodyPr wrap="square">
+            <a:spAutoFit/>
+          </a:bodyPr>
+          <a:lstStyle/>
+          <a:p>
+            <a:pPr>
+              <a:spcBef>
+                <a:spcPts val="200"/>
+              </a:spcBef>
+              <a:spcAft>
+                <a:spcPts val="700"/>
+              </a:spcAft>
+            </a:pPr>
+            <a:r>
+              <a:rPr b="0" sz="1200">
+                <a:solidFill>
+                  <a:srgbClr val="60A5FA"/>
+                </a:solidFill>
+                <a:latin typeface="Segoe UI"/>
+              </a:rPr>
+              <a:t>•  </a:t>
+            </a:r>
+            <a:r>
+              <a:rPr b="1" sz="1200">
+                <a:solidFill>
+                  <a:srgbClr val="E2E8F0"/>
+                </a:solidFill>
+                <a:latin typeface="Segoe UI"/>
+              </a:rPr>
+              <a:t>Caso 1 (Búsqueda por DNI): </a:t>
+            </a:r>
+            <a:r>
+              <a:rPr b="0" sz="1200">
+                <a:solidFill>
+                  <a:srgbClr val="94A3B8"/>
+                </a:solidFill>
+                <a:latin typeface="Segoe UI"/>
+              </a:rPr>
+              <a:t>La latencia se redujo de 13.71 ms a 0.12 ms; las lecturas pasaron de 1,301 bloques a solo 4 bloques (mejora &gt;110x).</a:t>
+            </a:r>
+          </a:p>
+          <a:p>
+            <a:pPr>
+              <a:spcBef>
+                <a:spcPts val="200"/>
+              </a:spcBef>
+              <a:spcAft>
+                <a:spcPts val="700"/>
+              </a:spcAft>
+            </a:pPr>
+            <a:r>
+              <a:rPr b="0" sz="1200">
+                <a:solidFill>
+                  <a:srgbClr val="60A5FA"/>
+                </a:solidFill>
+                <a:latin typeface="Segoe UI"/>
+              </a:rPr>
+              <a:t>•  </a:t>
+            </a:r>
+            <a:r>
+              <a:rPr b="1" sz="1200">
+                <a:solidFill>
+                  <a:srgbClr val="E2E8F0"/>
+                </a:solidFill>
+                <a:latin typeface="Segoe UI"/>
+              </a:rPr>
+              <a:t>Caso 2 (Cuentas y Fechas): </a:t>
+            </a:r>
+            <a:r>
+              <a:rPr b="0" sz="1200">
+                <a:solidFill>
+                  <a:srgbClr val="94A3B8"/>
+                </a:solidFill>
+                <a:latin typeface="Segoe UI"/>
+              </a:rPr>
+              <a:t>El índice compuesto evitó el Quicksort sobre 400k filas; la latencia se redujo de 391.04 ms a 0.10 ms (mejora &gt;3,900x).</a:t>
+            </a:r>
+          </a:p>
+          <a:p>
+            <a:pPr>
+              <a:spcBef>
+                <a:spcPts val="200"/>
+              </a:spcBef>
+              <a:spcAft>
+                <a:spcPts val="700"/>
+              </a:spcAft>
+            </a:pPr>
+            <a:r>
+              <a:rPr b="0" sz="1200">
+                <a:solidFill>
+                  <a:srgbClr val="60A5FA"/>
+                </a:solidFill>
+                <a:latin typeface="Segoe UI"/>
+              </a:rPr>
+              <a:t>•  </a:t>
+            </a:r>
+            <a:r>
+              <a:rPr b="1" sz="1200">
+                <a:solidFill>
+                  <a:srgbClr val="E2E8F0"/>
+                </a:solidFill>
+                <a:latin typeface="Segoe UI"/>
+              </a:rPr>
+              <a:t>Caso 3 (Uso de LOWER): </a:t>
+            </a:r>
+            <a:r>
+              <a:rPr b="0" sz="1200">
+                <a:solidFill>
+                  <a:srgbClr val="94A3B8"/>
+                </a:solidFill>
+                <a:latin typeface="Segoe UI"/>
+              </a:rPr>
+              <a:t>El índice funcional resolvió la invalidación del índice estándar, reduciendo el tiempo de 71.17 ms a 0.72 ms (mejora &gt;95x).</a:t>
+            </a:r>
+          </a:p>
+          <a:p>
+            <a:pPr>
+              <a:spcBef>
+                <a:spcPts val="200"/>
+              </a:spcBef>
+              <a:spcAft>
+                <a:spcPts val="700"/>
+              </a:spcAft>
+            </a:pPr>
+            <a:r>
+              <a:rPr b="0" sz="1200">
+                <a:solidFill>
+                  <a:srgbClr val="60A5FA"/>
+                </a:solidFill>
+                <a:latin typeface="Segoe UI"/>
+              </a:rPr>
+              <a:t>•  </a:t>
+            </a:r>
+            <a:r>
+              <a:rPr b="1" sz="1200">
+                <a:solidFill>
+                  <a:srgbClr val="E2E8F0"/>
+                </a:solidFill>
+                <a:latin typeface="Segoe UI"/>
+              </a:rPr>
+              <a:t>Eficiencia General: </a:t>
+            </a:r>
+            <a:r>
+              <a:rPr b="0" sz="1200">
+                <a:solidFill>
+                  <a:srgbClr val="94A3B8"/>
+                </a:solidFill>
+                <a:latin typeface="Segoe UI"/>
+              </a:rPr>
+              <a:t>Menor contención de memoria compartida y liberación inmediata de conexiones en el pool.</a:t>
+            </a:r>
+          </a:p>
+        </p:txBody>
+      </p:sp>
+      <p:pic>
+        <p:nvPicPr>
+          <p:cNvPr id="8" name="Picture 7" descr="grafico_optimizacion_benchmark.png"/>
+          <p:cNvPicPr>
+            <a:picLocks noChangeAspect="1"/>
+          </p:cNvPicPr>
+          <p:nvPr/>
+        </p:nvPicPr>
+        <p:blipFill>
+          <a:blip r:embed="rId2"/>
+          <a:stretch>
+            <a:fillRect/>
+          </a:stretch>
+        </p:blipFill>
+        <p:spPr>
+          <a:xfrm>
+            <a:off x="6035040" y="1645920"/>
+            <a:ext cx="5394960" cy="3371850"/>
+          </a:xfrm>
+          <a:prstGeom prst="rect">
+            <a:avLst/>
+          </a:prstGeom>
+        </p:spPr>
+      </p:pic>
+    </p:spTree>
+  </p:cSld>
+  <p:clrMapOvr>
+    <a:masterClrMapping/>
+  </p:clrMapOvr>
+</p:sld>
+</file>
+
+<file path=ppt/slides/slide13.xml><?xml version="1.0" encoding="utf-8"?>
+<p:sld xmlns:a="http://schemas.openxmlformats.org/drawingml/2006/main" xmlns:p="http://schemas.openxmlformats.org/presentationml/2006/main" xmlns:r="http://schemas.openxmlformats.org/officeDocument/2006/relationships">
+  <p:cSld>
+    <p:spTree>
+      <p:nvGrpSpPr>
+        <p:cNvPr id="1" name=""/>
+        <p:cNvGrpSpPr/>
+        <p:nvPr/>
+      </p:nvGrpSpPr>
+      <p:grpSpPr/>
+      <p:sp>
+        <p:nvSpPr>
+          <p:cNvPr id="2" name="Rectangle 1"/>
+          <p:cNvSpPr/>
+          <p:nvPr/>
+        </p:nvSpPr>
+        <p:spPr>
+          <a:xfrm>
+            <a:off x="0" y="0"/>
+            <a:ext cx="12191695" cy="6858000"/>
+          </a:xfrm>
+          <a:prstGeom prst="rect">
+            <a:avLst/>
+          </a:prstGeom>
+          <a:solidFill>
+            <a:srgbClr val="0F172A"/>
+          </a:solidFill>
+          <a:ln>
+            <a:noFill/>
+          </a:ln>
+        </p:spPr>
+        <p:style>
+          <a:lnRef idx="1">
+            <a:schemeClr val="accent1"/>
+          </a:lnRef>
+          <a:fillRef idx="3">
+            <a:schemeClr val="accent1"/>
+          </a:fillRef>
+          <a:effectRef idx="2">
+            <a:schemeClr val="accent1"/>
+          </a:effectRef>
+          <a:fontRef idx="minor">
+            <a:schemeClr val="lt1"/>
+          </a:fontRef>
+        </p:style>
+        <p:txBody>
+          <a:bodyPr rtlCol="0" anchor="ctr"/>
+          <a:lstStyle/>
+          <a:p>
+            <a:pPr algn="ctr"/>
+          </a:p>
+        </p:txBody>
+      </p:sp>
+      <p:sp>
+        <p:nvSpPr>
+          <p:cNvPr id="3" name="TextBox 2"/>
+          <p:cNvSpPr txBox="1"/>
+          <p:nvPr/>
+        </p:nvSpPr>
+        <p:spPr>
+          <a:xfrm>
+            <a:off x="731520" y="384048"/>
+            <a:ext cx="10698480" cy="274320"/>
+          </a:xfrm>
+          <a:prstGeom prst="rect">
+            <a:avLst/>
+          </a:prstGeom>
+          <a:noFill/>
+        </p:spPr>
+        <p:txBody>
+          <a:bodyPr wrap="square">
+            <a:spAutoFit/>
+          </a:bodyPr>
+          <a:lstStyle/>
+          <a:p>
+            <a:pPr>
+              <a:defRPr sz="1000" b="1">
+                <a:solidFill>
+                  <a:srgbClr val="60A5FA"/>
+                </a:solidFill>
+                <a:latin typeface="Segoe UI"/>
+              </a:defRPr>
+            </a:pPr>
+            <a:r>
+              <a:t>METODOLOGÍA EXPERIMENTAL</a:t>
+            </a:r>
+          </a:p>
+        </p:txBody>
+      </p:sp>
+      <p:sp>
+        <p:nvSpPr>
+          <p:cNvPr id="4" name="TextBox 3"/>
+          <p:cNvSpPr txBox="1"/>
+          <p:nvPr/>
+        </p:nvSpPr>
+        <p:spPr>
+          <a:xfrm>
+            <a:off x="731520" y="658368"/>
+            <a:ext cx="10698480" cy="640080"/>
+          </a:xfrm>
+          <a:prstGeom prst="rect">
+            <a:avLst/>
+          </a:prstGeom>
+          <a:noFill/>
+        </p:spPr>
+        <p:txBody>
+          <a:bodyPr wrap="square">
+            <a:spAutoFit/>
+          </a:bodyPr>
+          <a:lstStyle/>
+          <a:p>
+            <a:pPr>
+              <a:defRPr sz="2200" b="1">
+                <a:solidFill>
+                  <a:srgbClr val="F8FAFC"/>
+                </a:solidFill>
+                <a:latin typeface="Segoe UI"/>
+              </a:defRPr>
+            </a:pPr>
+            <a:r>
+              <a:t>Flujo Integrado de Demostración del Laboratorio</a:t>
+            </a:r>
+          </a:p>
+        </p:txBody>
+      </p:sp>
+      <p:sp>
+        <p:nvSpPr>
+          <p:cNvPr id="5" name="Rounded Rectangle 4"/>
+          <p:cNvSpPr/>
+          <p:nvPr/>
+        </p:nvSpPr>
+        <p:spPr>
+          <a:xfrm>
+            <a:off x="731520" y="1508760"/>
+            <a:ext cx="3291840" cy="4663440"/>
+          </a:xfrm>
+          <a:prstGeom prst="roundRect">
+            <a:avLst/>
+          </a:prstGeom>
+          <a:solidFill>
+            <a:srgbClr val="1E293B"/>
+          </a:solidFill>
+          <a:ln w="12700">
+            <a:solidFill>
+              <a:srgbClr val="334155"/>
+            </a:solidFill>
+          </a:ln>
+          <a:effectLst/>
+        </p:spPr>
+        <p:style>
+          <a:lnRef idx="1">
+            <a:schemeClr val="accent1"/>
+          </a:lnRef>
+          <a:fillRef idx="3">
+            <a:schemeClr val="accent1"/>
+          </a:fillRef>
+          <a:effectRef idx="2">
+            <a:schemeClr val="accent1"/>
+          </a:effectRef>
+          <a:fontRef idx="minor">
+            <a:schemeClr val="lt1"/>
+          </a:fontRef>
+        </p:style>
+        <p:txBody>
+          <a:bodyPr rtlCol="0" anchor="ctr"/>
+          <a:lstStyle/>
+          <a:p>
+            <a:pPr algn="ctr"/>
+          </a:p>
+        </p:txBody>
+      </p:sp>
+      <p:sp>
+        <p:nvSpPr>
+          <p:cNvPr id="6" name="TextBox 5"/>
+          <p:cNvSpPr txBox="1"/>
+          <p:nvPr/>
+        </p:nvSpPr>
+        <p:spPr>
+          <a:xfrm>
+            <a:off x="960120" y="1673352"/>
+            <a:ext cx="2834640" cy="411480"/>
+          </a:xfrm>
+          <a:prstGeom prst="rect">
+            <a:avLst/>
+          </a:prstGeom>
+          <a:noFill/>
+        </p:spPr>
+        <p:txBody>
+          <a:bodyPr wrap="square">
+            <a:spAutoFit/>
+          </a:bodyPr>
+          <a:lstStyle/>
+          <a:p>
+            <a:pPr>
+              <a:defRPr sz="1400" b="1">
+                <a:solidFill>
+                  <a:srgbClr val="60A5FA"/>
+                </a:solidFill>
+                <a:latin typeface="Segoe UI"/>
+              </a:defRPr>
+            </a:pPr>
+            <a:r>
+              <a:t>Fase 1: Línea Base y Respaldo</a:t>
+            </a:r>
+          </a:p>
+        </p:txBody>
+      </p:sp>
+      <p:sp>
+        <p:nvSpPr>
+          <p:cNvPr id="7" name="TextBox 6"/>
+          <p:cNvSpPr txBox="1"/>
+          <p:nvPr/>
+        </p:nvSpPr>
+        <p:spPr>
+          <a:xfrm>
+            <a:off x="914400" y="2103120"/>
+            <a:ext cx="2926080" cy="3840480"/>
+          </a:xfrm>
+          <a:prstGeom prst="rect">
+            <a:avLst/>
+          </a:prstGeom>
+          <a:noFill/>
+        </p:spPr>
+        <p:txBody>
+          <a:bodyPr wrap="square">
+            <a:spAutoFit/>
+          </a:bodyPr>
+          <a:lstStyle/>
+          <a:p>
+            <a:pPr>
+              <a:spcBef>
+                <a:spcPts val="200"/>
+              </a:spcBef>
+              <a:spcAft>
+                <a:spcPts val="700"/>
+              </a:spcAft>
+            </a:pPr>
+            <a:r>
+              <a:rPr b="0" sz="1200">
+                <a:solidFill>
+                  <a:srgbClr val="60A5FA"/>
+                </a:solidFill>
+                <a:latin typeface="Segoe UI"/>
+              </a:rPr>
+              <a:t>•  </a:t>
+            </a:r>
+            <a:r>
+              <a:rPr b="1" sz="1200">
+                <a:solidFill>
+                  <a:srgbClr val="E2E8F0"/>
+                </a:solidFill>
+                <a:latin typeface="Segoe UI"/>
+              </a:rPr>
+              <a:t>Poblado Inicial: </a:t>
+            </a:r>
+            <a:r>
+              <a:rPr b="0" sz="1200">
+                <a:solidFill>
+                  <a:srgbClr val="94A3B8"/>
+                </a:solidFill>
+                <a:latin typeface="Segoe UI"/>
+              </a:rPr>
+              <a:t>Generación masiva de 600,000 registros sintéticos en PostgreSQL mediante funciones de memoria.</a:t>
+            </a:r>
+          </a:p>
+          <a:p>
+            <a:pPr>
+              <a:spcBef>
+                <a:spcPts val="200"/>
+              </a:spcBef>
+              <a:spcAft>
+                <a:spcPts val="700"/>
+              </a:spcAft>
+            </a:pPr>
+            <a:r>
+              <a:rPr b="0" sz="1200">
+                <a:solidFill>
+                  <a:srgbClr val="60A5FA"/>
+                </a:solidFill>
+                <a:latin typeface="Segoe UI"/>
+              </a:rPr>
+              <a:t>•  </a:t>
+            </a:r>
+            <a:r>
+              <a:rPr b="1" sz="1200">
+                <a:solidFill>
+                  <a:srgbClr val="E2E8F0"/>
+                </a:solidFill>
+                <a:latin typeface="Segoe UI"/>
+              </a:rPr>
+              <a:t>Respaldo Completo: </a:t>
+            </a:r>
+            <a:r>
+              <a:rPr b="0" sz="1200">
+                <a:solidFill>
+                  <a:srgbClr val="94A3B8"/>
+                </a:solidFill>
+                <a:latin typeface="Segoe UI"/>
+              </a:rPr>
+              <a:t>Ejecución de snapshot inicial en formato comprimido dentro del almacenamiento aislado.</a:t>
+            </a:r>
+          </a:p>
+          <a:p>
+            <a:pPr>
+              <a:spcBef>
+                <a:spcPts val="200"/>
+              </a:spcBef>
+              <a:spcAft>
+                <a:spcPts val="700"/>
+              </a:spcAft>
+            </a:pPr>
+            <a:r>
+              <a:rPr b="0" sz="1200">
+                <a:solidFill>
+                  <a:srgbClr val="60A5FA"/>
+                </a:solidFill>
+                <a:latin typeface="Segoe UI"/>
+              </a:rPr>
+              <a:t>•  </a:t>
+            </a:r>
+            <a:r>
+              <a:rPr b="1" sz="1200">
+                <a:solidFill>
+                  <a:srgbClr val="E2E8F0"/>
+                </a:solidFill>
+                <a:latin typeface="Segoe UI"/>
+              </a:rPr>
+              <a:t>Recuperación PITR: </a:t>
+            </a:r>
+            <a:r>
+              <a:rPr b="0" sz="1200">
+                <a:solidFill>
+                  <a:srgbClr val="94A3B8"/>
+                </a:solidFill>
+                <a:latin typeface="Segoe UI"/>
+              </a:rPr>
+              <a:t>Simulación de incidente destructivo y validación de consistencia transaccional tras restaurar.</a:t>
+            </a:r>
+          </a:p>
+        </p:txBody>
+      </p:sp>
+      <p:sp>
+        <p:nvSpPr>
+          <p:cNvPr id="8" name="Rounded Rectangle 7"/>
+          <p:cNvSpPr/>
+          <p:nvPr/>
+        </p:nvSpPr>
+        <p:spPr>
+          <a:xfrm>
+            <a:off x="4389120" y="1508760"/>
+            <a:ext cx="3291840" cy="4663440"/>
+          </a:xfrm>
+          <a:prstGeom prst="roundRect">
+            <a:avLst/>
+          </a:prstGeom>
+          <a:solidFill>
+            <a:srgbClr val="1E293B"/>
+          </a:solidFill>
+          <a:ln w="12700">
+            <a:solidFill>
+              <a:srgbClr val="334155"/>
+            </a:solidFill>
+          </a:ln>
+          <a:effectLst/>
+        </p:spPr>
+        <p:style>
+          <a:lnRef idx="1">
+            <a:schemeClr val="accent1"/>
+          </a:lnRef>
+          <a:fillRef idx="3">
+            <a:schemeClr val="accent1"/>
+          </a:fillRef>
+          <a:effectRef idx="2">
+            <a:schemeClr val="accent1"/>
+          </a:effectRef>
+          <a:fontRef idx="minor">
+            <a:schemeClr val="lt1"/>
+          </a:fontRef>
+        </p:style>
+        <p:txBody>
+          <a:bodyPr rtlCol="0" anchor="ctr"/>
+          <a:lstStyle/>
+          <a:p>
+            <a:pPr algn="ctr"/>
+          </a:p>
+        </p:txBody>
+      </p:sp>
+      <p:sp>
+        <p:nvSpPr>
+          <p:cNvPr id="9" name="TextBox 8"/>
+          <p:cNvSpPr txBox="1"/>
+          <p:nvPr/>
+        </p:nvSpPr>
+        <p:spPr>
+          <a:xfrm>
+            <a:off x="4617720" y="1673352"/>
+            <a:ext cx="2834640" cy="411480"/>
+          </a:xfrm>
+          <a:prstGeom prst="rect">
+            <a:avLst/>
+          </a:prstGeom>
+          <a:noFill/>
+        </p:spPr>
+        <p:txBody>
+          <a:bodyPr wrap="square">
+            <a:spAutoFit/>
+          </a:bodyPr>
+          <a:lstStyle/>
+          <a:p>
+            <a:pPr>
+              <a:defRPr sz="1400" b="1">
+                <a:solidFill>
+                  <a:srgbClr val="60A5FA"/>
+                </a:solidFill>
+                <a:latin typeface="Segoe UI"/>
+              </a:defRPr>
+            </a:pPr>
+            <a:r>
+              <a:t>Fase 2: Telemetría y Carga</a:t>
+            </a:r>
+          </a:p>
+        </p:txBody>
+      </p:sp>
+      <p:sp>
+        <p:nvSpPr>
+          <p:cNvPr id="10" name="TextBox 9"/>
+          <p:cNvSpPr txBox="1"/>
+          <p:nvPr/>
+        </p:nvSpPr>
+        <p:spPr>
+          <a:xfrm>
+            <a:off x="4572000" y="2103120"/>
+            <a:ext cx="2926080" cy="3840480"/>
+          </a:xfrm>
+          <a:prstGeom prst="rect">
+            <a:avLst/>
+          </a:prstGeom>
+          <a:noFill/>
+        </p:spPr>
+        <p:txBody>
+          <a:bodyPr wrap="square">
+            <a:spAutoFit/>
+          </a:bodyPr>
+          <a:lstStyle/>
+          <a:p>
+            <a:pPr>
+              <a:spcBef>
+                <a:spcPts val="200"/>
+              </a:spcBef>
+              <a:spcAft>
+                <a:spcPts val="700"/>
+              </a:spcAft>
+            </a:pPr>
+            <a:r>
+              <a:rPr b="0" sz="1200">
+                <a:solidFill>
+                  <a:srgbClr val="60A5FA"/>
+                </a:solidFill>
+                <a:latin typeface="Segoe UI"/>
+              </a:rPr>
+              <a:t>•  </a:t>
+            </a:r>
+            <a:r>
+              <a:rPr b="1" sz="1200">
+                <a:solidFill>
+                  <a:srgbClr val="E2E8F0"/>
+                </a:solidFill>
+                <a:latin typeface="Segoe UI"/>
+              </a:rPr>
+              <a:t>Inyección Concurrente: </a:t>
+            </a:r>
+            <a:r>
+              <a:rPr b="0" sz="1200">
+                <a:solidFill>
+                  <a:srgbClr val="94A3B8"/>
+                </a:solidFill>
+                <a:latin typeface="Segoe UI"/>
+              </a:rPr>
+              <a:t>Simulación de tráfico transaccional continuo (lecturas, transferencias y rollbacks).</a:t>
+            </a:r>
+          </a:p>
+          <a:p>
+            <a:pPr>
+              <a:spcBef>
+                <a:spcPts val="200"/>
+              </a:spcBef>
+              <a:spcAft>
+                <a:spcPts val="700"/>
+              </a:spcAft>
+            </a:pPr>
+            <a:r>
+              <a:rPr b="0" sz="1200">
+                <a:solidFill>
+                  <a:srgbClr val="60A5FA"/>
+                </a:solidFill>
+                <a:latin typeface="Segoe UI"/>
+              </a:rPr>
+              <a:t>•  </a:t>
+            </a:r>
+            <a:r>
+              <a:rPr b="1" sz="1200">
+                <a:solidFill>
+                  <a:srgbClr val="E2E8F0"/>
+                </a:solidFill>
+                <a:latin typeface="Segoe UI"/>
+              </a:rPr>
+              <a:t>Transmisión en Streaming: </a:t>
+            </a:r>
+            <a:r>
+              <a:rPr b="0" sz="1200">
+                <a:solidFill>
+                  <a:srgbClr val="94A3B8"/>
+                </a:solidFill>
+                <a:latin typeface="Segoe UI"/>
+              </a:rPr>
+              <a:t>Captura en tiempo real de eventos con Promtail hacia el repositorio de Loki.</a:t>
+            </a:r>
+          </a:p>
+          <a:p>
+            <a:pPr>
+              <a:spcBef>
+                <a:spcPts val="200"/>
+              </a:spcBef>
+              <a:spcAft>
+                <a:spcPts val="700"/>
+              </a:spcAft>
+            </a:pPr>
+            <a:r>
+              <a:rPr b="0" sz="1200">
+                <a:solidFill>
+                  <a:srgbClr val="60A5FA"/>
+                </a:solidFill>
+                <a:latin typeface="Segoe UI"/>
+              </a:rPr>
+              <a:t>•  </a:t>
+            </a:r>
+            <a:r>
+              <a:rPr b="1" sz="1200">
+                <a:solidFill>
+                  <a:srgbClr val="E2E8F0"/>
+                </a:solidFill>
+                <a:latin typeface="Segoe UI"/>
+              </a:rPr>
+              <a:t>Monitoreo en Vivo: </a:t>
+            </a:r>
+            <a:r>
+              <a:rPr b="0" sz="1200">
+                <a:solidFill>
+                  <a:srgbClr val="94A3B8"/>
+                </a:solidFill>
+                <a:latin typeface="Segoe UI"/>
+              </a:rPr>
+              <a:t>Inspección de curvas de QPS, patrones de escritura y registro de errores en Grafana.</a:t>
+            </a:r>
+          </a:p>
+        </p:txBody>
+      </p:sp>
+      <p:sp>
+        <p:nvSpPr>
+          <p:cNvPr id="11" name="Rounded Rectangle 10"/>
+          <p:cNvSpPr/>
+          <p:nvPr/>
+        </p:nvSpPr>
+        <p:spPr>
+          <a:xfrm>
+            <a:off x="8046720" y="1508760"/>
+            <a:ext cx="3383280" cy="4663440"/>
+          </a:xfrm>
+          <a:prstGeom prst="roundRect">
+            <a:avLst/>
+          </a:prstGeom>
+          <a:solidFill>
+            <a:srgbClr val="1E293B"/>
+          </a:solidFill>
+          <a:ln w="12700">
+            <a:solidFill>
+              <a:srgbClr val="334155"/>
+            </a:solidFill>
+          </a:ln>
+          <a:effectLst/>
+        </p:spPr>
+        <p:style>
+          <a:lnRef idx="1">
+            <a:schemeClr val="accent1"/>
+          </a:lnRef>
+          <a:fillRef idx="3">
+            <a:schemeClr val="accent1"/>
+          </a:fillRef>
+          <a:effectRef idx="2">
+            <a:schemeClr val="accent1"/>
+          </a:effectRef>
+          <a:fontRef idx="minor">
+            <a:schemeClr val="lt1"/>
+          </a:fontRef>
+        </p:style>
+        <p:txBody>
+          <a:bodyPr rtlCol="0" anchor="ctr"/>
+          <a:lstStyle/>
+          <a:p>
+            <a:pPr algn="ctr"/>
+          </a:p>
+        </p:txBody>
+      </p:sp>
+      <p:sp>
+        <p:nvSpPr>
+          <p:cNvPr id="12" name="TextBox 11"/>
+          <p:cNvSpPr txBox="1"/>
+          <p:nvPr/>
+        </p:nvSpPr>
+        <p:spPr>
+          <a:xfrm>
+            <a:off x="8275320" y="1673352"/>
+            <a:ext cx="2926080" cy="411480"/>
+          </a:xfrm>
+          <a:prstGeom prst="rect">
+            <a:avLst/>
+          </a:prstGeom>
+          <a:noFill/>
+        </p:spPr>
+        <p:txBody>
+          <a:bodyPr wrap="square">
+            <a:spAutoFit/>
+          </a:bodyPr>
+          <a:lstStyle/>
+          <a:p>
+            <a:pPr>
+              <a:defRPr sz="1400" b="1">
+                <a:solidFill>
+                  <a:srgbClr val="60A5FA"/>
+                </a:solidFill>
+                <a:latin typeface="Segoe UI"/>
+              </a:defRPr>
+            </a:pPr>
+            <a:r>
+              <a:t>Fase 3: Diagnóstico y Tuning</a:t>
+            </a:r>
+          </a:p>
+        </p:txBody>
+      </p:sp>
+      <p:sp>
+        <p:nvSpPr>
+          <p:cNvPr id="13" name="TextBox 12"/>
+          <p:cNvSpPr txBox="1"/>
+          <p:nvPr/>
+        </p:nvSpPr>
+        <p:spPr>
+          <a:xfrm>
+            <a:off x="8229600" y="2103120"/>
+            <a:ext cx="3017520" cy="3840480"/>
+          </a:xfrm>
+          <a:prstGeom prst="rect">
+            <a:avLst/>
+          </a:prstGeom>
+          <a:noFill/>
+        </p:spPr>
+        <p:txBody>
+          <a:bodyPr wrap="square">
+            <a:spAutoFit/>
+          </a:bodyPr>
+          <a:lstStyle/>
+          <a:p>
+            <a:pPr>
+              <a:spcBef>
+                <a:spcPts val="200"/>
+              </a:spcBef>
+              <a:spcAft>
+                <a:spcPts val="700"/>
+              </a:spcAft>
+            </a:pPr>
+            <a:r>
+              <a:rPr b="0" sz="1200">
+                <a:solidFill>
+                  <a:srgbClr val="60A5FA"/>
+                </a:solidFill>
+                <a:latin typeface="Segoe UI"/>
+              </a:rPr>
+              <a:t>•  </a:t>
+            </a:r>
+            <a:r>
+              <a:rPr b="1" sz="1200">
+                <a:solidFill>
+                  <a:srgbClr val="E2E8F0"/>
+                </a:solidFill>
+                <a:latin typeface="Segoe UI"/>
+              </a:rPr>
+              <a:t>Detección de Cuellos: </a:t>
+            </a:r>
+            <a:r>
+              <a:rPr b="0" sz="1200">
+                <a:solidFill>
+                  <a:srgbClr val="94A3B8"/>
+                </a:solidFill>
+                <a:latin typeface="Segoe UI"/>
+              </a:rPr>
+              <a:t>Identificación de sentencias costosas reportadas por telemetría y pg_stat_statements.</a:t>
+            </a:r>
+          </a:p>
+          <a:p>
+            <a:pPr>
+              <a:spcBef>
+                <a:spcPts val="200"/>
+              </a:spcBef>
+              <a:spcAft>
+                <a:spcPts val="700"/>
+              </a:spcAft>
+            </a:pPr>
+            <a:r>
+              <a:rPr b="0" sz="1200">
+                <a:solidFill>
+                  <a:srgbClr val="60A5FA"/>
+                </a:solidFill>
+                <a:latin typeface="Segoe UI"/>
+              </a:rPr>
+              <a:t>•  </a:t>
+            </a:r>
+            <a:r>
+              <a:rPr b="1" sz="1200">
+                <a:solidFill>
+                  <a:srgbClr val="E2E8F0"/>
+                </a:solidFill>
+                <a:latin typeface="Segoe UI"/>
+              </a:rPr>
+              <a:t>Análisis de Planes: </a:t>
+            </a:r>
+            <a:r>
+              <a:rPr b="0" sz="1200">
+                <a:solidFill>
+                  <a:srgbClr val="94A3B8"/>
+                </a:solidFill>
+                <a:latin typeface="Segoe UI"/>
+              </a:rPr>
+              <a:t>Evaluación de costos y lecturas de bloques de disco mediante EXPLAIN ANALYZE.</a:t>
+            </a:r>
+          </a:p>
+          <a:p>
+            <a:pPr>
+              <a:spcBef>
+                <a:spcPts val="200"/>
+              </a:spcBef>
+              <a:spcAft>
+                <a:spcPts val="700"/>
+              </a:spcAft>
+            </a:pPr>
+            <a:r>
+              <a:rPr b="0" sz="1200">
+                <a:solidFill>
+                  <a:srgbClr val="60A5FA"/>
+                </a:solidFill>
+                <a:latin typeface="Segoe UI"/>
+              </a:rPr>
+              <a:t>•  </a:t>
+            </a:r>
+            <a:r>
+              <a:rPr b="1" sz="1200">
+                <a:solidFill>
+                  <a:srgbClr val="E2E8F0"/>
+                </a:solidFill>
+                <a:latin typeface="Segoe UI"/>
+              </a:rPr>
+              <a:t>Verificación de Índices: </a:t>
+            </a:r>
+            <a:r>
+              <a:rPr b="0" sz="1200">
+                <a:solidFill>
+                  <a:srgbClr val="94A3B8"/>
+                </a:solidFill>
+                <a:latin typeface="Segoe UI"/>
+              </a:rPr>
+              <a:t>Constatación inmediata de la caída drástica en la latencia tras crear las estructuras.</a:t>
+            </a:r>
+          </a:p>
+        </p:txBody>
+      </p:sp>
+    </p:spTree>
+  </p:cSld>
+  <p:clrMapOvr>
+    <a:masterClrMapping/>
+  </p:clrMapOvr>
+</p:sld>
+</file>
+
+<file path=ppt/slides/slide14.xml><?xml version="1.0" encoding="utf-8"?>
+<p:sld xmlns:a="http://schemas.openxmlformats.org/drawingml/2006/main" xmlns:p="http://schemas.openxmlformats.org/presentationml/2006/main" xmlns:r="http://schemas.openxmlformats.org/officeDocument/2006/relationships">
+  <p:cSld>
+    <p:spTree>
+      <p:nvGrpSpPr>
+        <p:cNvPr id="1" name=""/>
+        <p:cNvGrpSpPr/>
+        <p:nvPr/>
+      </p:nvGrpSpPr>
+      <p:grpSpPr/>
+      <p:sp>
+        <p:nvSpPr>
+          <p:cNvPr id="2" name="Rectangle 1"/>
+          <p:cNvSpPr/>
+          <p:nvPr/>
+        </p:nvSpPr>
+        <p:spPr>
+          <a:xfrm>
+            <a:off x="0" y="0"/>
+            <a:ext cx="12191695" cy="6858000"/>
+          </a:xfrm>
+          <a:prstGeom prst="rect">
+            <a:avLst/>
+          </a:prstGeom>
+          <a:solidFill>
+            <a:srgbClr val="0F172A"/>
+          </a:solidFill>
+          <a:ln>
+            <a:noFill/>
+          </a:ln>
+        </p:spPr>
+        <p:style>
+          <a:lnRef idx="1">
+            <a:schemeClr val="accent1"/>
+          </a:lnRef>
+          <a:fillRef idx="3">
+            <a:schemeClr val="accent1"/>
+          </a:fillRef>
+          <a:effectRef idx="2">
+            <a:schemeClr val="accent1"/>
+          </a:effectRef>
+          <a:fontRef idx="minor">
+            <a:schemeClr val="lt1"/>
+          </a:fontRef>
+        </p:style>
+        <p:txBody>
+          <a:bodyPr rtlCol="0" anchor="ctr"/>
+          <a:lstStyle/>
+          <a:p>
+            <a:pPr algn="ctr"/>
+          </a:p>
+        </p:txBody>
+      </p:sp>
+      <p:sp>
+        <p:nvSpPr>
+          <p:cNvPr id="3" name="TextBox 2"/>
+          <p:cNvSpPr txBox="1"/>
+          <p:nvPr/>
+        </p:nvSpPr>
+        <p:spPr>
+          <a:xfrm>
+            <a:off x="731520" y="384048"/>
+            <a:ext cx="10698480" cy="274320"/>
+          </a:xfrm>
+          <a:prstGeom prst="rect">
+            <a:avLst/>
+          </a:prstGeom>
+          <a:noFill/>
+        </p:spPr>
+        <p:txBody>
+          <a:bodyPr wrap="square">
+            <a:spAutoFit/>
+          </a:bodyPr>
+          <a:lstStyle/>
+          <a:p>
+            <a:pPr>
+              <a:defRPr sz="1000" b="1">
+                <a:solidFill>
+                  <a:srgbClr val="60A5FA"/>
+                </a:solidFill>
+                <a:latin typeface="Segoe UI"/>
+              </a:defRPr>
+            </a:pPr>
+            <a:r>
               <a:t>SÍNTESIS EJECUTIVA</a:t>
             </a:r>
           </a:p>
@@ -6413,7 +7912,7 @@
               </a:defRPr>
             </a:pPr>
             <a:r>
-              <a:t>Estrategias de Backup: Totales, Incrementales y Diferenciales</a:t>
+              <a:t>Taxonomía de Backups: Totales, Incrementales y Diferenciales</a:t>
             </a:r>
           </a:p>
         </p:txBody>
@@ -6555,7 +8054,7 @@
                 </a:solidFill>
                 <a:latin typeface="Segoe UI"/>
               </a:rPr>
-              <a:t>Copia completa de estructuras y datos. Base indispensable para cualquier esquema de contingencia.</a:t>
+              <a:t>Copia íntegra de estructuras y datos. Base obligatoria para cualquier plan de continuidad.</a:t>
             </a:r>
           </a:p>
           <a:p>
@@ -6666,7 +8165,7 @@
                 </a:solidFill>
                 <a:latin typeface="Segoe UI"/>
               </a:rPr>
-              <a:t>Objetivo de Punto de Recuperación; define el volumen máximo de transacciones que la organización tolera perder.</a:t>
+              <a:t>Recovery Point Objective; volumen máximo de transacciones que la organización tolera perder.</a:t>
             </a:r>
           </a:p>
           <a:p>
@@ -6703,7 +8202,7 @@
                 </a:solidFill>
                 <a:latin typeface="Segoe UI"/>
               </a:rPr>
-              <a:t>Objetivo de Tiempo de Recuperación; plazo admisible para restablecer la operatividad normal.</a:t>
+              <a:t>Recovery Time Objective; plazo máximo admisible para restablecer la operatividad normal.</a:t>
             </a:r>
           </a:p>
         </p:txBody>
@@ -6824,7 +8323,7 @@
               </a:defRPr>
             </a:pPr>
             <a:r>
-              <a:t>VALIDACIÓN PRÁCTICA</a:t>
+              <a:t>MECANISMOS DE RECUPERACIÓN</a:t>
             </a:r>
           </a:p>
         </p:txBody>
@@ -6860,7 +8359,7 @@
               </a:defRPr>
             </a:pPr>
             <a:r>
-              <a:t>Simulación de Pérdida de Datos y Restauración de Contingencia</a:t>
+              <a:t>Criterios de Selección: ¿Cuándo Utilizar Cada Método?</a:t>
             </a:r>
           </a:p>
         </p:txBody>
@@ -6942,7 +8441,7 @@
               </a:defRPr>
             </a:pPr>
             <a:r>
-              <a:t>Procedimiento de la Prueba</a:t>
+              <a:t>Escenarios Recomendados por Tipo</a:t>
             </a:r>
           </a:p>
         </p:txBody>
@@ -6993,7 +8492,7 @@
                 </a:solidFill>
                 <a:latin typeface="Segoe UI"/>
               </a:rPr>
-              <a:t>Fase 1 (Respaldo Base): </a:t>
+              <a:t>Cuándo usar Backup Total: </a:t>
             </a:r>
             <a:r>
               <a:rPr b="0" sz="1200">
@@ -7002,7 +8501,7 @@
                 </a:solidFill>
                 <a:latin typeface="Segoe UI"/>
               </a:rPr>
-              <a:t>Generación de dump binario comprimido de 13 MB mediante pg_dump en 5.2 segundos.</a:t>
+              <a:t>Ventanas semanales o mensuales de bajo tráfico (ej. domingos en la noche); indispensable antes de migraciones de esquema mayores.</a:t>
             </a:r>
           </a:p>
           <a:p>
@@ -7030,7 +8529,7 @@
                 </a:solidFill>
                 <a:latin typeface="Segoe UI"/>
               </a:rPr>
-              <a:t>Fase 2 (Transacción Crítica): </a:t>
+              <a:t>Cuándo usar Backup Diferencial: </a:t>
             </a:r>
             <a:r>
               <a:rPr b="0" sz="1200">
@@ -7039,7 +8538,7 @@
                 </a:solidFill>
                 <a:latin typeface="Segoe UI"/>
               </a:rPr>
-              <a:t>Registro de movimientos financieros de última hora posteriores al backup base.</a:t>
+              <a:t>Ejecución diaria nocturna entre semana; recomendado cuando se exige un RTO muy rápido, ya que solo se restaura el Full + último diferencial.</a:t>
             </a:r>
           </a:p>
           <a:p>
@@ -7067,7 +8566,7 @@
                 </a:solidFill>
                 <a:latin typeface="Segoe UI"/>
               </a:rPr>
-              <a:t>Fase 3 (Desastre Simulado): </a:t>
+              <a:t>Cuándo usar Backup Incremental: </a:t>
             </a:r>
             <a:r>
               <a:rPr b="0" sz="1200">
@@ -7076,7 +8575,7 @@
                 </a:solidFill>
                 <a:latin typeface="Segoe UI"/>
               </a:rPr>
-              <a:t>Ejecución de sentencia destructiva accidental: DROP TABLE transacciones CASCADE.</a:t>
+              <a:t>Ejecución horaria o continua mediante WAL archiving; ideal para sistemas transaccionales críticos donde el RPO debe ser menor a 5 minutos.</a:t>
             </a:r>
           </a:p>
           <a:p>
@@ -7104,7 +8603,7 @@
                 </a:solidFill>
                 <a:latin typeface="Segoe UI"/>
               </a:rPr>
-              <a:t>Fase 4 (Verificación de Pérdida): </a:t>
+              <a:t>Enfoque Híbrido Estándar: </a:t>
             </a:r>
             <a:r>
               <a:rPr b="0" sz="1200">
@@ -7113,44 +8612,7 @@
                 </a:solidFill>
                 <a:latin typeface="Segoe UI"/>
               </a:rPr>
-              <a:t>Consulta de catálogo donde se constata la indisponibilidad total de la información.</a:t>
-            </a:r>
-          </a:p>
-          <a:p>
-            <a:pPr>
-              <a:spcBef>
-                <a:spcPts val="200"/>
-              </a:spcBef>
-              <a:spcAft>
-                <a:spcPts val="700"/>
-              </a:spcAft>
-            </a:pPr>
-            <a:r>
-              <a:rPr b="0" sz="1200">
-                <a:solidFill>
-                  <a:srgbClr val="60A5FA"/>
-                </a:solidFill>
-                <a:latin typeface="Segoe UI"/>
-              </a:rPr>
-              <a:t>•  </a:t>
-            </a:r>
-            <a:r>
-              <a:rPr b="1" sz="1200">
-                <a:solidFill>
-                  <a:srgbClr val="E2E8F0"/>
-                </a:solidFill>
-                <a:latin typeface="Segoe UI"/>
-              </a:rPr>
-              <a:t>Fase 5 (Restauración Exitosa): </a:t>
-            </a:r>
-            <a:r>
-              <a:rPr b="0" sz="1200">
-                <a:solidFill>
-                  <a:srgbClr val="94A3B8"/>
-                </a:solidFill>
-                <a:latin typeface="Segoe UI"/>
-              </a:rPr>
-              <a:t>Ejecución de procedimiento de contingencia recuperando las 600,000 filas en 6 segundos.</a:t>
+              <a:t>Full semanal + Diferencial diario + Archivado continuo de WALs en tiempo real.</a:t>
             </a:r>
           </a:p>
         </p:txBody>
@@ -7232,7 +8694,7 @@
               </a:defRPr>
             </a:pPr>
             <a:r>
-              <a:t>Mecanismo Interno: WAL y LSN</a:t>
+              <a:t>Impacto en Recursos y Recuperación</a:t>
             </a:r>
           </a:p>
         </p:txBody>
@@ -7283,7 +8745,7 @@
                 </a:solidFill>
                 <a:latin typeface="Segoe UI"/>
               </a:rPr>
-              <a:t>Write-Ahead Logging: </a:t>
+              <a:t>Sobrecarga de I/O en Producción: </a:t>
             </a:r>
             <a:r>
               <a:rPr b="0" sz="1200">
@@ -7292,7 +8754,7 @@
                 </a:solidFill>
                 <a:latin typeface="Segoe UI"/>
               </a:rPr>
-              <a:t>Ningún cambio se escribe en las páginas de datos sin haber sido persistido antes en el WAL.</a:t>
+              <a:t>El Backup Total satura lecturas en disco; el Incremental lee únicamente bloques modificados o registros WAL.</a:t>
             </a:r>
           </a:p>
           <a:p>
@@ -7320,7 +8782,7 @@
                 </a:solidFill>
                 <a:latin typeface="Segoe UI"/>
               </a:rPr>
-              <a:t>Log Sequence Number (LSN): </a:t>
+              <a:t>Espacio de Almacenamiento: </a:t>
             </a:r>
             <a:r>
               <a:rPr b="0" sz="1200">
@@ -7329,7 +8791,7 @@
                 </a:solidFill>
                 <a:latin typeface="Segoe UI"/>
               </a:rPr>
-              <a:t>Identificador único y secuencial asignado a cada transacción en el sistema.</a:t>
+              <a:t>El Total requiere terabytes de destino; el Incremental minimiza el uso de disco al capturar solo deltas.</a:t>
             </a:r>
           </a:p>
           <a:p>
@@ -7357,7 +8819,7 @@
                 </a:solidFill>
                 <a:latin typeface="Segoe UI"/>
               </a:rPr>
-              <a:t>Archivado Activo: </a:t>
+              <a:t>Riesgo en la Restauración: </a:t>
             </a:r>
             <a:r>
               <a:rPr b="0" sz="1200">
@@ -7366,7 +8828,7 @@
                 </a:solidFill>
                 <a:latin typeface="Segoe UI"/>
               </a:rPr>
-              <a:t>PostgreSQL segmenta el log en ficheros de 16 MB y los transfiere de forma segura a storage aislado.</a:t>
+              <a:t>Si un segmento incremental de la cadena se corrompe, los incrementales posteriores se vuelven inválidos.</a:t>
             </a:r>
           </a:p>
           <a:p>
@@ -7394,7 +8856,7 @@
                 </a:solidFill>
                 <a:latin typeface="Segoe UI"/>
               </a:rPr>
-              <a:t>Point-In-Time Recovery (PITR): </a:t>
+              <a:t>Velocidad de Restauración (RTO): </a:t>
             </a:r>
             <a:r>
               <a:rPr b="0" sz="1200">
@@ -7403,7 +8865,7 @@
                 </a:solidFill>
                 <a:latin typeface="Segoe UI"/>
               </a:rPr>
-              <a:t>Permite reproducir la secuencia de transacciones hasta el segundo exacto previo a la falla.</a:t>
+              <a:t>Diferencial restaura en 2 pasos; Incremental exige aplicar Full + Inc1 + Inc2 + ... + IncN.</a:t>
             </a:r>
           </a:p>
         </p:txBody>
@@ -7500,7 +8962,7 @@
               </a:defRPr>
             </a:pPr>
             <a:r>
-              <a:t>OBSERVABILIDAD</a:t>
+              <a:t>ARQUITECTURA INTERNA</a:t>
             </a:r>
           </a:p>
         </p:txBody>
@@ -7536,7 +8998,7 @@
               </a:defRPr>
             </a:pPr>
             <a:r>
-              <a:t>Telemetría de Consultas y Almacenamiento Centralizado</a:t>
+              <a:t>Anatomía del WAL y el Motor de Archivador (archive_mode)</a:t>
             </a:r>
           </a:p>
         </p:txBody>
@@ -7618,7 +9080,7 @@
               </a:defRPr>
             </a:pPr>
             <a:r>
-              <a:t>Dimensiones de la Telemetría</a:t>
+              <a:t>Convención Hexadecimal de 24 Caracteres</a:t>
             </a:r>
           </a:p>
         </p:txBody>
@@ -7669,7 +9131,7 @@
                 </a:solidFill>
                 <a:latin typeface="Segoe UI"/>
               </a:rPr>
-              <a:t>Más allá del Hardware: </a:t>
+              <a:t>Estructura Física: </a:t>
             </a:r>
             <a:r>
               <a:rPr b="0" sz="1200">
@@ -7678,7 +9140,7 @@
                 </a:solidFill>
                 <a:latin typeface="Segoe UI"/>
               </a:rPr>
-              <a:t>No se limita al uso de CPU o memoria; audita cada sentencia ejecutada por clientes y aplicaciones.</a:t>
+              <a:t>Cada fichero WAL tiene un tamaño inmutable de exactamente 16.0 MB (ej. 00000001000000000000001D).</a:t>
             </a:r>
           </a:p>
           <a:p>
@@ -7706,7 +9168,7 @@
                 </a:solidFill>
                 <a:latin typeface="Segoe UI"/>
               </a:rPr>
-              <a:t>Throughput (QPS): </a:t>
+              <a:t>Timeline ID (Primeros 8 dígitos): </a:t>
             </a:r>
             <a:r>
               <a:rPr b="0" sz="1200">
@@ -7715,7 +9177,7 @@
                 </a:solidFill>
                 <a:latin typeface="Segoe UI"/>
               </a:rPr>
-              <a:t>Mide el volumen de operaciones por segundo y detecta picos de demanda inusuales.</a:t>
+              <a:t>00000001 identifica la línea temporal del motor; se incrementa si una réplica es promovida a nodo maestro.</a:t>
             </a:r>
           </a:p>
           <a:p>
@@ -7743,7 +9205,7 @@
                 </a:solidFill>
                 <a:latin typeface="Segoe UI"/>
               </a:rPr>
-              <a:t>Composición DML: </a:t>
+              <a:t>Log ID (Dígitos 9 al 16): </a:t>
             </a:r>
             <a:r>
               <a:rPr b="0" sz="1200">
@@ -7752,7 +9214,7 @@
                 </a:solidFill>
                 <a:latin typeface="Segoe UI"/>
               </a:rPr>
-              <a:t>Distribución entre consultas de lectura (SELECT) y operaciones de escritura (INSERT, UPDATE).</a:t>
+              <a:t>00000000 indica el número de serie del ciclo lógico de registros de transacciones.</a:t>
             </a:r>
           </a:p>
           <a:p>
@@ -7780,7 +9242,7 @@
                 </a:solidFill>
                 <a:latin typeface="Segoe UI"/>
               </a:rPr>
-              <a:t>Alertas Tempranas: </a:t>
+              <a:t>Segmento LSN (Últimos 8 dígitos): </a:t>
             </a:r>
             <a:r>
               <a:rPr b="0" sz="1200">
@@ -7789,7 +9251,44 @@
                 </a:solidFill>
                 <a:latin typeface="Segoe UI"/>
               </a:rPr>
-              <a:t>Identificación inmediata de bloqueos (locks), transacciones canceladas y rollbacks.</a:t>
+              <a:t>0000001D representa el número correlativo del segmento dentro del ciclo activo.</a:t>
+            </a:r>
+          </a:p>
+          <a:p>
+            <a:pPr>
+              <a:spcBef>
+                <a:spcPts val="200"/>
+              </a:spcBef>
+              <a:spcAft>
+                <a:spcPts val="700"/>
+              </a:spcAft>
+            </a:pPr>
+            <a:r>
+              <a:rPr b="0" sz="1200">
+                <a:solidFill>
+                  <a:srgbClr val="60A5FA"/>
+                </a:solidFill>
+                <a:latin typeface="Segoe UI"/>
+              </a:rPr>
+              <a:t>•  </a:t>
+            </a:r>
+            <a:r>
+              <a:rPr b="1" sz="1200">
+                <a:solidFill>
+                  <a:srgbClr val="E2E8F0"/>
+                </a:solidFill>
+                <a:latin typeface="Segoe UI"/>
+              </a:rPr>
+              <a:t>Principio WAL Inviolable: </a:t>
+            </a:r>
+            <a:r>
+              <a:rPr b="0" sz="1200">
+                <a:solidFill>
+                  <a:srgbClr val="94A3B8"/>
+                </a:solidFill>
+                <a:latin typeface="Segoe UI"/>
+              </a:rPr>
+              <a:t>Ningún registro se persiste en las tablas de datos sin antes haberse volcado en el WAL.</a:t>
             </a:r>
           </a:p>
         </p:txBody>
@@ -7871,7 +9370,7 @@
               </a:defRPr>
             </a:pPr>
             <a:r>
-              <a:t>Eficiencia de Grafana Loki</a:t>
+              <a:t>El Hilo del Motor: archive_mode</a:t>
             </a:r>
           </a:p>
         </p:txBody>
@@ -7922,7 +9421,7 @@
                 </a:solidFill>
                 <a:latin typeface="Segoe UI"/>
               </a:rPr>
-              <a:t>Indexación por Metadatos: </a:t>
+              <a:t>Qué es archive_mode: </a:t>
             </a:r>
             <a:r>
               <a:rPr b="0" sz="1200">
@@ -7931,7 +9430,7 @@
                 </a:solidFill>
                 <a:latin typeface="Segoe UI"/>
               </a:rPr>
-              <a:t>A diferencia de motores convencionales, Loki solo indexa etiquetas; reduce el consumo de RAM hasta un 90%.</a:t>
+              <a:t>Interruptor maestro que activa el proceso interno de fondo (Archiver Process) en PostgreSQL.</a:t>
             </a:r>
           </a:p>
           <a:p>
@@ -7959,7 +9458,7 @@
                 </a:solidFill>
                 <a:latin typeface="Segoe UI"/>
               </a:rPr>
-              <a:t>Consumo No Invasivo: </a:t>
+              <a:t>Parámetro POSTMASTER: </a:t>
             </a:r>
             <a:r>
               <a:rPr b="0" sz="1200">
@@ -7968,7 +9467,7 @@
                 </a:solidFill>
                 <a:latin typeface="Segoe UI"/>
               </a:rPr>
-              <a:t>Promtail recopila logs en streaming sin abrir bloqueos de tabla ni interferir en sesiones activas.</a:t>
+              <a:t>No puede cambiarse al vuelo con un simple SET en DBeaver; exige reinicio del motor porque reserva memoria compartida al arrancar.</a:t>
             </a:r>
           </a:p>
           <a:p>
@@ -7996,7 +9495,7 @@
                 </a:solidFill>
                 <a:latin typeface="Segoe UI"/>
               </a:rPr>
-              <a:t>Visibilidad Central: </a:t>
+              <a:t>Mecanismo Reactivo: </a:t>
             </a:r>
             <a:r>
               <a:rPr b="0" sz="1200">
@@ -8005,7 +9504,7 @@
                 </a:solidFill>
                 <a:latin typeface="Segoe UI"/>
               </a:rPr>
-              <a:t>Dashboards dinámicos permiten correlacionar latencias de consultas con eventos del motor.</a:t>
+              <a:t>En lugar de scripts manuales periódicos, el motor expulsa el archivo en el milisegundo exacto en que se sella el bloque de 16MB.</a:t>
             </a:r>
           </a:p>
           <a:p>
@@ -8033,7 +9532,7 @@
                 </a:solidFill>
                 <a:latin typeface="Segoe UI"/>
               </a:rPr>
-              <a:t>Retención Independiente: </a:t>
+              <a:t>Monitoreo con pg_stat_archiver: </a:t>
             </a:r>
             <a:r>
               <a:rPr b="0" sz="1200">
@@ -8042,7 +9541,7 @@
                 </a:solidFill>
                 <a:latin typeface="Segoe UI"/>
               </a:rPr>
-              <a:t>Políticas de archivado de logs sin comprometer el ciclo de vida de los datos transaccionales.</a:t>
+              <a:t>Vista del sistema que audita en vivo: archived_count (29 WALs), último archivo y hora exacta de despacho.</a:t>
             </a:r>
           </a:p>
         </p:txBody>
@@ -8139,7 +9638,7 @@
               </a:defRPr>
             </a:pPr>
             <a:r>
-              <a:t>DIAGNÓSTICO EXPERIMENTAL</a:t>
+              <a:t>OPERACIONES Y HERRAMIENTAS</a:t>
             </a:r>
           </a:p>
         </p:txBody>
@@ -8175,7 +9674,7 @@
               </a:defRPr>
             </a:pPr>
             <a:r>
-              <a:t>Comportamiento del Almacenamiento: Datos vs Logs Transaccionales</a:t>
+              <a:t>Comandos Nativos: Banderas Críticas y Sintaxis de Archivador</a:t>
             </a:r>
           </a:p>
         </p:txBody>
@@ -8189,7 +9688,7 @@
         <p:spPr>
           <a:xfrm>
             <a:off x="731520" y="1508760"/>
-            <a:ext cx="5029200" cy="4663440"/>
+            <a:ext cx="5212080" cy="4663440"/>
           </a:xfrm>
           <a:prstGeom prst="roundRect">
             <a:avLst/>
@@ -8235,7 +9734,7 @@
         <p:spPr>
           <a:xfrm>
             <a:off x="960120" y="1673352"/>
-            <a:ext cx="4572000" cy="411480"/>
+            <a:ext cx="4754880" cy="411480"/>
           </a:xfrm>
           <a:prstGeom prst="rect">
             <a:avLst/>
@@ -8257,7 +9756,7 @@
               </a:defRPr>
             </a:pPr>
             <a:r>
-              <a:t>Hallazgos de la Simulación</a:t>
+              <a:t>Generación de Respaldo y archive_command</a:t>
             </a:r>
           </a:p>
         </p:txBody>
@@ -8271,7 +9770,7 @@
         <p:spPr>
           <a:xfrm>
             <a:off x="960120" y="2057400"/>
-            <a:ext cx="4572000" cy="3931920"/>
+            <a:ext cx="4754880" cy="3931920"/>
           </a:xfrm>
           <a:prstGeom prst="rect">
             <a:avLst/>
@@ -8308,7 +9807,7 @@
                 </a:solidFill>
                 <a:latin typeface="Segoe UI"/>
               </a:rPr>
-              <a:t>Condición de Prueba: </a:t>
+              <a:t>pg_dump con Formato Custom (-F c): </a:t>
             </a:r>
             <a:r>
               <a:rPr b="0" sz="1200">
@@ -8317,7 +9816,7 @@
                 </a:solidFill>
                 <a:latin typeface="Segoe UI"/>
               </a:rPr>
-              <a:t>Ejecución continua de 500 sentencias UPDATE consecutivas sobre una única fila de saldo.</a:t>
+              <a:t>Comprime con zlib (13 MB para 600k filas) y genera metadatos para restauraciones selectivas o paralelas (-j).</a:t>
             </a:r>
           </a:p>
           <a:p>
@@ -8345,7 +9844,7 @@
                 </a:solidFill>
                 <a:latin typeface="Segoe UI"/>
               </a:rPr>
-              <a:t>Resultado en Tablas: </a:t>
+              <a:t>Banderas -b (Blobs) y -v (Verbose): </a:t>
             </a:r>
             <a:r>
               <a:rPr b="0" sz="1200">
@@ -8354,7 +9853,7 @@
                 </a:solidFill>
                 <a:latin typeface="Segoe UI"/>
               </a:rPr>
-              <a:t>El tamaño físico de la tabla en disco se mantiene invariable (~12.1 MB).</a:t>
+              <a:t>Garantizan integridad binaria y trazabilidad completa de cada tabla exportada.</a:t>
             </a:r>
           </a:p>
           <a:p>
@@ -8382,7 +9881,7 @@
                 </a:solidFill>
                 <a:latin typeface="Segoe UI"/>
               </a:rPr>
-              <a:t>Resultado en Logs: </a:t>
+              <a:t>Sintaxis de archive_command: </a:t>
             </a:r>
             <a:r>
               <a:rPr b="0" sz="1200">
@@ -8391,7 +9890,7 @@
                 </a:solidFill>
                 <a:latin typeface="Segoe UI"/>
               </a:rPr>
-              <a:t>Se emitieron 500 registros WAL de 16 MB y cientos de entradas de auditoría hacia Loki.</a:t>
+              <a:t>Utiliza %p (ruta del segmento cerrado en pg_wal) y %f (nombre del fichero) para enviar el WAL al destino seguro.</a:t>
             </a:r>
           </a:p>
           <a:p>
@@ -8419,7 +9918,7 @@
                 </a:solidFill>
                 <a:latin typeface="Segoe UI"/>
               </a:rPr>
-              <a:t>Conclusión Crítica: </a:t>
+              <a:t>Rotación Manual (pg_switch_wal): </a:t>
             </a:r>
             <a:r>
               <a:rPr b="0" sz="1200">
@@ -8428,9 +9927,114 @@
                 </a:solidFill>
                 <a:latin typeface="Segoe UI"/>
               </a:rPr>
-              <a:t>El almacenamiento de logs crece en función de la actividad operativa, no del número de filas.</a:t>
-            </a:r>
-          </a:p>
+              <a:t>SELECT pg_switch_wal(); fuerza el sellado del bloque activo para archivado inmediato sin esperar archive_timeout.</a:t>
+            </a:r>
+          </a:p>
+        </p:txBody>
+      </p:sp>
+      <p:sp>
+        <p:nvSpPr>
+          <p:cNvPr id="8" name="Rounded Rectangle 7"/>
+          <p:cNvSpPr/>
+          <p:nvPr/>
+        </p:nvSpPr>
+        <p:spPr>
+          <a:xfrm>
+            <a:off x="6217920" y="1508760"/>
+            <a:ext cx="5212080" cy="4663440"/>
+          </a:xfrm>
+          <a:prstGeom prst="roundRect">
+            <a:avLst/>
+          </a:prstGeom>
+          <a:solidFill>
+            <a:srgbClr val="1E293B"/>
+          </a:solidFill>
+          <a:ln w="12700">
+            <a:solidFill>
+              <a:srgbClr val="334155"/>
+            </a:solidFill>
+          </a:ln>
+          <a:effectLst/>
+        </p:spPr>
+        <p:style>
+          <a:lnRef idx="1">
+            <a:schemeClr val="accent1"/>
+          </a:lnRef>
+          <a:fillRef idx="3">
+            <a:schemeClr val="accent1"/>
+          </a:fillRef>
+          <a:effectRef idx="2">
+            <a:schemeClr val="accent1"/>
+          </a:effectRef>
+          <a:fontRef idx="minor">
+            <a:schemeClr val="lt1"/>
+          </a:fontRef>
+        </p:style>
+        <p:txBody>
+          <a:bodyPr rtlCol="0" anchor="ctr"/>
+          <a:lstStyle/>
+          <a:p>
+            <a:pPr algn="ctr"/>
+          </a:p>
+        </p:txBody>
+      </p:sp>
+      <p:sp>
+        <p:nvSpPr>
+          <p:cNvPr id="9" name="TextBox 8"/>
+          <p:cNvSpPr txBox="1"/>
+          <p:nvPr/>
+        </p:nvSpPr>
+        <p:spPr>
+          <a:xfrm>
+            <a:off x="6446520" y="1673352"/>
+            <a:ext cx="4754880" cy="411480"/>
+          </a:xfrm>
+          <a:prstGeom prst="rect">
+            <a:avLst/>
+          </a:prstGeom>
+          <a:noFill/>
+        </p:spPr>
+        <p:txBody>
+          <a:bodyPr wrap="square">
+            <a:spAutoFit/>
+          </a:bodyPr>
+          <a:lstStyle/>
+          <a:p>
+            <a:pPr>
+              <a:defRPr sz="1400" b="1">
+                <a:solidFill>
+                  <a:srgbClr val="60A5FA"/>
+                </a:solidFill>
+                <a:latin typeface="Segoe UI"/>
+              </a:defRPr>
+            </a:pPr>
+            <a:r>
+              <a:t>Procedimiento de Restauración (pg_restore)</a:t>
+            </a:r>
+          </a:p>
+        </p:txBody>
+      </p:sp>
+      <p:sp>
+        <p:nvSpPr>
+          <p:cNvPr id="10" name="TextBox 9"/>
+          <p:cNvSpPr txBox="1"/>
+          <p:nvPr/>
+        </p:nvSpPr>
+        <p:spPr>
+          <a:xfrm>
+            <a:off x="6446520" y="2057400"/>
+            <a:ext cx="4754880" cy="3931920"/>
+          </a:xfrm>
+          <a:prstGeom prst="rect">
+            <a:avLst/>
+          </a:prstGeom>
+          <a:noFill/>
+        </p:spPr>
+        <p:txBody>
+          <a:bodyPr wrap="square">
+            <a:spAutoFit/>
+          </a:bodyPr>
+          <a:lstStyle/>
           <a:p>
             <a:pPr>
               <a:spcBef>
@@ -8456,7 +10060,7 @@
                 </a:solidFill>
                 <a:latin typeface="Segoe UI"/>
               </a:rPr>
-              <a:t>Principio Rector: </a:t>
+              <a:t>Comando de Restauración: </a:t>
             </a:r>
             <a:r>
               <a:rPr b="0" sz="1200">
@@ -8465,35 +10069,159 @@
                 </a:solidFill>
                 <a:latin typeface="Segoe UI"/>
               </a:rPr>
-              <a:t>La separación de discos e instancias de log es indispensable para evitar incidentes por disco lleno.</a:t>
-            </a:r>
-          </a:p>
-        </p:txBody>
-      </p:sp>
-      <p:pic>
-        <p:nvPicPr>
-          <p:cNvPr id="8" name="Picture 7" descr="grafico_paradoja_logs.png"/>
-          <p:cNvPicPr>
-            <a:picLocks noChangeAspect="1"/>
-          </p:cNvPicPr>
-          <p:nvPr/>
-        </p:nvPicPr>
-        <p:blipFill>
-          <a:blip r:embed="rId2"/>
-          <a:stretch>
-            <a:fillRect/>
-          </a:stretch>
-        </p:blipFill>
-        <p:spPr>
-          <a:xfrm>
-            <a:off x="6035040" y="1645920"/>
-            <a:ext cx="5394960" cy="3371850"/>
-          </a:xfrm>
-          <a:prstGeom prst="rect">
-            <a:avLst/>
-          </a:prstGeom>
-        </p:spPr>
-      </p:pic>
+              <a:t>pg_restore -U admin_db -d banco_telemetria --clean --if-exists -v &lt;archivo.dump&gt;</a:t>
+            </a:r>
+          </a:p>
+          <a:p>
+            <a:pPr>
+              <a:spcBef>
+                <a:spcPts val="200"/>
+              </a:spcBef>
+              <a:spcAft>
+                <a:spcPts val="700"/>
+              </a:spcAft>
+            </a:pPr>
+            <a:r>
+              <a:rPr b="0" sz="1200">
+                <a:solidFill>
+                  <a:srgbClr val="60A5FA"/>
+                </a:solidFill>
+                <a:latin typeface="Segoe UI"/>
+              </a:rPr>
+              <a:t>•  </a:t>
+            </a:r>
+            <a:r>
+              <a:rPr b="1" sz="1200">
+                <a:solidFill>
+                  <a:srgbClr val="E2E8F0"/>
+                </a:solidFill>
+                <a:latin typeface="Segoe UI"/>
+              </a:rPr>
+              <a:t>Bandera --clean: </a:t>
+            </a:r>
+            <a:r>
+              <a:rPr b="0" sz="1200">
+                <a:solidFill>
+                  <a:srgbClr val="94A3B8"/>
+                </a:solidFill>
+                <a:latin typeface="Segoe UI"/>
+              </a:rPr>
+              <a:t>Emite sentencias DROP sobre tablas existentes antes de recrear las estructuras, evitando conflictos.</a:t>
+            </a:r>
+          </a:p>
+          <a:p>
+            <a:pPr>
+              <a:spcBef>
+                <a:spcPts val="200"/>
+              </a:spcBef>
+              <a:spcAft>
+                <a:spcPts val="700"/>
+              </a:spcAft>
+            </a:pPr>
+            <a:r>
+              <a:rPr b="0" sz="1200">
+                <a:solidFill>
+                  <a:srgbClr val="60A5FA"/>
+                </a:solidFill>
+                <a:latin typeface="Segoe UI"/>
+              </a:rPr>
+              <a:t>•  </a:t>
+            </a:r>
+            <a:r>
+              <a:rPr b="1" sz="1200">
+                <a:solidFill>
+                  <a:srgbClr val="E2E8F0"/>
+                </a:solidFill>
+                <a:latin typeface="Segoe UI"/>
+              </a:rPr>
+              <a:t>Bandera --if-exists: </a:t>
+            </a:r>
+            <a:r>
+              <a:rPr b="0" sz="1200">
+                <a:solidFill>
+                  <a:srgbClr val="94A3B8"/>
+                </a:solidFill>
+                <a:latin typeface="Segoe UI"/>
+              </a:rPr>
+              <a:t>Evita que el proceso aborte con error si un objeto a borrar no existía previamente.</a:t>
+            </a:r>
+          </a:p>
+          <a:p>
+            <a:pPr>
+              <a:spcBef>
+                <a:spcPts val="200"/>
+              </a:spcBef>
+              <a:spcAft>
+                <a:spcPts val="700"/>
+              </a:spcAft>
+            </a:pPr>
+            <a:r>
+              <a:rPr b="0" sz="1200">
+                <a:solidFill>
+                  <a:srgbClr val="60A5FA"/>
+                </a:solidFill>
+                <a:latin typeface="Segoe UI"/>
+              </a:rPr>
+              <a:t>•  </a:t>
+            </a:r>
+            <a:r>
+              <a:rPr b="1" sz="1200">
+                <a:solidFill>
+                  <a:srgbClr val="E2E8F0"/>
+                </a:solidFill>
+                <a:latin typeface="Segoe UI"/>
+              </a:rPr>
+              <a:t>Bandera --no-owner: </a:t>
+            </a:r>
+            <a:r>
+              <a:rPr b="0" sz="1200">
+                <a:solidFill>
+                  <a:srgbClr val="94A3B8"/>
+                </a:solidFill>
+                <a:latin typeface="Segoe UI"/>
+              </a:rPr>
+              <a:t>Omite comandos de asignación de propiedad original para permitir restaurar entre diferentes usuarios o entornos.</a:t>
+            </a:r>
+          </a:p>
+          <a:p>
+            <a:pPr>
+              <a:spcBef>
+                <a:spcPts val="200"/>
+              </a:spcBef>
+              <a:spcAft>
+                <a:spcPts val="700"/>
+              </a:spcAft>
+            </a:pPr>
+            <a:r>
+              <a:rPr b="0" sz="1200">
+                <a:solidFill>
+                  <a:srgbClr val="60A5FA"/>
+                </a:solidFill>
+                <a:latin typeface="Segoe UI"/>
+              </a:rPr>
+              <a:t>•  </a:t>
+            </a:r>
+            <a:r>
+              <a:rPr b="1" sz="1200">
+                <a:solidFill>
+                  <a:srgbClr val="E2E8F0"/>
+                </a:solidFill>
+                <a:latin typeface="Segoe UI"/>
+              </a:rPr>
+              <a:t>Consistencia Transaccional: </a:t>
+            </a:r>
+            <a:r>
+              <a:rPr b="0" sz="1200">
+                <a:solidFill>
+                  <a:srgbClr val="94A3B8"/>
+                </a:solidFill>
+                <a:latin typeface="Segoe UI"/>
+              </a:rPr>
+              <a:t>Utiliza transacciones snapshot con nivel REPEATABLE READ para asegurar coherencia sin bloquear operaciones.</a:t>
+            </a:r>
+          </a:p>
+        </p:txBody>
+      </p:sp>
     </p:spTree>
   </p:cSld>
   <p:clrMapOvr>
@@ -8586,7 +10314,7 @@
               </a:defRPr>
             </a:pPr>
             <a:r>
-              <a:t>AFINAMIENTO DE RENDIMIENTO</a:t>
+              <a:t>VALIDACIÓN PRÁCTICA</a:t>
             </a:r>
           </a:p>
         </p:txBody>
@@ -8622,7 +10350,7 @@
               </a:defRPr>
             </a:pPr>
             <a:r>
-              <a:t>Análisis de Planes de Ejecución y Métricas de E/S</a:t>
+              <a:t>Simulación de Pérdida de Datos y Restauración de Contingencia</a:t>
             </a:r>
           </a:p>
         </p:txBody>
@@ -8704,7 +10432,7 @@
               </a:defRPr>
             </a:pPr>
             <a:r>
-              <a:t>Fundamentos de EXPLAIN ANALYZE</a:t>
+              <a:t>Procedimiento de la Prueba</a:t>
             </a:r>
           </a:p>
         </p:txBody>
@@ -8755,7 +10483,7 @@
                 </a:solidFill>
                 <a:latin typeface="Segoe UI"/>
               </a:rPr>
-              <a:t>Tiempo de Ejecución: </a:t>
+              <a:t>Fase 1 (Respaldo Base): </a:t>
             </a:r>
             <a:r>
               <a:rPr b="0" sz="1200">
@@ -8764,7 +10492,7 @@
                 </a:solidFill>
                 <a:latin typeface="Segoe UI"/>
               </a:rPr>
-              <a:t>Medición cronométrica real del procesamiento interno en el motor de la base de datos.</a:t>
+              <a:t>Generación de dump binario comprimido de 13 MB mediante pg_dump en 3.9 segundos.</a:t>
             </a:r>
           </a:p>
           <a:p>
@@ -8792,7 +10520,7 @@
                 </a:solidFill>
                 <a:latin typeface="Segoe UI"/>
               </a:rPr>
-              <a:t>Buffers (Hit vs Read): </a:t>
+              <a:t>Fase 2 (Transacción Crítica): </a:t>
             </a:r>
             <a:r>
               <a:rPr b="0" sz="1200">
@@ -8801,7 +10529,7 @@
                 </a:solidFill>
                 <a:latin typeface="Segoe UI"/>
               </a:rPr>
-              <a:t>Hit indica lectura directa en memoria RAM; Read representa lectura física de disco (cuello de botella de E/S).</a:t>
+              <a:t>Registro de movimientos financieros de última hora posteriores al backup base.</a:t>
             </a:r>
           </a:p>
           <a:p>
@@ -8829,7 +10557,7 @@
                 </a:solidFill>
                 <a:latin typeface="Segoe UI"/>
               </a:rPr>
-              <a:t>Sequential Scan (Seq Scan): </a:t>
+              <a:t>Fase 3 (Desastre Simulado): </a:t>
             </a:r>
             <a:r>
               <a:rPr b="0" sz="1200">
@@ -8838,7 +10566,7 @@
                 </a:solidFill>
                 <a:latin typeface="Segoe UI"/>
               </a:rPr>
-              <a:t>Recorrido exhaustivo de cada página de la tabla. Ineficiente para búsquedas selectivas sobre grandes volúmenes.</a:t>
+              <a:t>Ejecución de sentencia destructiva accidental: DROP TABLE transacciones, cuentas, clientes CASCADE.</a:t>
             </a:r>
           </a:p>
           <a:p>
@@ -8866,7 +10594,7 @@
                 </a:solidFill>
                 <a:latin typeface="Segoe UI"/>
               </a:rPr>
-              <a:t>Index Scan: </a:t>
+              <a:t>Fase 4 (Verificación de Pérdida): </a:t>
             </a:r>
             <a:r>
               <a:rPr b="0" sz="1200">
@@ -8875,7 +10603,44 @@
                 </a:solidFill>
                 <a:latin typeface="Segoe UI"/>
               </a:rPr>
-              <a:t>Acceso selectivo mediante estructuras balanceadas B-Tree con complejidad logarítmica O(log N).</a:t>
+              <a:t>Consulta de catálogo donde se constata la indisponibilidad total de la información.</a:t>
+            </a:r>
+          </a:p>
+          <a:p>
+            <a:pPr>
+              <a:spcBef>
+                <a:spcPts val="200"/>
+              </a:spcBef>
+              <a:spcAft>
+                <a:spcPts val="700"/>
+              </a:spcAft>
+            </a:pPr>
+            <a:r>
+              <a:rPr b="0" sz="1200">
+                <a:solidFill>
+                  <a:srgbClr val="60A5FA"/>
+                </a:solidFill>
+                <a:latin typeface="Segoe UI"/>
+              </a:rPr>
+              <a:t>•  </a:t>
+            </a:r>
+            <a:r>
+              <a:rPr b="1" sz="1200">
+                <a:solidFill>
+                  <a:srgbClr val="E2E8F0"/>
+                </a:solidFill>
+                <a:latin typeface="Segoe UI"/>
+              </a:rPr>
+              <a:t>Fase 5 (Restauración Exitosa): </a:t>
+            </a:r>
+            <a:r>
+              <a:rPr b="0" sz="1200">
+                <a:solidFill>
+                  <a:srgbClr val="94A3B8"/>
+                </a:solidFill>
+                <a:latin typeface="Segoe UI"/>
+              </a:rPr>
+              <a:t>Ejecución de procedimiento de contingencia recuperando las 600,000 filas en 5 segundos.</a:t>
             </a:r>
           </a:p>
         </p:txBody>
@@ -8957,7 +10722,7 @@
               </a:defRPr>
             </a:pPr>
             <a:r>
-              <a:t>Técnicas de Indexación Aplicadas</a:t>
+              <a:t>Mecanismo Point-In-Time Recovery (PITR)</a:t>
             </a:r>
           </a:p>
         </p:txBody>
@@ -9008,7 +10773,7 @@
                 </a:solidFill>
                 <a:latin typeface="Segoe UI"/>
               </a:rPr>
-              <a:t>Índice B-Tree Único: </a:t>
+              <a:t>Recuperación a Punto Específico: </a:t>
             </a:r>
             <a:r>
               <a:rPr b="0" sz="1200">
@@ -9017,7 +10782,7 @@
                 </a:solidFill>
                 <a:latin typeface="Segoe UI"/>
               </a:rPr>
-              <a:t>Búsqueda directa por documento de identidad; evita el escaneo de 100,000 filas.</a:t>
+              <a:t>Combina el último Backup Total con el 'replay' secuencial de los segmentos WAL archivados.</a:t>
             </a:r>
           </a:p>
           <a:p>
@@ -9045,7 +10810,7 @@
                 </a:solidFill>
                 <a:latin typeface="Segoe UI"/>
               </a:rPr>
-              <a:t>Índice Compuesto Multicolumna: </a:t>
+              <a:t>recovery_target_time: </a:t>
             </a:r>
             <a:r>
               <a:rPr b="0" sz="1200">
@@ -9054,7 +10819,7 @@
                 </a:solidFill>
                 <a:latin typeface="Segoe UI"/>
               </a:rPr>
-              <a:t>Indexación simultánea de cuenta y fecha; elimina la necesidad de ordenamiento en memoria (Sort).</a:t>
+              <a:t>Parámetro que permite detener la reproducción de logs en la hora exacta previa al error humano.</a:t>
             </a:r>
           </a:p>
           <a:p>
@@ -9082,7 +10847,7 @@
                 </a:solidFill>
                 <a:latin typeface="Segoe UI"/>
               </a:rPr>
-              <a:t>Índice Basado en Expresiones: </a:t>
+              <a:t>recovery_target_lsn: </a:t>
             </a:r>
             <a:r>
               <a:rPr b="0" sz="1200">
@@ -9091,7 +10856,7 @@
                 </a:solidFill>
                 <a:latin typeface="Segoe UI"/>
               </a:rPr>
-              <a:t>Creación sobre funciones de transformación (ej. LOWER); neutraliza anti-patrones en el WHERE.</a:t>
+              <a:t>Detención en una posición de bytes exacta de LSN para máxima precisión forense.</a:t>
             </a:r>
           </a:p>
           <a:p>
@@ -9119,7 +10884,7 @@
                 </a:solidFill>
                 <a:latin typeface="Segoe UI"/>
               </a:rPr>
-              <a:t>Auditoría con pg_stat_statements: </a:t>
+              <a:t>Resiliencia Total: </a:t>
             </a:r>
             <a:r>
               <a:rPr b="0" sz="1200">
@@ -9128,7 +10893,7 @@
                 </a:solidFill>
                 <a:latin typeface="Segoe UI"/>
               </a:rPr>
-              <a:t>Inspección acumulada para identificar las 10 consultas más lentas del sistema global.</a:t>
+              <a:t>Garantiza que la empresa no pierda las transacciones del día entre el último backup y el desastre.</a:t>
             </a:r>
           </a:p>
         </p:txBody>
@@ -9225,7 +10990,7 @@
               </a:defRPr>
             </a:pPr>
             <a:r>
-              <a:t>RESULTADOS COMPARATIVOS</a:t>
+              <a:t>OBSERVABILIDAD</a:t>
             </a:r>
           </a:p>
         </p:txBody>
@@ -9261,7 +11026,7 @@
               </a:defRPr>
             </a:pPr>
             <a:r>
-              <a:t>Impacto de la Optimización: De Sequential Scan a Index Scan</a:t>
+              <a:t>Telemetría de Consultas y Almacenamiento Centralizado</a:t>
             </a:r>
           </a:p>
         </p:txBody>
@@ -9275,7 +11040,7 @@
         <p:spPr>
           <a:xfrm>
             <a:off x="731520" y="1508760"/>
-            <a:ext cx="5029200" cy="4663440"/>
+            <a:ext cx="5212080" cy="4663440"/>
           </a:xfrm>
           <a:prstGeom prst="roundRect">
             <a:avLst/>
@@ -9321,7 +11086,7 @@
         <p:spPr>
           <a:xfrm>
             <a:off x="960120" y="1673352"/>
-            <a:ext cx="4572000" cy="411480"/>
+            <a:ext cx="4754880" cy="411480"/>
           </a:xfrm>
           <a:prstGeom prst="rect">
             <a:avLst/>
@@ -9343,7 +11108,7 @@
               </a:defRPr>
             </a:pPr>
             <a:r>
-              <a:t>Métricas de Desempeño</a:t>
+              <a:t>Dimensiones de la Telemetría</a:t>
             </a:r>
           </a:p>
         </p:txBody>
@@ -9357,7 +11122,7 @@
         <p:spPr>
           <a:xfrm>
             <a:off x="960120" y="2057400"/>
-            <a:ext cx="4572000" cy="3931920"/>
+            <a:ext cx="4754880" cy="3931920"/>
           </a:xfrm>
           <a:prstGeom prst="rect">
             <a:avLst/>
@@ -9394,7 +11159,7 @@
                 </a:solidFill>
                 <a:latin typeface="Segoe UI"/>
               </a:rPr>
-              <a:t>Caso 1 (Búsqueda por DNI): </a:t>
+              <a:t>Más allá del Hardware: </a:t>
             </a:r>
             <a:r>
               <a:rPr b="0" sz="1200">
@@ -9403,7 +11168,7 @@
                 </a:solidFill>
                 <a:latin typeface="Segoe UI"/>
               </a:rPr>
-              <a:t>La latencia se redujo de 13.71 ms a 0.12 ms; las lecturas pasaron de 1,301 bloques a solo 4 bloques (mejora &gt;110x).</a:t>
+              <a:t>No se limita al uso de CPU o memoria; audita cada sentencia ejecutada por clientes y aplicaciones.</a:t>
             </a:r>
           </a:p>
           <a:p>
@@ -9431,7 +11196,7 @@
                 </a:solidFill>
                 <a:latin typeface="Segoe UI"/>
               </a:rPr>
-              <a:t>Caso 2 (Cuentas y Fechas): </a:t>
+              <a:t>Throughput (QPS): </a:t>
             </a:r>
             <a:r>
               <a:rPr b="0" sz="1200">
@@ -9440,7 +11205,7 @@
                 </a:solidFill>
                 <a:latin typeface="Segoe UI"/>
               </a:rPr>
-              <a:t>El índice compuesto evitó el Quicksort sobre 400k filas; la latencia se redujo de 391.04 ms a 0.10 ms (mejora &gt;3,900x).</a:t>
+              <a:t>Mide el volumen de operaciones por segundo y detecta picos de demanda inusuales.</a:t>
             </a:r>
           </a:p>
           <a:p>
@@ -9468,7 +11233,7 @@
                 </a:solidFill>
                 <a:latin typeface="Segoe UI"/>
               </a:rPr>
-              <a:t>Caso 3 (Uso de LOWER): </a:t>
+              <a:t>Composición DML: </a:t>
             </a:r>
             <a:r>
               <a:rPr b="0" sz="1200">
@@ -9477,7 +11242,7 @@
                 </a:solidFill>
                 <a:latin typeface="Segoe UI"/>
               </a:rPr>
-              <a:t>El índice funcional resolvió la invalidación del índice estándar, reduciendo el tiempo de 71.17 ms a 0.72 ms (mejora &gt;95x).</a:t>
+              <a:t>Distribución entre consultas de lectura (SELECT) y operaciones de escritura (INSERT, UPDATE).</a:t>
             </a:r>
           </a:p>
           <a:p>
@@ -9505,7 +11270,7 @@
                 </a:solidFill>
                 <a:latin typeface="Segoe UI"/>
               </a:rPr>
-              <a:t>Eficiencia General: </a:t>
+              <a:t>Alertas Tempranas: </a:t>
             </a:r>
             <a:r>
               <a:rPr b="0" sz="1200">
@@ -9514,35 +11279,264 @@
                 </a:solidFill>
                 <a:latin typeface="Segoe UI"/>
               </a:rPr>
-              <a:t>Menor contención de memoria compartida y liberación inmediata de conexiones en el pool.</a:t>
-            </a:r>
-          </a:p>
-        </p:txBody>
-      </p:sp>
-      <p:pic>
-        <p:nvPicPr>
-          <p:cNvPr id="8" name="Picture 7" descr="grafico_optimizacion_benchmark.png"/>
-          <p:cNvPicPr>
-            <a:picLocks noChangeAspect="1"/>
-          </p:cNvPicPr>
-          <p:nvPr/>
-        </p:nvPicPr>
-        <p:blipFill>
-          <a:blip r:embed="rId2"/>
-          <a:stretch>
-            <a:fillRect/>
-          </a:stretch>
-        </p:blipFill>
-        <p:spPr>
-          <a:xfrm>
-            <a:off x="6035040" y="1645920"/>
-            <a:ext cx="5394960" cy="3371850"/>
+              <a:t>Identificación inmediata de bloqueos (locks), transacciones canceladas y rollbacks.</a:t>
+            </a:r>
+          </a:p>
+        </p:txBody>
+      </p:sp>
+      <p:sp>
+        <p:nvSpPr>
+          <p:cNvPr id="8" name="Rounded Rectangle 7"/>
+          <p:cNvSpPr/>
+          <p:nvPr/>
+        </p:nvSpPr>
+        <p:spPr>
+          <a:xfrm>
+            <a:off x="6217920" y="1508760"/>
+            <a:ext cx="5212080" cy="4663440"/>
+          </a:xfrm>
+          <a:prstGeom prst="roundRect">
+            <a:avLst/>
+          </a:prstGeom>
+          <a:solidFill>
+            <a:srgbClr val="1E293B"/>
+          </a:solidFill>
+          <a:ln w="12700">
+            <a:solidFill>
+              <a:srgbClr val="334155"/>
+            </a:solidFill>
+          </a:ln>
+          <a:effectLst/>
+        </p:spPr>
+        <p:style>
+          <a:lnRef idx="1">
+            <a:schemeClr val="accent1"/>
+          </a:lnRef>
+          <a:fillRef idx="3">
+            <a:schemeClr val="accent1"/>
+          </a:fillRef>
+          <a:effectRef idx="2">
+            <a:schemeClr val="accent1"/>
+          </a:effectRef>
+          <a:fontRef idx="minor">
+            <a:schemeClr val="lt1"/>
+          </a:fontRef>
+        </p:style>
+        <p:txBody>
+          <a:bodyPr rtlCol="0" anchor="ctr"/>
+          <a:lstStyle/>
+          <a:p>
+            <a:pPr algn="ctr"/>
+          </a:p>
+        </p:txBody>
+      </p:sp>
+      <p:sp>
+        <p:nvSpPr>
+          <p:cNvPr id="9" name="TextBox 8"/>
+          <p:cNvSpPr txBox="1"/>
+          <p:nvPr/>
+        </p:nvSpPr>
+        <p:spPr>
+          <a:xfrm>
+            <a:off x="6446520" y="1673352"/>
+            <a:ext cx="4754880" cy="411480"/>
           </a:xfrm>
           <a:prstGeom prst="rect">
             <a:avLst/>
           </a:prstGeom>
-        </p:spPr>
-      </p:pic>
+          <a:noFill/>
+        </p:spPr>
+        <p:txBody>
+          <a:bodyPr wrap="square">
+            <a:spAutoFit/>
+          </a:bodyPr>
+          <a:lstStyle/>
+          <a:p>
+            <a:pPr>
+              <a:defRPr sz="1400" b="1">
+                <a:solidFill>
+                  <a:srgbClr val="60A5FA"/>
+                </a:solidFill>
+                <a:latin typeface="Segoe UI"/>
+              </a:defRPr>
+            </a:pPr>
+            <a:r>
+              <a:t>Eficiencia de Grafana Loki</a:t>
+            </a:r>
+          </a:p>
+        </p:txBody>
+      </p:sp>
+      <p:sp>
+        <p:nvSpPr>
+          <p:cNvPr id="10" name="TextBox 9"/>
+          <p:cNvSpPr txBox="1"/>
+          <p:nvPr/>
+        </p:nvSpPr>
+        <p:spPr>
+          <a:xfrm>
+            <a:off x="6446520" y="2057400"/>
+            <a:ext cx="4754880" cy="3931920"/>
+          </a:xfrm>
+          <a:prstGeom prst="rect">
+            <a:avLst/>
+          </a:prstGeom>
+          <a:noFill/>
+        </p:spPr>
+        <p:txBody>
+          <a:bodyPr wrap="square">
+            <a:spAutoFit/>
+          </a:bodyPr>
+          <a:lstStyle/>
+          <a:p>
+            <a:pPr>
+              <a:spcBef>
+                <a:spcPts val="200"/>
+              </a:spcBef>
+              <a:spcAft>
+                <a:spcPts val="700"/>
+              </a:spcAft>
+            </a:pPr>
+            <a:r>
+              <a:rPr b="0" sz="1200">
+                <a:solidFill>
+                  <a:srgbClr val="60A5FA"/>
+                </a:solidFill>
+                <a:latin typeface="Segoe UI"/>
+              </a:rPr>
+              <a:t>•  </a:t>
+            </a:r>
+            <a:r>
+              <a:rPr b="1" sz="1200">
+                <a:solidFill>
+                  <a:srgbClr val="E2E8F0"/>
+                </a:solidFill>
+                <a:latin typeface="Segoe UI"/>
+              </a:rPr>
+              <a:t>Indexación por Metadatos: </a:t>
+            </a:r>
+            <a:r>
+              <a:rPr b="0" sz="1200">
+                <a:solidFill>
+                  <a:srgbClr val="94A3B8"/>
+                </a:solidFill>
+                <a:latin typeface="Segoe UI"/>
+              </a:rPr>
+              <a:t>A diferencia de motores convencionales, Loki solo indexa etiquetas; reduce el consumo de RAM hasta un 90%.</a:t>
+            </a:r>
+          </a:p>
+          <a:p>
+            <a:pPr>
+              <a:spcBef>
+                <a:spcPts val="200"/>
+              </a:spcBef>
+              <a:spcAft>
+                <a:spcPts val="700"/>
+              </a:spcAft>
+            </a:pPr>
+            <a:r>
+              <a:rPr b="0" sz="1200">
+                <a:solidFill>
+                  <a:srgbClr val="60A5FA"/>
+                </a:solidFill>
+                <a:latin typeface="Segoe UI"/>
+              </a:rPr>
+              <a:t>•  </a:t>
+            </a:r>
+            <a:r>
+              <a:rPr b="1" sz="1200">
+                <a:solidFill>
+                  <a:srgbClr val="E2E8F0"/>
+                </a:solidFill>
+                <a:latin typeface="Segoe UI"/>
+              </a:rPr>
+              <a:t>Consumo No Invasivo: </a:t>
+            </a:r>
+            <a:r>
+              <a:rPr b="0" sz="1200">
+                <a:solidFill>
+                  <a:srgbClr val="94A3B8"/>
+                </a:solidFill>
+                <a:latin typeface="Segoe UI"/>
+              </a:rPr>
+              <a:t>Promtail recopila logs en streaming sin abrir bloqueos de tabla ni interferir en sesiones activas.</a:t>
+            </a:r>
+          </a:p>
+          <a:p>
+            <a:pPr>
+              <a:spcBef>
+                <a:spcPts val="200"/>
+              </a:spcBef>
+              <a:spcAft>
+                <a:spcPts val="700"/>
+              </a:spcAft>
+            </a:pPr>
+            <a:r>
+              <a:rPr b="0" sz="1200">
+                <a:solidFill>
+                  <a:srgbClr val="60A5FA"/>
+                </a:solidFill>
+                <a:latin typeface="Segoe UI"/>
+              </a:rPr>
+              <a:t>•  </a:t>
+            </a:r>
+            <a:r>
+              <a:rPr b="1" sz="1200">
+                <a:solidFill>
+                  <a:srgbClr val="E2E8F0"/>
+                </a:solidFill>
+                <a:latin typeface="Segoe UI"/>
+              </a:rPr>
+              <a:t>Visibilidad Central: </a:t>
+            </a:r>
+            <a:r>
+              <a:rPr b="0" sz="1200">
+                <a:solidFill>
+                  <a:srgbClr val="94A3B8"/>
+                </a:solidFill>
+                <a:latin typeface="Segoe UI"/>
+              </a:rPr>
+              <a:t>Dashboards dinámicos permiten correlacionar latencias de consultas con eventos del motor.</a:t>
+            </a:r>
+          </a:p>
+          <a:p>
+            <a:pPr>
+              <a:spcBef>
+                <a:spcPts val="200"/>
+              </a:spcBef>
+              <a:spcAft>
+                <a:spcPts val="700"/>
+              </a:spcAft>
+            </a:pPr>
+            <a:r>
+              <a:rPr b="0" sz="1200">
+                <a:solidFill>
+                  <a:srgbClr val="60A5FA"/>
+                </a:solidFill>
+                <a:latin typeface="Segoe UI"/>
+              </a:rPr>
+              <a:t>•  </a:t>
+            </a:r>
+            <a:r>
+              <a:rPr b="1" sz="1200">
+                <a:solidFill>
+                  <a:srgbClr val="E2E8F0"/>
+                </a:solidFill>
+                <a:latin typeface="Segoe UI"/>
+              </a:rPr>
+              <a:t>Retención Independiente: </a:t>
+            </a:r>
+            <a:r>
+              <a:rPr b="0" sz="1200">
+                <a:solidFill>
+                  <a:srgbClr val="94A3B8"/>
+                </a:solidFill>
+                <a:latin typeface="Segoe UI"/>
+              </a:rPr>
+              <a:t>Políticas de archivado de logs sin comprometer el ciclo de vida de los datos transaccionales.</a:t>
+            </a:r>
+          </a:p>
+        </p:txBody>
+      </p:sp>
     </p:spTree>
   </p:cSld>
   <p:clrMapOvr>

</xml_diff>

<commit_message>
feat(backup): update Flujo 3 to 10k synthetic insert and add Slide B6 covering enterprise backup ecosystem (pg_basebackup, pgBackRest, Barman, WAL-G)
</commit_message>
<xml_diff>
--- a/presentacion/Presentacion_Telemetria_Optimizacion.pptx
+++ b/presentacion/Presentacion_Telemetria_Optimizacion.pptx
@@ -19,6 +19,7 @@
     <p:sldId id="267" r:id="rId18"/>
     <p:sldId id="268" r:id="rId19"/>
     <p:sldId id="269" r:id="rId20"/>
+    <p:sldId id="270" r:id="rId21"/>
   </p:sldIdLst>
   <p:sldSz cx="12191695" cy="6858000" type="screen4x3"/>
   <p:notesSz cx="6858000" cy="9144000"/>
@@ -3756,7 +3757,7 @@
               </a:defRPr>
             </a:pPr>
             <a:r>
-              <a:t>DIAGNÓSTICO EXPERIMENTAL</a:t>
+              <a:t>OBSERVABILIDAD</a:t>
             </a:r>
           </a:p>
         </p:txBody>
@@ -3792,7 +3793,7 @@
               </a:defRPr>
             </a:pPr>
             <a:r>
-              <a:t>Comportamiento del Almacenamiento: Datos vs Logs Transaccionales</a:t>
+              <a:t>Telemetría de Consultas y Almacenamiento Centralizado</a:t>
             </a:r>
           </a:p>
         </p:txBody>
@@ -3806,7 +3807,7 @@
         <p:spPr>
           <a:xfrm>
             <a:off x="731520" y="1508760"/>
-            <a:ext cx="5029200" cy="4663440"/>
+            <a:ext cx="5212080" cy="4663440"/>
           </a:xfrm>
           <a:prstGeom prst="roundRect">
             <a:avLst/>
@@ -3852,7 +3853,7 @@
         <p:spPr>
           <a:xfrm>
             <a:off x="960120" y="1673352"/>
-            <a:ext cx="4572000" cy="411480"/>
+            <a:ext cx="4754880" cy="411480"/>
           </a:xfrm>
           <a:prstGeom prst="rect">
             <a:avLst/>
@@ -3874,7 +3875,7 @@
               </a:defRPr>
             </a:pPr>
             <a:r>
-              <a:t>Hallazgos de la Simulación</a:t>
+              <a:t>Dimensiones de la Telemetría</a:t>
             </a:r>
           </a:p>
         </p:txBody>
@@ -3888,7 +3889,7 @@
         <p:spPr>
           <a:xfrm>
             <a:off x="960120" y="2057400"/>
-            <a:ext cx="4572000" cy="3931920"/>
+            <a:ext cx="4754880" cy="3931920"/>
           </a:xfrm>
           <a:prstGeom prst="rect">
             <a:avLst/>
@@ -3925,7 +3926,7 @@
                 </a:solidFill>
                 <a:latin typeface="Segoe UI"/>
               </a:rPr>
-              <a:t>Condición de Prueba: </a:t>
+              <a:t>Más allá del Hardware: </a:t>
             </a:r>
             <a:r>
               <a:rPr b="0" sz="1200">
@@ -3934,7 +3935,7 @@
                 </a:solidFill>
                 <a:latin typeface="Segoe UI"/>
               </a:rPr>
-              <a:t>Ejecución continua de 500 sentencias UPDATE consecutivas sobre una única fila de saldo.</a:t>
+              <a:t>No se limita al uso de CPU o memoria; audita cada sentencia ejecutada por clientes y aplicaciones.</a:t>
             </a:r>
           </a:p>
           <a:p>
@@ -3962,7 +3963,7 @@
                 </a:solidFill>
                 <a:latin typeface="Segoe UI"/>
               </a:rPr>
-              <a:t>Resultado en Tablas: </a:t>
+              <a:t>Throughput (QPS): </a:t>
             </a:r>
             <a:r>
               <a:rPr b="0" sz="1200">
@@ -3971,7 +3972,7 @@
                 </a:solidFill>
                 <a:latin typeface="Segoe UI"/>
               </a:rPr>
-              <a:t>El tamaño físico de la tabla en disco se mantiene invariable (~12.1 MB).</a:t>
+              <a:t>Mide el volumen de operaciones por segundo y detecta picos de demanda inusuales.</a:t>
             </a:r>
           </a:p>
           <a:p>
@@ -3999,7 +4000,7 @@
                 </a:solidFill>
                 <a:latin typeface="Segoe UI"/>
               </a:rPr>
-              <a:t>Resultado en Logs: </a:t>
+              <a:t>Composición DML: </a:t>
             </a:r>
             <a:r>
               <a:rPr b="0" sz="1200">
@@ -4008,7 +4009,7 @@
                 </a:solidFill>
                 <a:latin typeface="Segoe UI"/>
               </a:rPr>
-              <a:t>Se emitieron 500 registros WAL de 16 MB y cientos de entradas de auditoría hacia Loki.</a:t>
+              <a:t>Distribución entre consultas de lectura (SELECT) y operaciones de escritura (INSERT, UPDATE).</a:t>
             </a:r>
           </a:p>
           <a:p>
@@ -4036,7 +4037,7 @@
                 </a:solidFill>
                 <a:latin typeface="Segoe UI"/>
               </a:rPr>
-              <a:t>Conclusión Crítica: </a:t>
+              <a:t>Alertas Tempranas: </a:t>
             </a:r>
             <a:r>
               <a:rPr b="0" sz="1200">
@@ -4045,9 +4046,114 @@
                 </a:solidFill>
                 <a:latin typeface="Segoe UI"/>
               </a:rPr>
-              <a:t>El almacenamiento de logs crece en función de la actividad operativa, no del número de filas.</a:t>
-            </a:r>
-          </a:p>
+              <a:t>Identificación inmediata de bloqueos (locks), transacciones canceladas y rollbacks.</a:t>
+            </a:r>
+          </a:p>
+        </p:txBody>
+      </p:sp>
+      <p:sp>
+        <p:nvSpPr>
+          <p:cNvPr id="8" name="Rounded Rectangle 7"/>
+          <p:cNvSpPr/>
+          <p:nvPr/>
+        </p:nvSpPr>
+        <p:spPr>
+          <a:xfrm>
+            <a:off x="6217920" y="1508760"/>
+            <a:ext cx="5212080" cy="4663440"/>
+          </a:xfrm>
+          <a:prstGeom prst="roundRect">
+            <a:avLst/>
+          </a:prstGeom>
+          <a:solidFill>
+            <a:srgbClr val="1E293B"/>
+          </a:solidFill>
+          <a:ln w="12700">
+            <a:solidFill>
+              <a:srgbClr val="334155"/>
+            </a:solidFill>
+          </a:ln>
+          <a:effectLst/>
+        </p:spPr>
+        <p:style>
+          <a:lnRef idx="1">
+            <a:schemeClr val="accent1"/>
+          </a:lnRef>
+          <a:fillRef idx="3">
+            <a:schemeClr val="accent1"/>
+          </a:fillRef>
+          <a:effectRef idx="2">
+            <a:schemeClr val="accent1"/>
+          </a:effectRef>
+          <a:fontRef idx="minor">
+            <a:schemeClr val="lt1"/>
+          </a:fontRef>
+        </p:style>
+        <p:txBody>
+          <a:bodyPr rtlCol="0" anchor="ctr"/>
+          <a:lstStyle/>
+          <a:p>
+            <a:pPr algn="ctr"/>
+          </a:p>
+        </p:txBody>
+      </p:sp>
+      <p:sp>
+        <p:nvSpPr>
+          <p:cNvPr id="9" name="TextBox 8"/>
+          <p:cNvSpPr txBox="1"/>
+          <p:nvPr/>
+        </p:nvSpPr>
+        <p:spPr>
+          <a:xfrm>
+            <a:off x="6446520" y="1673352"/>
+            <a:ext cx="4754880" cy="411480"/>
+          </a:xfrm>
+          <a:prstGeom prst="rect">
+            <a:avLst/>
+          </a:prstGeom>
+          <a:noFill/>
+        </p:spPr>
+        <p:txBody>
+          <a:bodyPr wrap="square">
+            <a:spAutoFit/>
+          </a:bodyPr>
+          <a:lstStyle/>
+          <a:p>
+            <a:pPr>
+              <a:defRPr sz="1400" b="1">
+                <a:solidFill>
+                  <a:srgbClr val="60A5FA"/>
+                </a:solidFill>
+                <a:latin typeface="Segoe UI"/>
+              </a:defRPr>
+            </a:pPr>
+            <a:r>
+              <a:t>Eficiencia de Grafana Loki</a:t>
+            </a:r>
+          </a:p>
+        </p:txBody>
+      </p:sp>
+      <p:sp>
+        <p:nvSpPr>
+          <p:cNvPr id="10" name="TextBox 9"/>
+          <p:cNvSpPr txBox="1"/>
+          <p:nvPr/>
+        </p:nvSpPr>
+        <p:spPr>
+          <a:xfrm>
+            <a:off x="6446520" y="2057400"/>
+            <a:ext cx="4754880" cy="3931920"/>
+          </a:xfrm>
+          <a:prstGeom prst="rect">
+            <a:avLst/>
+          </a:prstGeom>
+          <a:noFill/>
+        </p:spPr>
+        <p:txBody>
+          <a:bodyPr wrap="square">
+            <a:spAutoFit/>
+          </a:bodyPr>
+          <a:lstStyle/>
           <a:p>
             <a:pPr>
               <a:spcBef>
@@ -4073,7 +4179,7 @@
                 </a:solidFill>
                 <a:latin typeface="Segoe UI"/>
               </a:rPr>
-              <a:t>Principio Rector: </a:t>
+              <a:t>Indexación por Metadatos: </a:t>
             </a:r>
             <a:r>
               <a:rPr b="0" sz="1200">
@@ -4082,35 +4188,122 @@
                 </a:solidFill>
                 <a:latin typeface="Segoe UI"/>
               </a:rPr>
-              <a:t>La separación de discos e instancias de log es indispensable para evitar incidentes por disco lleno.</a:t>
-            </a:r>
-          </a:p>
-        </p:txBody>
-      </p:sp>
-      <p:pic>
-        <p:nvPicPr>
-          <p:cNvPr id="8" name="Picture 7" descr="grafico_paradoja_logs.png"/>
-          <p:cNvPicPr>
-            <a:picLocks noChangeAspect="1"/>
-          </p:cNvPicPr>
-          <p:nvPr/>
-        </p:nvPicPr>
-        <p:blipFill>
-          <a:blip r:embed="rId2"/>
-          <a:stretch>
-            <a:fillRect/>
-          </a:stretch>
-        </p:blipFill>
-        <p:spPr>
-          <a:xfrm>
-            <a:off x="6035040" y="1645920"/>
-            <a:ext cx="5394960" cy="3371850"/>
-          </a:xfrm>
-          <a:prstGeom prst="rect">
-            <a:avLst/>
-          </a:prstGeom>
-        </p:spPr>
-      </p:pic>
+              <a:t>A diferencia de motores convencionales, Loki solo indexa etiquetas; reduce el consumo de RAM hasta un 90%.</a:t>
+            </a:r>
+          </a:p>
+          <a:p>
+            <a:pPr>
+              <a:spcBef>
+                <a:spcPts val="200"/>
+              </a:spcBef>
+              <a:spcAft>
+                <a:spcPts val="700"/>
+              </a:spcAft>
+            </a:pPr>
+            <a:r>
+              <a:rPr b="0" sz="1200">
+                <a:solidFill>
+                  <a:srgbClr val="60A5FA"/>
+                </a:solidFill>
+                <a:latin typeface="Segoe UI"/>
+              </a:rPr>
+              <a:t>•  </a:t>
+            </a:r>
+            <a:r>
+              <a:rPr b="1" sz="1200">
+                <a:solidFill>
+                  <a:srgbClr val="E2E8F0"/>
+                </a:solidFill>
+                <a:latin typeface="Segoe UI"/>
+              </a:rPr>
+              <a:t>Consumo No Invasivo: </a:t>
+            </a:r>
+            <a:r>
+              <a:rPr b="0" sz="1200">
+                <a:solidFill>
+                  <a:srgbClr val="94A3B8"/>
+                </a:solidFill>
+                <a:latin typeface="Segoe UI"/>
+              </a:rPr>
+              <a:t>Promtail recopila logs en streaming sin abrir bloqueos de tabla ni interferir en sesiones activas.</a:t>
+            </a:r>
+          </a:p>
+          <a:p>
+            <a:pPr>
+              <a:spcBef>
+                <a:spcPts val="200"/>
+              </a:spcBef>
+              <a:spcAft>
+                <a:spcPts val="700"/>
+              </a:spcAft>
+            </a:pPr>
+            <a:r>
+              <a:rPr b="0" sz="1200">
+                <a:solidFill>
+                  <a:srgbClr val="60A5FA"/>
+                </a:solidFill>
+                <a:latin typeface="Segoe UI"/>
+              </a:rPr>
+              <a:t>•  </a:t>
+            </a:r>
+            <a:r>
+              <a:rPr b="1" sz="1200">
+                <a:solidFill>
+                  <a:srgbClr val="E2E8F0"/>
+                </a:solidFill>
+                <a:latin typeface="Segoe UI"/>
+              </a:rPr>
+              <a:t>Visibilidad Central: </a:t>
+            </a:r>
+            <a:r>
+              <a:rPr b="0" sz="1200">
+                <a:solidFill>
+                  <a:srgbClr val="94A3B8"/>
+                </a:solidFill>
+                <a:latin typeface="Segoe UI"/>
+              </a:rPr>
+              <a:t>Dashboards dinámicos permiten correlacionar latencias de consultas con eventos del motor.</a:t>
+            </a:r>
+          </a:p>
+          <a:p>
+            <a:pPr>
+              <a:spcBef>
+                <a:spcPts val="200"/>
+              </a:spcBef>
+              <a:spcAft>
+                <a:spcPts val="700"/>
+              </a:spcAft>
+            </a:pPr>
+            <a:r>
+              <a:rPr b="0" sz="1200">
+                <a:solidFill>
+                  <a:srgbClr val="60A5FA"/>
+                </a:solidFill>
+                <a:latin typeface="Segoe UI"/>
+              </a:rPr>
+              <a:t>•  </a:t>
+            </a:r>
+            <a:r>
+              <a:rPr b="1" sz="1200">
+                <a:solidFill>
+                  <a:srgbClr val="E2E8F0"/>
+                </a:solidFill>
+                <a:latin typeface="Segoe UI"/>
+              </a:rPr>
+              <a:t>Retención Independiente: </a:t>
+            </a:r>
+            <a:r>
+              <a:rPr b="0" sz="1200">
+                <a:solidFill>
+                  <a:srgbClr val="94A3B8"/>
+                </a:solidFill>
+                <a:latin typeface="Segoe UI"/>
+              </a:rPr>
+              <a:t>Políticas de archivado de logs sin comprometer el ciclo de vida de los datos transaccionales.</a:t>
+            </a:r>
+          </a:p>
+        </p:txBody>
+      </p:sp>
     </p:spTree>
   </p:cSld>
   <p:clrMapOvr>
@@ -4203,7 +4396,7 @@
               </a:defRPr>
             </a:pPr>
             <a:r>
-              <a:t>AFINAMIENTO DE RENDIMIENTO</a:t>
+              <a:t>DIAGNÓSTICO EXPERIMENTAL</a:t>
             </a:r>
           </a:p>
         </p:txBody>
@@ -4239,7 +4432,7 @@
               </a:defRPr>
             </a:pPr>
             <a:r>
-              <a:t>Análisis de Planes de Ejecución y Métricas de E/S</a:t>
+              <a:t>Comportamiento del Almacenamiento: Datos vs Logs Transaccionales</a:t>
             </a:r>
           </a:p>
         </p:txBody>
@@ -4253,7 +4446,7 @@
         <p:spPr>
           <a:xfrm>
             <a:off x="731520" y="1508760"/>
-            <a:ext cx="5212080" cy="4663440"/>
+            <a:ext cx="5029200" cy="4663440"/>
           </a:xfrm>
           <a:prstGeom prst="roundRect">
             <a:avLst/>
@@ -4299,7 +4492,7 @@
         <p:spPr>
           <a:xfrm>
             <a:off x="960120" y="1673352"/>
-            <a:ext cx="4754880" cy="411480"/>
+            <a:ext cx="4572000" cy="411480"/>
           </a:xfrm>
           <a:prstGeom prst="rect">
             <a:avLst/>
@@ -4321,7 +4514,7 @@
               </a:defRPr>
             </a:pPr>
             <a:r>
-              <a:t>Fundamentos de EXPLAIN ANALYZE</a:t>
+              <a:t>Hallazgos de la Simulación</a:t>
             </a:r>
           </a:p>
         </p:txBody>
@@ -4335,7 +4528,7 @@
         <p:spPr>
           <a:xfrm>
             <a:off x="960120" y="2057400"/>
-            <a:ext cx="4754880" cy="3931920"/>
+            <a:ext cx="4572000" cy="3931920"/>
           </a:xfrm>
           <a:prstGeom prst="rect">
             <a:avLst/>
@@ -4372,7 +4565,7 @@
                 </a:solidFill>
                 <a:latin typeface="Segoe UI"/>
               </a:rPr>
-              <a:t>Tiempo de Ejecución: </a:t>
+              <a:t>Condición de Prueba: </a:t>
             </a:r>
             <a:r>
               <a:rPr b="0" sz="1200">
@@ -4381,7 +4574,7 @@
                 </a:solidFill>
                 <a:latin typeface="Segoe UI"/>
               </a:rPr>
-              <a:t>Medición cronométrica real del procesamiento interno en el motor de la base de datos.</a:t>
+              <a:t>Ejecución continua de 500 sentencias UPDATE consecutivas sobre una única fila de saldo.</a:t>
             </a:r>
           </a:p>
           <a:p>
@@ -4409,7 +4602,7 @@
                 </a:solidFill>
                 <a:latin typeface="Segoe UI"/>
               </a:rPr>
-              <a:t>Buffers (Hit vs Read): </a:t>
+              <a:t>Resultado en Tablas: </a:t>
             </a:r>
             <a:r>
               <a:rPr b="0" sz="1200">
@@ -4418,7 +4611,7 @@
                 </a:solidFill>
                 <a:latin typeface="Segoe UI"/>
               </a:rPr>
-              <a:t>Hit indica lectura directa en memoria RAM; Read representa lectura física de disco (cuello de botella de E/S).</a:t>
+              <a:t>El tamaño físico de la tabla en disco se mantiene invariable (~12.1 MB).</a:t>
             </a:r>
           </a:p>
           <a:p>
@@ -4446,7 +4639,7 @@
                 </a:solidFill>
                 <a:latin typeface="Segoe UI"/>
               </a:rPr>
-              <a:t>Sequential Scan (Seq Scan): </a:t>
+              <a:t>Resultado en Logs: </a:t>
             </a:r>
             <a:r>
               <a:rPr b="0" sz="1200">
@@ -4455,7 +4648,7 @@
                 </a:solidFill>
                 <a:latin typeface="Segoe UI"/>
               </a:rPr>
-              <a:t>Recorrido exhaustivo de cada página de la tabla. Ineficiente para búsquedas selectivas sobre grandes volúmenes.</a:t>
+              <a:t>Se emitieron 500 registros WAL de 16 MB y cientos de entradas de auditoría hacia Loki.</a:t>
             </a:r>
           </a:p>
           <a:p>
@@ -4483,7 +4676,7 @@
                 </a:solidFill>
                 <a:latin typeface="Segoe UI"/>
               </a:rPr>
-              <a:t>Index Scan: </a:t>
+              <a:t>Conclusión Crítica: </a:t>
             </a:r>
             <a:r>
               <a:rPr b="0" sz="1200">
@@ -4492,114 +4685,9 @@
                 </a:solidFill>
                 <a:latin typeface="Segoe UI"/>
               </a:rPr>
-              <a:t>Acceso selectivo mediante estructuras balanceadas B-Tree con complejidad logarítmica O(log N).</a:t>
-            </a:r>
-          </a:p>
-        </p:txBody>
-      </p:sp>
-      <p:sp>
-        <p:nvSpPr>
-          <p:cNvPr id="8" name="Rounded Rectangle 7"/>
-          <p:cNvSpPr/>
-          <p:nvPr/>
-        </p:nvSpPr>
-        <p:spPr>
-          <a:xfrm>
-            <a:off x="6217920" y="1508760"/>
-            <a:ext cx="5212080" cy="4663440"/>
-          </a:xfrm>
-          <a:prstGeom prst="roundRect">
-            <a:avLst/>
-          </a:prstGeom>
-          <a:solidFill>
-            <a:srgbClr val="1E293B"/>
-          </a:solidFill>
-          <a:ln w="12700">
-            <a:solidFill>
-              <a:srgbClr val="334155"/>
-            </a:solidFill>
-          </a:ln>
-          <a:effectLst/>
-        </p:spPr>
-        <p:style>
-          <a:lnRef idx="1">
-            <a:schemeClr val="accent1"/>
-          </a:lnRef>
-          <a:fillRef idx="3">
-            <a:schemeClr val="accent1"/>
-          </a:fillRef>
-          <a:effectRef idx="2">
-            <a:schemeClr val="accent1"/>
-          </a:effectRef>
-          <a:fontRef idx="minor">
-            <a:schemeClr val="lt1"/>
-          </a:fontRef>
-        </p:style>
-        <p:txBody>
-          <a:bodyPr rtlCol="0" anchor="ctr"/>
-          <a:lstStyle/>
-          <a:p>
-            <a:pPr algn="ctr"/>
-          </a:p>
-        </p:txBody>
-      </p:sp>
-      <p:sp>
-        <p:nvSpPr>
-          <p:cNvPr id="9" name="TextBox 8"/>
-          <p:cNvSpPr txBox="1"/>
-          <p:nvPr/>
-        </p:nvSpPr>
-        <p:spPr>
-          <a:xfrm>
-            <a:off x="6446520" y="1673352"/>
-            <a:ext cx="4754880" cy="411480"/>
-          </a:xfrm>
-          <a:prstGeom prst="rect">
-            <a:avLst/>
-          </a:prstGeom>
-          <a:noFill/>
-        </p:spPr>
-        <p:txBody>
-          <a:bodyPr wrap="square">
-            <a:spAutoFit/>
-          </a:bodyPr>
-          <a:lstStyle/>
-          <a:p>
-            <a:pPr>
-              <a:defRPr sz="1400" b="1">
-                <a:solidFill>
-                  <a:srgbClr val="60A5FA"/>
-                </a:solidFill>
-                <a:latin typeface="Segoe UI"/>
-              </a:defRPr>
-            </a:pPr>
-            <a:r>
-              <a:t>Técnicas de Indexación Aplicadas</a:t>
-            </a:r>
-          </a:p>
-        </p:txBody>
-      </p:sp>
-      <p:sp>
-        <p:nvSpPr>
-          <p:cNvPr id="10" name="TextBox 9"/>
-          <p:cNvSpPr txBox="1"/>
-          <p:nvPr/>
-        </p:nvSpPr>
-        <p:spPr>
-          <a:xfrm>
-            <a:off x="6446520" y="2057400"/>
-            <a:ext cx="4754880" cy="3931920"/>
-          </a:xfrm>
-          <a:prstGeom prst="rect">
-            <a:avLst/>
-          </a:prstGeom>
-          <a:noFill/>
-        </p:spPr>
-        <p:txBody>
-          <a:bodyPr wrap="square">
-            <a:spAutoFit/>
-          </a:bodyPr>
-          <a:lstStyle/>
+              <a:t>El almacenamiento de logs crece en función de la actividad operativa, no del número de filas.</a:t>
+            </a:r>
+          </a:p>
           <a:p>
             <a:pPr>
               <a:spcBef>
@@ -4625,7 +4713,7 @@
                 </a:solidFill>
                 <a:latin typeface="Segoe UI"/>
               </a:rPr>
-              <a:t>Índice B-Tree Único: </a:t>
+              <a:t>Principio Rector: </a:t>
             </a:r>
             <a:r>
               <a:rPr b="0" sz="1200">
@@ -4634,122 +4722,35 @@
                 </a:solidFill>
                 <a:latin typeface="Segoe UI"/>
               </a:rPr>
-              <a:t>Búsqueda directa por documento de identidad; evita el escaneo de 100,000 filas.</a:t>
-            </a:r>
-          </a:p>
-          <a:p>
-            <a:pPr>
-              <a:spcBef>
-                <a:spcPts val="200"/>
-              </a:spcBef>
-              <a:spcAft>
-                <a:spcPts val="700"/>
-              </a:spcAft>
-            </a:pPr>
-            <a:r>
-              <a:rPr b="0" sz="1200">
-                <a:solidFill>
-                  <a:srgbClr val="60A5FA"/>
-                </a:solidFill>
-                <a:latin typeface="Segoe UI"/>
-              </a:rPr>
-              <a:t>•  </a:t>
-            </a:r>
-            <a:r>
-              <a:rPr b="1" sz="1200">
-                <a:solidFill>
-                  <a:srgbClr val="E2E8F0"/>
-                </a:solidFill>
-                <a:latin typeface="Segoe UI"/>
-              </a:rPr>
-              <a:t>Índice Compuesto Multicolumna: </a:t>
-            </a:r>
-            <a:r>
-              <a:rPr b="0" sz="1200">
-                <a:solidFill>
-                  <a:srgbClr val="94A3B8"/>
-                </a:solidFill>
-                <a:latin typeface="Segoe UI"/>
-              </a:rPr>
-              <a:t>Indexación simultánea de cuenta y fecha; elimina la necesidad de ordenamiento en memoria (Sort).</a:t>
-            </a:r>
-          </a:p>
-          <a:p>
-            <a:pPr>
-              <a:spcBef>
-                <a:spcPts val="200"/>
-              </a:spcBef>
-              <a:spcAft>
-                <a:spcPts val="700"/>
-              </a:spcAft>
-            </a:pPr>
-            <a:r>
-              <a:rPr b="0" sz="1200">
-                <a:solidFill>
-                  <a:srgbClr val="60A5FA"/>
-                </a:solidFill>
-                <a:latin typeface="Segoe UI"/>
-              </a:rPr>
-              <a:t>•  </a:t>
-            </a:r>
-            <a:r>
-              <a:rPr b="1" sz="1200">
-                <a:solidFill>
-                  <a:srgbClr val="E2E8F0"/>
-                </a:solidFill>
-                <a:latin typeface="Segoe UI"/>
-              </a:rPr>
-              <a:t>Índice Basado en Expresiones: </a:t>
-            </a:r>
-            <a:r>
-              <a:rPr b="0" sz="1200">
-                <a:solidFill>
-                  <a:srgbClr val="94A3B8"/>
-                </a:solidFill>
-                <a:latin typeface="Segoe UI"/>
-              </a:rPr>
-              <a:t>Creación sobre funciones de transformación (ej. LOWER); neutraliza anti-patrones en el WHERE.</a:t>
-            </a:r>
-          </a:p>
-          <a:p>
-            <a:pPr>
-              <a:spcBef>
-                <a:spcPts val="200"/>
-              </a:spcBef>
-              <a:spcAft>
-                <a:spcPts val="700"/>
-              </a:spcAft>
-            </a:pPr>
-            <a:r>
-              <a:rPr b="0" sz="1200">
-                <a:solidFill>
-                  <a:srgbClr val="60A5FA"/>
-                </a:solidFill>
-                <a:latin typeface="Segoe UI"/>
-              </a:rPr>
-              <a:t>•  </a:t>
-            </a:r>
-            <a:r>
-              <a:rPr b="1" sz="1200">
-                <a:solidFill>
-                  <a:srgbClr val="E2E8F0"/>
-                </a:solidFill>
-                <a:latin typeface="Segoe UI"/>
-              </a:rPr>
-              <a:t>Auditoría con pg_stat_statements: </a:t>
-            </a:r>
-            <a:r>
-              <a:rPr b="0" sz="1200">
-                <a:solidFill>
-                  <a:srgbClr val="94A3B8"/>
-                </a:solidFill>
-                <a:latin typeface="Segoe UI"/>
-              </a:rPr>
-              <a:t>Inspección acumulada para identificar las 10 consultas más lentas del sistema global.</a:t>
-            </a:r>
-          </a:p>
-        </p:txBody>
-      </p:sp>
+              <a:t>La separación de discos e instancias de log es indispensable para evitar incidentes por disco lleno.</a:t>
+            </a:r>
+          </a:p>
+        </p:txBody>
+      </p:sp>
+      <p:pic>
+        <p:nvPicPr>
+          <p:cNvPr id="8" name="Picture 7" descr="grafico_paradoja_logs.png"/>
+          <p:cNvPicPr>
+            <a:picLocks noChangeAspect="1"/>
+          </p:cNvPicPr>
+          <p:nvPr/>
+        </p:nvPicPr>
+        <p:blipFill>
+          <a:blip r:embed="rId2"/>
+          <a:stretch>
+            <a:fillRect/>
+          </a:stretch>
+        </p:blipFill>
+        <p:spPr>
+          <a:xfrm>
+            <a:off x="6035040" y="1645920"/>
+            <a:ext cx="5394960" cy="3371850"/>
+          </a:xfrm>
+          <a:prstGeom prst="rect">
+            <a:avLst/>
+          </a:prstGeom>
+        </p:spPr>
+      </p:pic>
     </p:spTree>
   </p:cSld>
   <p:clrMapOvr>
@@ -4842,7 +4843,7 @@
               </a:defRPr>
             </a:pPr>
             <a:r>
-              <a:t>RESULTADOS COMPARATIVOS</a:t>
+              <a:t>AFINAMIENTO DE RENDIMIENTO</a:t>
             </a:r>
           </a:p>
         </p:txBody>
@@ -4878,7 +4879,7 @@
               </a:defRPr>
             </a:pPr>
             <a:r>
-              <a:t>Impacto de la Optimización: De Sequential Scan a Index Scan</a:t>
+              <a:t>Análisis de Planes de Ejecución y Métricas de E/S</a:t>
             </a:r>
           </a:p>
         </p:txBody>
@@ -4892,7 +4893,7 @@
         <p:spPr>
           <a:xfrm>
             <a:off x="731520" y="1508760"/>
-            <a:ext cx="5029200" cy="4663440"/>
+            <a:ext cx="5212080" cy="4663440"/>
           </a:xfrm>
           <a:prstGeom prst="roundRect">
             <a:avLst/>
@@ -4938,7 +4939,7 @@
         <p:spPr>
           <a:xfrm>
             <a:off x="960120" y="1673352"/>
-            <a:ext cx="4572000" cy="411480"/>
+            <a:ext cx="4754880" cy="411480"/>
           </a:xfrm>
           <a:prstGeom prst="rect">
             <a:avLst/>
@@ -4960,7 +4961,7 @@
               </a:defRPr>
             </a:pPr>
             <a:r>
-              <a:t>Métricas de Desempeño</a:t>
+              <a:t>Fundamentos de EXPLAIN ANALYZE</a:t>
             </a:r>
           </a:p>
         </p:txBody>
@@ -4974,7 +4975,7 @@
         <p:spPr>
           <a:xfrm>
             <a:off x="960120" y="2057400"/>
-            <a:ext cx="4572000" cy="3931920"/>
+            <a:ext cx="4754880" cy="3931920"/>
           </a:xfrm>
           <a:prstGeom prst="rect">
             <a:avLst/>
@@ -5011,7 +5012,7 @@
                 </a:solidFill>
                 <a:latin typeface="Segoe UI"/>
               </a:rPr>
-              <a:t>Caso 1 (Búsqueda por DNI): </a:t>
+              <a:t>Tiempo de Ejecución: </a:t>
             </a:r>
             <a:r>
               <a:rPr b="0" sz="1200">
@@ -5020,7 +5021,7 @@
                 </a:solidFill>
                 <a:latin typeface="Segoe UI"/>
               </a:rPr>
-              <a:t>La latencia se redujo de 13.71 ms a 0.12 ms; las lecturas pasaron de 1,301 bloques a solo 4 bloques (mejora &gt;110x).</a:t>
+              <a:t>Medición cronométrica real del procesamiento interno en el motor de la base de datos.</a:t>
             </a:r>
           </a:p>
           <a:p>
@@ -5048,7 +5049,7 @@
                 </a:solidFill>
                 <a:latin typeface="Segoe UI"/>
               </a:rPr>
-              <a:t>Caso 2 (Cuentas y Fechas): </a:t>
+              <a:t>Buffers (Hit vs Read): </a:t>
             </a:r>
             <a:r>
               <a:rPr b="0" sz="1200">
@@ -5057,7 +5058,7 @@
                 </a:solidFill>
                 <a:latin typeface="Segoe UI"/>
               </a:rPr>
-              <a:t>El índice compuesto evitó el Quicksort sobre 400k filas; la latencia se redujo de 391.04 ms a 0.10 ms (mejora &gt;3,900x).</a:t>
+              <a:t>Hit indica lectura directa en memoria RAM; Read representa lectura física de disco (cuello de botella de E/S).</a:t>
             </a:r>
           </a:p>
           <a:p>
@@ -5085,7 +5086,7 @@
                 </a:solidFill>
                 <a:latin typeface="Segoe UI"/>
               </a:rPr>
-              <a:t>Caso 3 (Uso de LOWER): </a:t>
+              <a:t>Sequential Scan (Seq Scan): </a:t>
             </a:r>
             <a:r>
               <a:rPr b="0" sz="1200">
@@ -5094,7 +5095,7 @@
                 </a:solidFill>
                 <a:latin typeface="Segoe UI"/>
               </a:rPr>
-              <a:t>El índice funcional resolvió la invalidación del índice estándar, reduciendo el tiempo de 71.17 ms a 0.72 ms (mejora &gt;95x).</a:t>
+              <a:t>Recorrido exhaustivo de cada página de la tabla. Ineficiente para búsquedas selectivas sobre grandes volúmenes.</a:t>
             </a:r>
           </a:p>
           <a:p>
@@ -5122,7 +5123,7 @@
                 </a:solidFill>
                 <a:latin typeface="Segoe UI"/>
               </a:rPr>
-              <a:t>Eficiencia General: </a:t>
+              <a:t>Index Scan: </a:t>
             </a:r>
             <a:r>
               <a:rPr b="0" sz="1200">
@@ -5131,35 +5132,264 @@
                 </a:solidFill>
                 <a:latin typeface="Segoe UI"/>
               </a:rPr>
-              <a:t>Menor contención de memoria compartida y liberación inmediata de conexiones en el pool.</a:t>
-            </a:r>
-          </a:p>
-        </p:txBody>
-      </p:sp>
-      <p:pic>
-        <p:nvPicPr>
-          <p:cNvPr id="8" name="Picture 7" descr="grafico_optimizacion_benchmark.png"/>
-          <p:cNvPicPr>
-            <a:picLocks noChangeAspect="1"/>
-          </p:cNvPicPr>
-          <p:nvPr/>
-        </p:nvPicPr>
-        <p:blipFill>
-          <a:blip r:embed="rId2"/>
-          <a:stretch>
-            <a:fillRect/>
-          </a:stretch>
-        </p:blipFill>
-        <p:spPr>
-          <a:xfrm>
-            <a:off x="6035040" y="1645920"/>
-            <a:ext cx="5394960" cy="3371850"/>
+              <a:t>Acceso selectivo mediante estructuras balanceadas B-Tree con complejidad logarítmica O(log N).</a:t>
+            </a:r>
+          </a:p>
+        </p:txBody>
+      </p:sp>
+      <p:sp>
+        <p:nvSpPr>
+          <p:cNvPr id="8" name="Rounded Rectangle 7"/>
+          <p:cNvSpPr/>
+          <p:nvPr/>
+        </p:nvSpPr>
+        <p:spPr>
+          <a:xfrm>
+            <a:off x="6217920" y="1508760"/>
+            <a:ext cx="5212080" cy="4663440"/>
+          </a:xfrm>
+          <a:prstGeom prst="roundRect">
+            <a:avLst/>
+          </a:prstGeom>
+          <a:solidFill>
+            <a:srgbClr val="1E293B"/>
+          </a:solidFill>
+          <a:ln w="12700">
+            <a:solidFill>
+              <a:srgbClr val="334155"/>
+            </a:solidFill>
+          </a:ln>
+          <a:effectLst/>
+        </p:spPr>
+        <p:style>
+          <a:lnRef idx="1">
+            <a:schemeClr val="accent1"/>
+          </a:lnRef>
+          <a:fillRef idx="3">
+            <a:schemeClr val="accent1"/>
+          </a:fillRef>
+          <a:effectRef idx="2">
+            <a:schemeClr val="accent1"/>
+          </a:effectRef>
+          <a:fontRef idx="minor">
+            <a:schemeClr val="lt1"/>
+          </a:fontRef>
+        </p:style>
+        <p:txBody>
+          <a:bodyPr rtlCol="0" anchor="ctr"/>
+          <a:lstStyle/>
+          <a:p>
+            <a:pPr algn="ctr"/>
+          </a:p>
+        </p:txBody>
+      </p:sp>
+      <p:sp>
+        <p:nvSpPr>
+          <p:cNvPr id="9" name="TextBox 8"/>
+          <p:cNvSpPr txBox="1"/>
+          <p:nvPr/>
+        </p:nvSpPr>
+        <p:spPr>
+          <a:xfrm>
+            <a:off x="6446520" y="1673352"/>
+            <a:ext cx="4754880" cy="411480"/>
           </a:xfrm>
           <a:prstGeom prst="rect">
             <a:avLst/>
           </a:prstGeom>
-        </p:spPr>
-      </p:pic>
+          <a:noFill/>
+        </p:spPr>
+        <p:txBody>
+          <a:bodyPr wrap="square">
+            <a:spAutoFit/>
+          </a:bodyPr>
+          <a:lstStyle/>
+          <a:p>
+            <a:pPr>
+              <a:defRPr sz="1400" b="1">
+                <a:solidFill>
+                  <a:srgbClr val="60A5FA"/>
+                </a:solidFill>
+                <a:latin typeface="Segoe UI"/>
+              </a:defRPr>
+            </a:pPr>
+            <a:r>
+              <a:t>Técnicas de Indexación Aplicadas</a:t>
+            </a:r>
+          </a:p>
+        </p:txBody>
+      </p:sp>
+      <p:sp>
+        <p:nvSpPr>
+          <p:cNvPr id="10" name="TextBox 9"/>
+          <p:cNvSpPr txBox="1"/>
+          <p:nvPr/>
+        </p:nvSpPr>
+        <p:spPr>
+          <a:xfrm>
+            <a:off x="6446520" y="2057400"/>
+            <a:ext cx="4754880" cy="3931920"/>
+          </a:xfrm>
+          <a:prstGeom prst="rect">
+            <a:avLst/>
+          </a:prstGeom>
+          <a:noFill/>
+        </p:spPr>
+        <p:txBody>
+          <a:bodyPr wrap="square">
+            <a:spAutoFit/>
+          </a:bodyPr>
+          <a:lstStyle/>
+          <a:p>
+            <a:pPr>
+              <a:spcBef>
+                <a:spcPts val="200"/>
+              </a:spcBef>
+              <a:spcAft>
+                <a:spcPts val="700"/>
+              </a:spcAft>
+            </a:pPr>
+            <a:r>
+              <a:rPr b="0" sz="1200">
+                <a:solidFill>
+                  <a:srgbClr val="60A5FA"/>
+                </a:solidFill>
+                <a:latin typeface="Segoe UI"/>
+              </a:rPr>
+              <a:t>•  </a:t>
+            </a:r>
+            <a:r>
+              <a:rPr b="1" sz="1200">
+                <a:solidFill>
+                  <a:srgbClr val="E2E8F0"/>
+                </a:solidFill>
+                <a:latin typeface="Segoe UI"/>
+              </a:rPr>
+              <a:t>Índice B-Tree Único: </a:t>
+            </a:r>
+            <a:r>
+              <a:rPr b="0" sz="1200">
+                <a:solidFill>
+                  <a:srgbClr val="94A3B8"/>
+                </a:solidFill>
+                <a:latin typeface="Segoe UI"/>
+              </a:rPr>
+              <a:t>Búsqueda directa por documento de identidad; evita el escaneo de 100,000 filas.</a:t>
+            </a:r>
+          </a:p>
+          <a:p>
+            <a:pPr>
+              <a:spcBef>
+                <a:spcPts val="200"/>
+              </a:spcBef>
+              <a:spcAft>
+                <a:spcPts val="700"/>
+              </a:spcAft>
+            </a:pPr>
+            <a:r>
+              <a:rPr b="0" sz="1200">
+                <a:solidFill>
+                  <a:srgbClr val="60A5FA"/>
+                </a:solidFill>
+                <a:latin typeface="Segoe UI"/>
+              </a:rPr>
+              <a:t>•  </a:t>
+            </a:r>
+            <a:r>
+              <a:rPr b="1" sz="1200">
+                <a:solidFill>
+                  <a:srgbClr val="E2E8F0"/>
+                </a:solidFill>
+                <a:latin typeface="Segoe UI"/>
+              </a:rPr>
+              <a:t>Índice Compuesto Multicolumna: </a:t>
+            </a:r>
+            <a:r>
+              <a:rPr b="0" sz="1200">
+                <a:solidFill>
+                  <a:srgbClr val="94A3B8"/>
+                </a:solidFill>
+                <a:latin typeface="Segoe UI"/>
+              </a:rPr>
+              <a:t>Indexación simultánea de cuenta y fecha; elimina la necesidad de ordenamiento en memoria (Sort).</a:t>
+            </a:r>
+          </a:p>
+          <a:p>
+            <a:pPr>
+              <a:spcBef>
+                <a:spcPts val="200"/>
+              </a:spcBef>
+              <a:spcAft>
+                <a:spcPts val="700"/>
+              </a:spcAft>
+            </a:pPr>
+            <a:r>
+              <a:rPr b="0" sz="1200">
+                <a:solidFill>
+                  <a:srgbClr val="60A5FA"/>
+                </a:solidFill>
+                <a:latin typeface="Segoe UI"/>
+              </a:rPr>
+              <a:t>•  </a:t>
+            </a:r>
+            <a:r>
+              <a:rPr b="1" sz="1200">
+                <a:solidFill>
+                  <a:srgbClr val="E2E8F0"/>
+                </a:solidFill>
+                <a:latin typeface="Segoe UI"/>
+              </a:rPr>
+              <a:t>Índice Basado en Expresiones: </a:t>
+            </a:r>
+            <a:r>
+              <a:rPr b="0" sz="1200">
+                <a:solidFill>
+                  <a:srgbClr val="94A3B8"/>
+                </a:solidFill>
+                <a:latin typeface="Segoe UI"/>
+              </a:rPr>
+              <a:t>Creación sobre funciones de transformación (ej. LOWER); neutraliza anti-patrones en el WHERE.</a:t>
+            </a:r>
+          </a:p>
+          <a:p>
+            <a:pPr>
+              <a:spcBef>
+                <a:spcPts val="200"/>
+              </a:spcBef>
+              <a:spcAft>
+                <a:spcPts val="700"/>
+              </a:spcAft>
+            </a:pPr>
+            <a:r>
+              <a:rPr b="0" sz="1200">
+                <a:solidFill>
+                  <a:srgbClr val="60A5FA"/>
+                </a:solidFill>
+                <a:latin typeface="Segoe UI"/>
+              </a:rPr>
+              <a:t>•  </a:t>
+            </a:r>
+            <a:r>
+              <a:rPr b="1" sz="1200">
+                <a:solidFill>
+                  <a:srgbClr val="E2E8F0"/>
+                </a:solidFill>
+                <a:latin typeface="Segoe UI"/>
+              </a:rPr>
+              <a:t>Auditoría con pg_stat_statements: </a:t>
+            </a:r>
+            <a:r>
+              <a:rPr b="0" sz="1200">
+                <a:solidFill>
+                  <a:srgbClr val="94A3B8"/>
+                </a:solidFill>
+                <a:latin typeface="Segoe UI"/>
+              </a:rPr>
+              <a:t>Inspección acumulada para identificar las 10 consultas más lentas del sistema global.</a:t>
+            </a:r>
+          </a:p>
+        </p:txBody>
+      </p:sp>
     </p:spTree>
   </p:cSld>
   <p:clrMapOvr>
@@ -5252,7 +5482,7 @@
               </a:defRPr>
             </a:pPr>
             <a:r>
-              <a:t>METODOLOGÍA EXPERIMENTAL</a:t>
+              <a:t>RESULTADOS COMPARATIVOS</a:t>
             </a:r>
           </a:p>
         </p:txBody>
@@ -5288,7 +5518,7 @@
               </a:defRPr>
             </a:pPr>
             <a:r>
-              <a:t>Flujo Integrado de Demostración del Laboratorio</a:t>
+              <a:t>Impacto de la Optimización: De Sequential Scan a Index Scan</a:t>
             </a:r>
           </a:p>
         </p:txBody>
@@ -5302,7 +5532,7 @@
         <p:spPr>
           <a:xfrm>
             <a:off x="731520" y="1508760"/>
-            <a:ext cx="3291840" cy="4663440"/>
+            <a:ext cx="5029200" cy="4663440"/>
           </a:xfrm>
           <a:prstGeom prst="roundRect">
             <a:avLst/>
@@ -5348,7 +5578,7 @@
         <p:spPr>
           <a:xfrm>
             <a:off x="960120" y="1673352"/>
-            <a:ext cx="2834640" cy="411480"/>
+            <a:ext cx="4572000" cy="411480"/>
           </a:xfrm>
           <a:prstGeom prst="rect">
             <a:avLst/>
@@ -5370,7 +5600,7 @@
               </a:defRPr>
             </a:pPr>
             <a:r>
-              <a:t>Fase 1: Línea Base y Respaldo</a:t>
+              <a:t>Métricas de Desempeño</a:t>
             </a:r>
           </a:p>
         </p:txBody>
@@ -5383,8 +5613,8 @@
         </p:nvSpPr>
         <p:spPr>
           <a:xfrm>
-            <a:off x="914400" y="2103120"/>
-            <a:ext cx="2926080" cy="3840480"/>
+            <a:off x="960120" y="2057400"/>
+            <a:ext cx="4572000" cy="3931920"/>
           </a:xfrm>
           <a:prstGeom prst="rect">
             <a:avLst/>
@@ -5421,7 +5651,7 @@
                 </a:solidFill>
                 <a:latin typeface="Segoe UI"/>
               </a:rPr>
-              <a:t>Poblado Inicial: </a:t>
+              <a:t>Caso 1 (Búsqueda por DNI): </a:t>
             </a:r>
             <a:r>
               <a:rPr b="0" sz="1200">
@@ -5430,7 +5660,7 @@
                 </a:solidFill>
                 <a:latin typeface="Segoe UI"/>
               </a:rPr>
-              <a:t>Generación masiva de 600,000 registros sintéticos en PostgreSQL mediante funciones de memoria.</a:t>
+              <a:t>La latencia se redujo de 13.71 ms a 0.12 ms; las lecturas pasaron de 1,301 bloques a solo 4 bloques (mejora &gt;110x).</a:t>
             </a:r>
           </a:p>
           <a:p>
@@ -5458,7 +5688,7 @@
                 </a:solidFill>
                 <a:latin typeface="Segoe UI"/>
               </a:rPr>
-              <a:t>Respaldo Completo: </a:t>
+              <a:t>Caso 2 (Cuentas y Fechas): </a:t>
             </a:r>
             <a:r>
               <a:rPr b="0" sz="1200">
@@ -5467,7 +5697,7 @@
                 </a:solidFill>
                 <a:latin typeface="Segoe UI"/>
               </a:rPr>
-              <a:t>Ejecución de snapshot inicial en formato comprimido dentro del almacenamiento aislado.</a:t>
+              <a:t>El índice compuesto evitó el Quicksort sobre 400k filas; la latencia se redujo de 391.04 ms a 0.10 ms (mejora &gt;3,900x).</a:t>
             </a:r>
           </a:p>
           <a:p>
@@ -5495,7 +5725,7 @@
                 </a:solidFill>
                 <a:latin typeface="Segoe UI"/>
               </a:rPr>
-              <a:t>Recuperación PITR: </a:t>
+              <a:t>Caso 3 (Uso de LOWER): </a:t>
             </a:r>
             <a:r>
               <a:rPr b="0" sz="1200">
@@ -5504,20 +5734,214 @@
                 </a:solidFill>
                 <a:latin typeface="Segoe UI"/>
               </a:rPr>
-              <a:t>Simulación de incidente destructivo y validación de consistencia transaccional tras restaurar.</a:t>
-            </a:r>
-          </a:p>
-        </p:txBody>
-      </p:sp>
-      <p:sp>
-        <p:nvSpPr>
-          <p:cNvPr id="8" name="Rounded Rectangle 7"/>
+              <a:t>El índice funcional resolvió la invalidación del índice estándar, reduciendo el tiempo de 71.17 ms a 0.72 ms (mejora &gt;95x).</a:t>
+            </a:r>
+          </a:p>
+          <a:p>
+            <a:pPr>
+              <a:spcBef>
+                <a:spcPts val="200"/>
+              </a:spcBef>
+              <a:spcAft>
+                <a:spcPts val="700"/>
+              </a:spcAft>
+            </a:pPr>
+            <a:r>
+              <a:rPr b="0" sz="1200">
+                <a:solidFill>
+                  <a:srgbClr val="60A5FA"/>
+                </a:solidFill>
+                <a:latin typeface="Segoe UI"/>
+              </a:rPr>
+              <a:t>•  </a:t>
+            </a:r>
+            <a:r>
+              <a:rPr b="1" sz="1200">
+                <a:solidFill>
+                  <a:srgbClr val="E2E8F0"/>
+                </a:solidFill>
+                <a:latin typeface="Segoe UI"/>
+              </a:rPr>
+              <a:t>Eficiencia General: </a:t>
+            </a:r>
+            <a:r>
+              <a:rPr b="0" sz="1200">
+                <a:solidFill>
+                  <a:srgbClr val="94A3B8"/>
+                </a:solidFill>
+                <a:latin typeface="Segoe UI"/>
+              </a:rPr>
+              <a:t>Menor contención de memoria compartida y liberación inmediata de conexiones en el pool.</a:t>
+            </a:r>
+          </a:p>
+        </p:txBody>
+      </p:sp>
+      <p:pic>
+        <p:nvPicPr>
+          <p:cNvPr id="8" name="Picture 7" descr="grafico_optimizacion_benchmark.png"/>
+          <p:cNvPicPr>
+            <a:picLocks noChangeAspect="1"/>
+          </p:cNvPicPr>
+          <p:nvPr/>
+        </p:nvPicPr>
+        <p:blipFill>
+          <a:blip r:embed="rId2"/>
+          <a:stretch>
+            <a:fillRect/>
+          </a:stretch>
+        </p:blipFill>
+        <p:spPr>
+          <a:xfrm>
+            <a:off x="6035040" y="1645920"/>
+            <a:ext cx="5394960" cy="3371850"/>
+          </a:xfrm>
+          <a:prstGeom prst="rect">
+            <a:avLst/>
+          </a:prstGeom>
+        </p:spPr>
+      </p:pic>
+    </p:spTree>
+  </p:cSld>
+  <p:clrMapOvr>
+    <a:masterClrMapping/>
+  </p:clrMapOvr>
+</p:sld>
+</file>
+
+<file path=ppt/slides/slide14.xml><?xml version="1.0" encoding="utf-8"?>
+<p:sld xmlns:a="http://schemas.openxmlformats.org/drawingml/2006/main" xmlns:p="http://schemas.openxmlformats.org/presentationml/2006/main" xmlns:r="http://schemas.openxmlformats.org/officeDocument/2006/relationships">
+  <p:cSld>
+    <p:spTree>
+      <p:nvGrpSpPr>
+        <p:cNvPr id="1" name=""/>
+        <p:cNvGrpSpPr/>
+        <p:nvPr/>
+      </p:nvGrpSpPr>
+      <p:grpSpPr/>
+      <p:sp>
+        <p:nvSpPr>
+          <p:cNvPr id="2" name="Rectangle 1"/>
           <p:cNvSpPr/>
           <p:nvPr/>
         </p:nvSpPr>
         <p:spPr>
           <a:xfrm>
-            <a:off x="4389120" y="1508760"/>
+            <a:off x="0" y="0"/>
+            <a:ext cx="12191695" cy="6858000"/>
+          </a:xfrm>
+          <a:prstGeom prst="rect">
+            <a:avLst/>
+          </a:prstGeom>
+          <a:solidFill>
+            <a:srgbClr val="0F172A"/>
+          </a:solidFill>
+          <a:ln>
+            <a:noFill/>
+          </a:ln>
+        </p:spPr>
+        <p:style>
+          <a:lnRef idx="1">
+            <a:schemeClr val="accent1"/>
+          </a:lnRef>
+          <a:fillRef idx="3">
+            <a:schemeClr val="accent1"/>
+          </a:fillRef>
+          <a:effectRef idx="2">
+            <a:schemeClr val="accent1"/>
+          </a:effectRef>
+          <a:fontRef idx="minor">
+            <a:schemeClr val="lt1"/>
+          </a:fontRef>
+        </p:style>
+        <p:txBody>
+          <a:bodyPr rtlCol="0" anchor="ctr"/>
+          <a:lstStyle/>
+          <a:p>
+            <a:pPr algn="ctr"/>
+          </a:p>
+        </p:txBody>
+      </p:sp>
+      <p:sp>
+        <p:nvSpPr>
+          <p:cNvPr id="3" name="TextBox 2"/>
+          <p:cNvSpPr txBox="1"/>
+          <p:nvPr/>
+        </p:nvSpPr>
+        <p:spPr>
+          <a:xfrm>
+            <a:off x="731520" y="384048"/>
+            <a:ext cx="10698480" cy="274320"/>
+          </a:xfrm>
+          <a:prstGeom prst="rect">
+            <a:avLst/>
+          </a:prstGeom>
+          <a:noFill/>
+        </p:spPr>
+        <p:txBody>
+          <a:bodyPr wrap="square">
+            <a:spAutoFit/>
+          </a:bodyPr>
+          <a:lstStyle/>
+          <a:p>
+            <a:pPr>
+              <a:defRPr sz="1000" b="1">
+                <a:solidFill>
+                  <a:srgbClr val="60A5FA"/>
+                </a:solidFill>
+                <a:latin typeface="Segoe UI"/>
+              </a:defRPr>
+            </a:pPr>
+            <a:r>
+              <a:t>METODOLOGÍA EXPERIMENTAL</a:t>
+            </a:r>
+          </a:p>
+        </p:txBody>
+      </p:sp>
+      <p:sp>
+        <p:nvSpPr>
+          <p:cNvPr id="4" name="TextBox 3"/>
+          <p:cNvSpPr txBox="1"/>
+          <p:nvPr/>
+        </p:nvSpPr>
+        <p:spPr>
+          <a:xfrm>
+            <a:off x="731520" y="658368"/>
+            <a:ext cx="10698480" cy="640080"/>
+          </a:xfrm>
+          <a:prstGeom prst="rect">
+            <a:avLst/>
+          </a:prstGeom>
+          <a:noFill/>
+        </p:spPr>
+        <p:txBody>
+          <a:bodyPr wrap="square">
+            <a:spAutoFit/>
+          </a:bodyPr>
+          <a:lstStyle/>
+          <a:p>
+            <a:pPr>
+              <a:defRPr sz="2200" b="1">
+                <a:solidFill>
+                  <a:srgbClr val="F8FAFC"/>
+                </a:solidFill>
+                <a:latin typeface="Segoe UI"/>
+              </a:defRPr>
+            </a:pPr>
+            <a:r>
+              <a:t>Flujo Integrado de Demostración del Laboratorio</a:t>
+            </a:r>
+          </a:p>
+        </p:txBody>
+      </p:sp>
+      <p:sp>
+        <p:nvSpPr>
+          <p:cNvPr id="5" name="Rounded Rectangle 4"/>
+          <p:cNvSpPr/>
+          <p:nvPr/>
+        </p:nvSpPr>
+        <p:spPr>
+          <a:xfrm>
+            <a:off x="731520" y="1508760"/>
             <a:ext cx="3291840" cy="4663440"/>
           </a:xfrm>
           <a:prstGeom prst="roundRect">
@@ -5557,13 +5981,13 @@
       </p:sp>
       <p:sp>
         <p:nvSpPr>
-          <p:cNvPr id="9" name="TextBox 8"/>
+          <p:cNvPr id="6" name="TextBox 5"/>
           <p:cNvSpPr txBox="1"/>
           <p:nvPr/>
         </p:nvSpPr>
         <p:spPr>
           <a:xfrm>
-            <a:off x="4617720" y="1673352"/>
+            <a:off x="960120" y="1673352"/>
             <a:ext cx="2834640" cy="411480"/>
           </a:xfrm>
           <a:prstGeom prst="rect">
@@ -5586,20 +6010,20 @@
               </a:defRPr>
             </a:pPr>
             <a:r>
-              <a:t>Fase 2: Telemetría y Carga</a:t>
-            </a:r>
-          </a:p>
-        </p:txBody>
-      </p:sp>
-      <p:sp>
-        <p:nvSpPr>
-          <p:cNvPr id="10" name="TextBox 9"/>
+              <a:t>Fase 1: Línea Base y Respaldo</a:t>
+            </a:r>
+          </a:p>
+        </p:txBody>
+      </p:sp>
+      <p:sp>
+        <p:nvSpPr>
+          <p:cNvPr id="7" name="TextBox 6"/>
           <p:cNvSpPr txBox="1"/>
           <p:nvPr/>
         </p:nvSpPr>
         <p:spPr>
           <a:xfrm>
-            <a:off x="4572000" y="2103120"/>
+            <a:off x="914400" y="2103120"/>
             <a:ext cx="2926080" cy="3840480"/>
           </a:xfrm>
           <a:prstGeom prst="rect">
@@ -5637,7 +6061,7 @@
                 </a:solidFill>
                 <a:latin typeface="Segoe UI"/>
               </a:rPr>
-              <a:t>Inyección Concurrente: </a:t>
+              <a:t>Poblado Inicial: </a:t>
             </a:r>
             <a:r>
               <a:rPr b="0" sz="1200">
@@ -5646,7 +6070,7 @@
                 </a:solidFill>
                 <a:latin typeface="Segoe UI"/>
               </a:rPr>
-              <a:t>Simulación de tráfico transaccional continuo (lecturas, transferencias y rollbacks).</a:t>
+              <a:t>Generación masiva de 600,000 registros sintéticos en PostgreSQL mediante funciones de memoria.</a:t>
             </a:r>
           </a:p>
           <a:p>
@@ -5674,7 +6098,7 @@
                 </a:solidFill>
                 <a:latin typeface="Segoe UI"/>
               </a:rPr>
-              <a:t>Transmisión en Streaming: </a:t>
+              <a:t>Respaldo Completo: </a:t>
             </a:r>
             <a:r>
               <a:rPr b="0" sz="1200">
@@ -5683,7 +6107,7 @@
                 </a:solidFill>
                 <a:latin typeface="Segoe UI"/>
               </a:rPr>
-              <a:t>Captura en tiempo real de eventos con Promtail hacia el repositorio de Loki.</a:t>
+              <a:t>Ejecución de snapshot inicial en formato comprimido dentro del almacenamiento aislado.</a:t>
             </a:r>
           </a:p>
           <a:p>
@@ -5711,7 +6135,7 @@
                 </a:solidFill>
                 <a:latin typeface="Segoe UI"/>
               </a:rPr>
-              <a:t>Monitoreo en Vivo: </a:t>
+              <a:t>Recuperación PITR: </a:t>
             </a:r>
             <a:r>
               <a:rPr b="0" sz="1200">
@@ -5720,21 +6144,21 @@
                 </a:solidFill>
                 <a:latin typeface="Segoe UI"/>
               </a:rPr>
-              <a:t>Inspección de curvas de QPS, patrones de escritura y registro de errores en Grafana.</a:t>
-            </a:r>
-          </a:p>
-        </p:txBody>
-      </p:sp>
-      <p:sp>
-        <p:nvSpPr>
-          <p:cNvPr id="11" name="Rounded Rectangle 10"/>
+              <a:t>Simulación de incidente destructivo y validación de consistencia transaccional tras restaurar.</a:t>
+            </a:r>
+          </a:p>
+        </p:txBody>
+      </p:sp>
+      <p:sp>
+        <p:nvSpPr>
+          <p:cNvPr id="8" name="Rounded Rectangle 7"/>
           <p:cNvSpPr/>
           <p:nvPr/>
         </p:nvSpPr>
         <p:spPr>
           <a:xfrm>
-            <a:off x="8046720" y="1508760"/>
-            <a:ext cx="3383280" cy="4663440"/>
+            <a:off x="4389120" y="1508760"/>
+            <a:ext cx="3291840" cy="4663440"/>
           </a:xfrm>
           <a:prstGeom prst="roundRect">
             <a:avLst/>
@@ -5773,6 +6197,222 @@
       </p:sp>
       <p:sp>
         <p:nvSpPr>
+          <p:cNvPr id="9" name="TextBox 8"/>
+          <p:cNvSpPr txBox="1"/>
+          <p:nvPr/>
+        </p:nvSpPr>
+        <p:spPr>
+          <a:xfrm>
+            <a:off x="4617720" y="1673352"/>
+            <a:ext cx="2834640" cy="411480"/>
+          </a:xfrm>
+          <a:prstGeom prst="rect">
+            <a:avLst/>
+          </a:prstGeom>
+          <a:noFill/>
+        </p:spPr>
+        <p:txBody>
+          <a:bodyPr wrap="square">
+            <a:spAutoFit/>
+          </a:bodyPr>
+          <a:lstStyle/>
+          <a:p>
+            <a:pPr>
+              <a:defRPr sz="1400" b="1">
+                <a:solidFill>
+                  <a:srgbClr val="60A5FA"/>
+                </a:solidFill>
+                <a:latin typeface="Segoe UI"/>
+              </a:defRPr>
+            </a:pPr>
+            <a:r>
+              <a:t>Fase 2: Telemetría y Carga</a:t>
+            </a:r>
+          </a:p>
+        </p:txBody>
+      </p:sp>
+      <p:sp>
+        <p:nvSpPr>
+          <p:cNvPr id="10" name="TextBox 9"/>
+          <p:cNvSpPr txBox="1"/>
+          <p:nvPr/>
+        </p:nvSpPr>
+        <p:spPr>
+          <a:xfrm>
+            <a:off x="4572000" y="2103120"/>
+            <a:ext cx="2926080" cy="3840480"/>
+          </a:xfrm>
+          <a:prstGeom prst="rect">
+            <a:avLst/>
+          </a:prstGeom>
+          <a:noFill/>
+        </p:spPr>
+        <p:txBody>
+          <a:bodyPr wrap="square">
+            <a:spAutoFit/>
+          </a:bodyPr>
+          <a:lstStyle/>
+          <a:p>
+            <a:pPr>
+              <a:spcBef>
+                <a:spcPts val="200"/>
+              </a:spcBef>
+              <a:spcAft>
+                <a:spcPts val="700"/>
+              </a:spcAft>
+            </a:pPr>
+            <a:r>
+              <a:rPr b="0" sz="1200">
+                <a:solidFill>
+                  <a:srgbClr val="60A5FA"/>
+                </a:solidFill>
+                <a:latin typeface="Segoe UI"/>
+              </a:rPr>
+              <a:t>•  </a:t>
+            </a:r>
+            <a:r>
+              <a:rPr b="1" sz="1200">
+                <a:solidFill>
+                  <a:srgbClr val="E2E8F0"/>
+                </a:solidFill>
+                <a:latin typeface="Segoe UI"/>
+              </a:rPr>
+              <a:t>Inyección Concurrente: </a:t>
+            </a:r>
+            <a:r>
+              <a:rPr b="0" sz="1200">
+                <a:solidFill>
+                  <a:srgbClr val="94A3B8"/>
+                </a:solidFill>
+                <a:latin typeface="Segoe UI"/>
+              </a:rPr>
+              <a:t>Simulación de tráfico transaccional continuo (lecturas, transferencias y rollbacks).</a:t>
+            </a:r>
+          </a:p>
+          <a:p>
+            <a:pPr>
+              <a:spcBef>
+                <a:spcPts val="200"/>
+              </a:spcBef>
+              <a:spcAft>
+                <a:spcPts val="700"/>
+              </a:spcAft>
+            </a:pPr>
+            <a:r>
+              <a:rPr b="0" sz="1200">
+                <a:solidFill>
+                  <a:srgbClr val="60A5FA"/>
+                </a:solidFill>
+                <a:latin typeface="Segoe UI"/>
+              </a:rPr>
+              <a:t>•  </a:t>
+            </a:r>
+            <a:r>
+              <a:rPr b="1" sz="1200">
+                <a:solidFill>
+                  <a:srgbClr val="E2E8F0"/>
+                </a:solidFill>
+                <a:latin typeface="Segoe UI"/>
+              </a:rPr>
+              <a:t>Transmisión en Streaming: </a:t>
+            </a:r>
+            <a:r>
+              <a:rPr b="0" sz="1200">
+                <a:solidFill>
+                  <a:srgbClr val="94A3B8"/>
+                </a:solidFill>
+                <a:latin typeface="Segoe UI"/>
+              </a:rPr>
+              <a:t>Captura en tiempo real de eventos con Promtail hacia el repositorio de Loki.</a:t>
+            </a:r>
+          </a:p>
+          <a:p>
+            <a:pPr>
+              <a:spcBef>
+                <a:spcPts val="200"/>
+              </a:spcBef>
+              <a:spcAft>
+                <a:spcPts val="700"/>
+              </a:spcAft>
+            </a:pPr>
+            <a:r>
+              <a:rPr b="0" sz="1200">
+                <a:solidFill>
+                  <a:srgbClr val="60A5FA"/>
+                </a:solidFill>
+                <a:latin typeface="Segoe UI"/>
+              </a:rPr>
+              <a:t>•  </a:t>
+            </a:r>
+            <a:r>
+              <a:rPr b="1" sz="1200">
+                <a:solidFill>
+                  <a:srgbClr val="E2E8F0"/>
+                </a:solidFill>
+                <a:latin typeface="Segoe UI"/>
+              </a:rPr>
+              <a:t>Monitoreo en Vivo: </a:t>
+            </a:r>
+            <a:r>
+              <a:rPr b="0" sz="1200">
+                <a:solidFill>
+                  <a:srgbClr val="94A3B8"/>
+                </a:solidFill>
+                <a:latin typeface="Segoe UI"/>
+              </a:rPr>
+              <a:t>Inspección de curvas de QPS, patrones de escritura y registro de errores en Grafana.</a:t>
+            </a:r>
+          </a:p>
+        </p:txBody>
+      </p:sp>
+      <p:sp>
+        <p:nvSpPr>
+          <p:cNvPr id="11" name="Rounded Rectangle 10"/>
+          <p:cNvSpPr/>
+          <p:nvPr/>
+        </p:nvSpPr>
+        <p:spPr>
+          <a:xfrm>
+            <a:off x="8046720" y="1508760"/>
+            <a:ext cx="3383280" cy="4663440"/>
+          </a:xfrm>
+          <a:prstGeom prst="roundRect">
+            <a:avLst/>
+          </a:prstGeom>
+          <a:solidFill>
+            <a:srgbClr val="1E293B"/>
+          </a:solidFill>
+          <a:ln w="12700">
+            <a:solidFill>
+              <a:srgbClr val="334155"/>
+            </a:solidFill>
+          </a:ln>
+          <a:effectLst/>
+        </p:spPr>
+        <p:style>
+          <a:lnRef idx="1">
+            <a:schemeClr val="accent1"/>
+          </a:lnRef>
+          <a:fillRef idx="3">
+            <a:schemeClr val="accent1"/>
+          </a:fillRef>
+          <a:effectRef idx="2">
+            <a:schemeClr val="accent1"/>
+          </a:effectRef>
+          <a:fontRef idx="minor">
+            <a:schemeClr val="lt1"/>
+          </a:fontRef>
+        </p:style>
+        <p:txBody>
+          <a:bodyPr rtlCol="0" anchor="ctr"/>
+          <a:lstStyle/>
+          <a:p>
+            <a:pPr algn="ctr"/>
+          </a:p>
+        </p:txBody>
+      </p:sp>
+      <p:sp>
+        <p:nvSpPr>
           <p:cNvPr id="12" name="TextBox 11"/>
           <p:cNvSpPr txBox="1"/>
           <p:nvPr/>
@@ -5949,7 +6589,7 @@
 </p:sld>
 </file>
 
-<file path=ppt/slides/slide14.xml><?xml version="1.0" encoding="utf-8"?>
+<file path=ppt/slides/slide15.xml><?xml version="1.0" encoding="utf-8"?>
 <p:sld xmlns:a="http://schemas.openxmlformats.org/drawingml/2006/main" xmlns:p="http://schemas.openxmlformats.org/presentationml/2006/main" xmlns:r="http://schemas.openxmlformats.org/officeDocument/2006/relationships">
   <p:cSld>
     <p:spTree>
@@ -10990,7 +11630,7 @@
               </a:defRPr>
             </a:pPr>
             <a:r>
-              <a:t>OBSERVABILIDAD</a:t>
+              <a:t>SOLUCIONES DE GRAN ESCALA</a:t>
             </a:r>
           </a:p>
         </p:txBody>
@@ -11026,7 +11666,7 @@
               </a:defRPr>
             </a:pPr>
             <a:r>
-              <a:t>Telemetría de Consultas y Almacenamiento Centralizado</a:t>
+              <a:t>Ecosistema Corporativo: Respaldos Físicos y Continuos</a:t>
             </a:r>
           </a:p>
         </p:txBody>
@@ -11108,7 +11748,7 @@
               </a:defRPr>
             </a:pPr>
             <a:r>
-              <a:t>Dimensiones de la Telemetría</a:t>
+              <a:t>Respaldos Físicos: pg_basebackup</a:t>
             </a:r>
           </a:p>
         </p:txBody>
@@ -11159,7 +11799,7 @@
                 </a:solidFill>
                 <a:latin typeface="Segoe UI"/>
               </a:rPr>
-              <a:t>Más allá del Hardware: </a:t>
+              <a:t>Copia Binaria Bit a Bit: </a:t>
             </a:r>
             <a:r>
               <a:rPr b="0" sz="1200">
@@ -11168,7 +11808,7 @@
                 </a:solidFill>
                 <a:latin typeface="Segoe UI"/>
               </a:rPr>
-              <a:t>No se limita al uso de CPU o memoria; audita cada sentencia ejecutada por clientes y aplicaciones.</a:t>
+              <a:t>A diferencia de pg_dump que genera sentencias SQL, pg_basebackup copia los bloques reales de datos ($PGDATA) a nivel de páginas de 8KB.</a:t>
             </a:r>
           </a:p>
           <a:p>
@@ -11196,7 +11836,7 @@
                 </a:solidFill>
                 <a:latin typeface="Segoe UI"/>
               </a:rPr>
-              <a:t>Throughput (QPS): </a:t>
+              <a:t>Streaming de WALs (-Xs): </a:t>
             </a:r>
             <a:r>
               <a:rPr b="0" sz="1200">
@@ -11205,7 +11845,7 @@
                 </a:solidFill>
                 <a:latin typeface="Segoe UI"/>
               </a:rPr>
-              <a:t>Mide el volumen de operaciones por segundo y detecta picos de demanda inusuales.</a:t>
+              <a:t>Abre una conexión simultánea que captura en streaming los WALs generados durante la copia para asegurar consistencia.</a:t>
             </a:r>
           </a:p>
           <a:p>
@@ -11233,7 +11873,7 @@
                 </a:solidFill>
                 <a:latin typeface="Segoe UI"/>
               </a:rPr>
-              <a:t>Composición DML: </a:t>
+              <a:t>Configuración de Réplicas (-R): </a:t>
             </a:r>
             <a:r>
               <a:rPr b="0" sz="1200">
@@ -11242,7 +11882,7 @@
                 </a:solidFill>
                 <a:latin typeface="Segoe UI"/>
               </a:rPr>
-              <a:t>Distribución entre consultas de lectura (SELECT) y operaciones de escritura (INSERT, UPDATE).</a:t>
+              <a:t>Genera automáticamente el fichero standby.signal y los parámetros de conexión primaria para levantar réplicas en caliente.</a:t>
             </a:r>
           </a:p>
           <a:p>
@@ -11270,7 +11910,7 @@
                 </a:solidFill>
                 <a:latin typeface="Segoe UI"/>
               </a:rPr>
-              <a:t>Alertas Tempranas: </a:t>
+              <a:t>Velocidad de Restauración: </a:t>
             </a:r>
             <a:r>
               <a:rPr b="0" sz="1200">
@@ -11279,7 +11919,7 @@
                 </a:solidFill>
                 <a:latin typeface="Segoe UI"/>
               </a:rPr>
-              <a:t>Identificación inmediata de bloqueos (locks), transacciones canceladas y rollbacks.</a:t>
+              <a:t>Inmediata; el motor arranca directamente sobre los bloques sin tener que reconstruir esquemas ni reindexar.</a:t>
             </a:r>
           </a:p>
         </p:txBody>
@@ -11361,7 +12001,7 @@
               </a:defRPr>
             </a:pPr>
             <a:r>
-              <a:t>Eficiencia de Grafana Loki</a:t>
+              <a:t>Herramientas de Nivel Bancario y Cloud</a:t>
             </a:r>
           </a:p>
         </p:txBody>
@@ -11412,7 +12052,7 @@
                 </a:solidFill>
                 <a:latin typeface="Segoe UI"/>
               </a:rPr>
-              <a:t>Indexación por Metadatos: </a:t>
+              <a:t>pgBackRest (Estándar de la Industria): </a:t>
             </a:r>
             <a:r>
               <a:rPr b="0" sz="1200">
@@ -11421,7 +12061,7 @@
                 </a:solidFill>
                 <a:latin typeface="Segoe UI"/>
               </a:rPr>
-              <a:t>A diferencia de motores convencionales, Loki solo indexa etiquetas; reduce el consumo de RAM hasta un 90%.</a:t>
+              <a:t>El software más robusto para backups incrementales y diferenciales a nivel de bloque (delta de páginas de 8KB), compresión multihilo LZ4/Zstandard y deduplicación.</a:t>
             </a:r>
           </a:p>
           <a:p>
@@ -11449,7 +12089,7 @@
                 </a:solidFill>
                 <a:latin typeface="Segoe UI"/>
               </a:rPr>
-              <a:t>Consumo No Invasivo: </a:t>
+              <a:t>Barman (Backup &amp; Recovery Manager): </a:t>
             </a:r>
             <a:r>
               <a:rPr b="0" sz="1200">
@@ -11458,7 +12098,7 @@
                 </a:solidFill>
                 <a:latin typeface="Segoe UI"/>
               </a:rPr>
-              <a:t>Promtail recopila logs en streaming sin abrir bloqueos de tabla ni interferir en sesiones activas.</a:t>
+              <a:t>Desarrollado por EnterpriseDB para la administración remota de catálogos y clusters masivos de bases de datos.</a:t>
             </a:r>
           </a:p>
           <a:p>
@@ -11486,7 +12126,7 @@
                 </a:solidFill>
                 <a:latin typeface="Segoe UI"/>
               </a:rPr>
-              <a:t>Visibilidad Central: </a:t>
+              <a:t>WAL-G (Cloud-Native): </a:t>
             </a:r>
             <a:r>
               <a:rPr b="0" sz="1200">
@@ -11495,7 +12135,7 @@
                 </a:solidFill>
                 <a:latin typeface="Segoe UI"/>
               </a:rPr>
-              <a:t>Dashboards dinámicos permiten correlacionar latencias de consultas con eventos del motor.</a:t>
+              <a:t>Diseñado para Kubernetes y contenedores; envía respaldos físicos y WALs comprimidos directamente hacia buckets en AWS S3, Google Cloud Storage o Azure Blob.</a:t>
             </a:r>
           </a:p>
           <a:p>
@@ -11523,7 +12163,7 @@
                 </a:solidFill>
                 <a:latin typeface="Segoe UI"/>
               </a:rPr>
-              <a:t>Retención Independiente: </a:t>
+              <a:t>Snapshots de Almacenamiento (SAN/EBS): </a:t>
             </a:r>
             <a:r>
               <a:rPr b="0" sz="1200">
@@ -11532,7 +12172,7 @@
                 </a:solidFill>
                 <a:latin typeface="Segoe UI"/>
               </a:rPr>
-              <a:t>Políticas de archivado de logs sin comprometer el ciclo de vida de los datos transaccionales.</a:t>
+              <a:t>pg_backup_start() y pg_backup_stop() permiten congelar la consistencia y tomar snapshots de disco virtual en segundos.</a:t>
             </a:r>
           </a:p>
         </p:txBody>

</xml_diff>